<commit_message>
figure fpr test installation changed
</commit_message>
<xml_diff>
--- a/source/_static/test-uftp-setup.pptx
+++ b/source/_static/test-uftp-setup.pptx
@@ -243,7 +243,7 @@
           <a:p>
             <a:fld id="{F89FD5E3-9FE6-47D6-82DD-5BFE33800862}" type="datetimeFigureOut">
               <a:rPr lang="en-GB" smtClean="0"/>
-              <a:t>02/09/2026</a:t>
+              <a:t>08/10/2026</a:t>
             </a:fld>
             <a:endParaRPr lang="en-GB"/>
           </a:p>
@@ -413,7 +413,7 @@
           <a:p>
             <a:fld id="{F89FD5E3-9FE6-47D6-82DD-5BFE33800862}" type="datetimeFigureOut">
               <a:rPr lang="en-GB" smtClean="0"/>
-              <a:t>02/09/2026</a:t>
+              <a:t>08/10/2026</a:t>
             </a:fld>
             <a:endParaRPr lang="en-GB"/>
           </a:p>
@@ -593,7 +593,7 @@
           <a:p>
             <a:fld id="{F89FD5E3-9FE6-47D6-82DD-5BFE33800862}" type="datetimeFigureOut">
               <a:rPr lang="en-GB" smtClean="0"/>
-              <a:t>02/09/2026</a:t>
+              <a:t>08/10/2026</a:t>
             </a:fld>
             <a:endParaRPr lang="en-GB"/>
           </a:p>
@@ -763,7 +763,7 @@
           <a:p>
             <a:fld id="{F89FD5E3-9FE6-47D6-82DD-5BFE33800862}" type="datetimeFigureOut">
               <a:rPr lang="en-GB" smtClean="0"/>
-              <a:t>02/09/2026</a:t>
+              <a:t>08/10/2026</a:t>
             </a:fld>
             <a:endParaRPr lang="en-GB"/>
           </a:p>
@@ -1007,7 +1007,7 @@
           <a:p>
             <a:fld id="{F89FD5E3-9FE6-47D6-82DD-5BFE33800862}" type="datetimeFigureOut">
               <a:rPr lang="en-GB" smtClean="0"/>
-              <a:t>02/09/2026</a:t>
+              <a:t>08/10/2026</a:t>
             </a:fld>
             <a:endParaRPr lang="en-GB"/>
           </a:p>
@@ -1239,7 +1239,7 @@
           <a:p>
             <a:fld id="{F89FD5E3-9FE6-47D6-82DD-5BFE33800862}" type="datetimeFigureOut">
               <a:rPr lang="en-GB" smtClean="0"/>
-              <a:t>02/09/2026</a:t>
+              <a:t>08/10/2026</a:t>
             </a:fld>
             <a:endParaRPr lang="en-GB"/>
           </a:p>
@@ -1606,7 +1606,7 @@
           <a:p>
             <a:fld id="{F89FD5E3-9FE6-47D6-82DD-5BFE33800862}" type="datetimeFigureOut">
               <a:rPr lang="en-GB" smtClean="0"/>
-              <a:t>02/09/2026</a:t>
+              <a:t>08/10/2026</a:t>
             </a:fld>
             <a:endParaRPr lang="en-GB"/>
           </a:p>
@@ -1724,7 +1724,7 @@
           <a:p>
             <a:fld id="{F89FD5E3-9FE6-47D6-82DD-5BFE33800862}" type="datetimeFigureOut">
               <a:rPr lang="en-GB" smtClean="0"/>
-              <a:t>02/09/2026</a:t>
+              <a:t>08/10/2026</a:t>
             </a:fld>
             <a:endParaRPr lang="en-GB"/>
           </a:p>
@@ -1819,7 +1819,7 @@
           <a:p>
             <a:fld id="{F89FD5E3-9FE6-47D6-82DD-5BFE33800862}" type="datetimeFigureOut">
               <a:rPr lang="en-GB" smtClean="0"/>
-              <a:t>02/09/2026</a:t>
+              <a:t>08/10/2026</a:t>
             </a:fld>
             <a:endParaRPr lang="en-GB"/>
           </a:p>
@@ -2096,7 +2096,7 @@
           <a:p>
             <a:fld id="{F89FD5E3-9FE6-47D6-82DD-5BFE33800862}" type="datetimeFigureOut">
               <a:rPr lang="en-GB" smtClean="0"/>
-              <a:t>02/09/2026</a:t>
+              <a:t>08/10/2026</a:t>
             </a:fld>
             <a:endParaRPr lang="en-GB"/>
           </a:p>
@@ -2353,7 +2353,7 @@
           <a:p>
             <a:fld id="{F89FD5E3-9FE6-47D6-82DD-5BFE33800862}" type="datetimeFigureOut">
               <a:rPr lang="en-GB" smtClean="0"/>
-              <a:t>02/09/2026</a:t>
+              <a:t>08/10/2026</a:t>
             </a:fld>
             <a:endParaRPr lang="en-GB"/>
           </a:p>
@@ -2566,7 +2566,7 @@
           <a:p>
             <a:fld id="{F89FD5E3-9FE6-47D6-82DD-5BFE33800862}" type="datetimeFigureOut">
               <a:rPr lang="en-GB" smtClean="0"/>
-              <a:t>02/09/2026</a:t>
+              <a:t>08/10/2026</a:t>
             </a:fld>
             <a:endParaRPr lang="en-GB"/>
           </a:p>
@@ -2971,6 +2971,49 @@
           <a:chExt cx="0" cy="0"/>
         </a:xfrm>
       </p:grpSpPr>
+      <p:cxnSp>
+        <p:nvCxnSpPr>
+          <p:cNvPr id="25" name="Gerade Verbindung mit Pfeil 24">
+            <a:extLst>
+              <a:ext uri="{FF2B5EF4-FFF2-40B4-BE49-F238E27FC236}">
+                <a16:creationId xmlns:a16="http://schemas.microsoft.com/office/drawing/2014/main" id="{EE190DF8-6F1D-428D-8AF9-1FBA26A30772}"/>
+              </a:ext>
+            </a:extLst>
+          </p:cNvPr>
+          <p:cNvCxnSpPr>
+            <a:stCxn id="100" idx="3"/>
+            <a:endCxn id="44" idx="1"/>
+          </p:cNvCxnSpPr>
+          <p:nvPr/>
+        </p:nvCxnSpPr>
+        <p:spPr>
+          <a:xfrm flipV="1">
+            <a:off x="2236350" y="4026833"/>
+            <a:ext cx="4529814" cy="7347"/>
+          </a:xfrm>
+          <a:prstGeom prst="straightConnector1">
+            <a:avLst/>
+          </a:prstGeom>
+          <a:ln w="25400">
+            <a:prstDash val="sysDash"/>
+            <a:tailEnd type="triangle"/>
+          </a:ln>
+        </p:spPr>
+        <p:style>
+          <a:lnRef idx="1">
+            <a:schemeClr val="accent1"/>
+          </a:lnRef>
+          <a:fillRef idx="0">
+            <a:schemeClr val="accent1"/>
+          </a:fillRef>
+          <a:effectRef idx="0">
+            <a:schemeClr val="accent1"/>
+          </a:effectRef>
+          <a:fontRef idx="minor">
+            <a:schemeClr val="tx1"/>
+          </a:fontRef>
+        </p:style>
+      </p:cxnSp>
       <p:sp>
         <p:nvSpPr>
           <p:cNvPr id="40" name="Textfeld 39">
@@ -2985,8 +3028,8 @@
         </p:nvSpPr>
         <p:spPr>
           <a:xfrm>
-            <a:off x="3334074" y="537565"/>
-            <a:ext cx="2063129" cy="615553"/>
+            <a:off x="3188536" y="964306"/>
+            <a:ext cx="1824474" cy="584775"/>
           </a:xfrm>
           <a:prstGeom prst="rect">
             <a:avLst/>
@@ -3008,23 +3051,23 @@
               <a:rPr lang="de-DE" sz="1600" dirty="0"/>
             </a:br>
             <a:r>
-              <a:rPr lang="de-DE" sz="1600" dirty="0"/>
+              <a:rPr lang="de-DE" sz="1400" dirty="0"/>
               <a:t>(</a:t>
             </a:r>
             <a:r>
-              <a:rPr lang="de-DE" sz="1600" dirty="0" err="1"/>
+              <a:rPr lang="de-DE" sz="1400" dirty="0" err="1"/>
               <a:t>or</a:t>
             </a:r>
             <a:r>
-              <a:rPr lang="de-DE" sz="1600" dirty="0"/>
+              <a:rPr lang="de-DE" sz="1400" dirty="0"/>
               <a:t> UNICORE/X </a:t>
             </a:r>
             <a:r>
-              <a:rPr lang="de-DE" sz="1600" dirty="0" err="1"/>
+              <a:rPr lang="de-DE" sz="1400" dirty="0" err="1"/>
               <a:t>server</a:t>
             </a:r>
             <a:r>
-              <a:rPr lang="de-DE" sz="1600" dirty="0"/>
+              <a:rPr lang="de-DE" sz="1400" dirty="0"/>
               <a:t>)</a:t>
             </a:r>
             <a:endParaRPr lang="en-GB" sz="1600" dirty="0"/>
@@ -3049,13 +3092,13 @@
         </p:nvCxnSpPr>
         <p:spPr>
           <a:xfrm rot="5400000" flipH="1" flipV="1">
-            <a:off x="1648685" y="1119828"/>
-            <a:ext cx="1462112" cy="2013299"/>
+            <a:off x="1526557" y="1617737"/>
+            <a:ext cx="1330589" cy="1875513"/>
           </a:xfrm>
           <a:prstGeom prst="bentConnector2">
             <a:avLst/>
           </a:prstGeom>
-          <a:ln w="34925">
+          <a:ln w="25400">
             <a:prstDash val="sysDash"/>
             <a:tailEnd type="triangle"/>
           </a:ln>
@@ -3075,31 +3118,1418 @@
           </a:fontRef>
         </p:style>
       </p:cxnSp>
+      <p:sp>
+        <p:nvSpPr>
+          <p:cNvPr id="83" name="Textfeld 82">
+            <a:extLst>
+              <a:ext uri="{FF2B5EF4-FFF2-40B4-BE49-F238E27FC236}">
+                <a16:creationId xmlns:a16="http://schemas.microsoft.com/office/drawing/2014/main" id="{26D14A21-0B88-43DA-B0E1-0EBC713B37C8}"/>
+              </a:ext>
+            </a:extLst>
+          </p:cNvPr>
+          <p:cNvSpPr txBox="1"/>
+          <p:nvPr/>
+        </p:nvSpPr>
+        <p:spPr>
+          <a:xfrm>
+            <a:off x="1212534" y="1425971"/>
+            <a:ext cx="1907573" cy="307777"/>
+          </a:xfrm>
+          <a:prstGeom prst="rect">
+            <a:avLst/>
+          </a:prstGeom>
+          <a:noFill/>
+        </p:spPr>
+        <p:txBody>
+          <a:bodyPr wrap="none" rtlCol="0">
+            <a:spAutoFit/>
+          </a:bodyPr>
+          <a:lstStyle/>
+          <a:p>
+            <a:pPr algn="ctr"/>
+            <a:r>
+              <a:rPr lang="de-DE" sz="1400" b="1" i="1" dirty="0">
+                <a:solidFill>
+                  <a:srgbClr val="0070C0"/>
+                </a:solidFill>
+              </a:rPr>
+              <a:t>Authentication </a:t>
+            </a:r>
+            <a:r>
+              <a:rPr lang="de-DE" sz="1400" b="1" i="1" dirty="0" err="1">
+                <a:solidFill>
+                  <a:srgbClr val="0070C0"/>
+                </a:solidFill>
+              </a:rPr>
+              <a:t>request</a:t>
+            </a:r>
+            <a:endParaRPr lang="en-GB" sz="1400" b="1" i="1" dirty="0">
+              <a:solidFill>
+                <a:srgbClr val="0070C0"/>
+              </a:solidFill>
+            </a:endParaRPr>
+          </a:p>
+        </p:txBody>
+      </p:sp>
+      <p:sp>
+        <p:nvSpPr>
+          <p:cNvPr id="85" name="Textfeld 84">
+            <a:extLst>
+              <a:ext uri="{FF2B5EF4-FFF2-40B4-BE49-F238E27FC236}">
+                <a16:creationId xmlns:a16="http://schemas.microsoft.com/office/drawing/2014/main" id="{A6A3D902-927E-448F-A1B0-BA89FCD59360}"/>
+              </a:ext>
+            </a:extLst>
+          </p:cNvPr>
+          <p:cNvSpPr txBox="1"/>
+          <p:nvPr/>
+        </p:nvSpPr>
+        <p:spPr>
+          <a:xfrm>
+            <a:off x="3212964" y="3562451"/>
+            <a:ext cx="1929695" cy="307777"/>
+          </a:xfrm>
+          <a:prstGeom prst="rect">
+            <a:avLst/>
+          </a:prstGeom>
+          <a:noFill/>
+        </p:spPr>
+        <p:txBody>
+          <a:bodyPr wrap="none" rtlCol="0">
+            <a:spAutoFit/>
+          </a:bodyPr>
+          <a:lstStyle/>
+          <a:p>
+            <a:r>
+              <a:rPr lang="de-DE" sz="1400" b="1" i="1" dirty="0">
+                <a:solidFill>
+                  <a:srgbClr val="0070C0"/>
+                </a:solidFill>
+              </a:rPr>
+              <a:t>FTP Control Connection</a:t>
+            </a:r>
+            <a:endParaRPr lang="en-GB" sz="1400" b="1" i="1" dirty="0">
+              <a:solidFill>
+                <a:srgbClr val="0070C0"/>
+              </a:solidFill>
+            </a:endParaRPr>
+          </a:p>
+        </p:txBody>
+      </p:sp>
+      <p:sp>
+        <p:nvSpPr>
+          <p:cNvPr id="86" name="Textfeld 85">
+            <a:extLst>
+              <a:ext uri="{FF2B5EF4-FFF2-40B4-BE49-F238E27FC236}">
+                <a16:creationId xmlns:a16="http://schemas.microsoft.com/office/drawing/2014/main" id="{0B57E1AD-EEB3-4F8C-8A56-7AB9D000514C}"/>
+              </a:ext>
+            </a:extLst>
+          </p:cNvPr>
+          <p:cNvSpPr txBox="1"/>
+          <p:nvPr/>
+        </p:nvSpPr>
+        <p:spPr>
+          <a:xfrm>
+            <a:off x="2968245" y="5005402"/>
+            <a:ext cx="2383409" cy="307777"/>
+          </a:xfrm>
+          <a:prstGeom prst="rect">
+            <a:avLst/>
+          </a:prstGeom>
+          <a:noFill/>
+        </p:spPr>
+        <p:txBody>
+          <a:bodyPr wrap="none" rtlCol="0">
+            <a:spAutoFit/>
+          </a:bodyPr>
+          <a:lstStyle/>
+          <a:p>
+            <a:pPr algn="ctr"/>
+            <a:r>
+              <a:rPr lang="de-DE" sz="1400" b="1" i="1" dirty="0">
+                <a:solidFill>
+                  <a:srgbClr val="008000"/>
+                </a:solidFill>
+              </a:rPr>
+              <a:t>Passive FTP Data Connections</a:t>
+            </a:r>
+            <a:endParaRPr lang="en-GB" sz="1400" b="1" i="1" dirty="0">
+              <a:solidFill>
+                <a:srgbClr val="008000"/>
+              </a:solidFill>
+            </a:endParaRPr>
+          </a:p>
+        </p:txBody>
+      </p:sp>
+      <p:sp>
+        <p:nvSpPr>
+          <p:cNvPr id="87" name="Ellipse 86">
+            <a:extLst>
+              <a:ext uri="{FF2B5EF4-FFF2-40B4-BE49-F238E27FC236}">
+                <a16:creationId xmlns:a16="http://schemas.microsoft.com/office/drawing/2014/main" id="{C7ED80CB-00A2-4FC7-80B1-852CEF67B7FB}"/>
+              </a:ext>
+            </a:extLst>
+          </p:cNvPr>
+          <p:cNvSpPr/>
+          <p:nvPr/>
+        </p:nvSpPr>
+        <p:spPr>
+          <a:xfrm>
+            <a:off x="2078720" y="1744263"/>
+            <a:ext cx="295324" cy="310219"/>
+          </a:xfrm>
+          <a:prstGeom prst="ellipse">
+            <a:avLst/>
+          </a:prstGeom>
+          <a:solidFill>
+            <a:srgbClr val="00B0F0"/>
+          </a:solidFill>
+        </p:spPr>
+        <p:style>
+          <a:lnRef idx="2">
+            <a:schemeClr val="accent1">
+              <a:shade val="50000"/>
+            </a:schemeClr>
+          </a:lnRef>
+          <a:fillRef idx="1">
+            <a:schemeClr val="accent1"/>
+          </a:fillRef>
+          <a:effectRef idx="0">
+            <a:schemeClr val="accent1"/>
+          </a:effectRef>
+          <a:fontRef idx="minor">
+            <a:schemeClr val="lt1"/>
+          </a:fontRef>
+        </p:style>
+        <p:txBody>
+          <a:bodyPr rtlCol="0" anchor="ctr"/>
+          <a:lstStyle/>
+          <a:p>
+            <a:pPr algn="ctr"/>
+            <a:r>
+              <a:rPr lang="de-DE" sz="1600" b="1" dirty="0"/>
+              <a:t>1</a:t>
+            </a:r>
+            <a:endParaRPr lang="en-GB" sz="1600" b="1" dirty="0"/>
+          </a:p>
+        </p:txBody>
+      </p:sp>
+      <p:sp>
+        <p:nvSpPr>
+          <p:cNvPr id="98" name="Rechteck: abgerundete Ecken 97">
+            <a:extLst>
+              <a:ext uri="{FF2B5EF4-FFF2-40B4-BE49-F238E27FC236}">
+                <a16:creationId xmlns:a16="http://schemas.microsoft.com/office/drawing/2014/main" id="{A51B0A78-7D82-42A1-BE29-97A41F65A540}"/>
+              </a:ext>
+            </a:extLst>
+          </p:cNvPr>
+          <p:cNvSpPr/>
+          <p:nvPr/>
+        </p:nvSpPr>
+        <p:spPr>
+          <a:xfrm>
+            <a:off x="3129608" y="818653"/>
+            <a:ext cx="1942333" cy="2143089"/>
+          </a:xfrm>
+          <a:prstGeom prst="roundRect">
+            <a:avLst/>
+          </a:prstGeom>
+          <a:noFill/>
+          <a:ln w="19050">
+            <a:solidFill>
+              <a:srgbClr val="0070C0"/>
+            </a:solidFill>
+          </a:ln>
+        </p:spPr>
+        <p:style>
+          <a:lnRef idx="2">
+            <a:schemeClr val="accent1">
+              <a:shade val="50000"/>
+            </a:schemeClr>
+          </a:lnRef>
+          <a:fillRef idx="1">
+            <a:schemeClr val="accent1"/>
+          </a:fillRef>
+          <a:effectRef idx="0">
+            <a:schemeClr val="accent1"/>
+          </a:effectRef>
+          <a:fontRef idx="minor">
+            <a:schemeClr val="lt1"/>
+          </a:fontRef>
+        </p:style>
+        <p:txBody>
+          <a:bodyPr rtlCol="0" anchor="ctr"/>
+          <a:lstStyle/>
+          <a:p>
+            <a:pPr algn="ctr"/>
+            <a:endParaRPr lang="en-GB" sz="1350"/>
+          </a:p>
+        </p:txBody>
+      </p:sp>
+      <p:sp>
+        <p:nvSpPr>
+          <p:cNvPr id="39" name="Textfeld 38">
+            <a:extLst>
+              <a:ext uri="{FF2B5EF4-FFF2-40B4-BE49-F238E27FC236}">
+                <a16:creationId xmlns:a16="http://schemas.microsoft.com/office/drawing/2014/main" id="{A191F60E-7B25-4957-8278-5EBD374A961A}"/>
+              </a:ext>
+            </a:extLst>
+          </p:cNvPr>
+          <p:cNvSpPr txBox="1"/>
+          <p:nvPr/>
+        </p:nvSpPr>
+        <p:spPr>
+          <a:xfrm>
+            <a:off x="480261" y="3411935"/>
+            <a:ext cx="1638525" cy="584775"/>
+          </a:xfrm>
+          <a:prstGeom prst="rect">
+            <a:avLst/>
+          </a:prstGeom>
+          <a:noFill/>
+        </p:spPr>
+        <p:txBody>
+          <a:bodyPr wrap="none" rtlCol="0">
+            <a:spAutoFit/>
+          </a:bodyPr>
+          <a:lstStyle/>
+          <a:p>
+            <a:pPr algn="ctr"/>
+            <a:r>
+              <a:rPr lang="de-DE" b="1" dirty="0"/>
+              <a:t>UFTP </a:t>
+            </a:r>
+            <a:r>
+              <a:rPr lang="de-DE" b="1" dirty="0" err="1"/>
+              <a:t>Cient</a:t>
+            </a:r>
+            <a:br>
+              <a:rPr lang="de-DE" sz="1600" dirty="0"/>
+            </a:br>
+            <a:r>
+              <a:rPr lang="de-DE" sz="1400" dirty="0"/>
+              <a:t>(end-user </a:t>
+            </a:r>
+            <a:r>
+              <a:rPr lang="de-DE" sz="1400" dirty="0" err="1"/>
+              <a:t>or</a:t>
+            </a:r>
+            <a:r>
+              <a:rPr lang="de-DE" sz="1400" dirty="0"/>
+              <a:t> </a:t>
+            </a:r>
+            <a:r>
+              <a:rPr lang="de-DE" sz="1400" dirty="0" err="1"/>
+              <a:t>server</a:t>
+            </a:r>
+            <a:r>
+              <a:rPr lang="de-DE" sz="1400" dirty="0"/>
+              <a:t>)</a:t>
+            </a:r>
+            <a:endParaRPr lang="en-GB" sz="1600" dirty="0"/>
+          </a:p>
+        </p:txBody>
+      </p:sp>
+      <p:sp>
+        <p:nvSpPr>
+          <p:cNvPr id="100" name="Rechteck: abgerundete Ecken 99">
+            <a:extLst>
+              <a:ext uri="{FF2B5EF4-FFF2-40B4-BE49-F238E27FC236}">
+                <a16:creationId xmlns:a16="http://schemas.microsoft.com/office/drawing/2014/main" id="{EB8AFB6D-3B50-4048-BE43-6F9F4E11FDB3}"/>
+              </a:ext>
+            </a:extLst>
+          </p:cNvPr>
+          <p:cNvSpPr/>
+          <p:nvPr/>
+        </p:nvSpPr>
+        <p:spPr>
+          <a:xfrm>
+            <a:off x="271840" y="3220787"/>
+            <a:ext cx="1964510" cy="1626785"/>
+          </a:xfrm>
+          <a:prstGeom prst="roundRect">
+            <a:avLst/>
+          </a:prstGeom>
+          <a:noFill/>
+          <a:ln w="19050">
+            <a:solidFill>
+              <a:srgbClr val="0070C0"/>
+            </a:solidFill>
+          </a:ln>
+        </p:spPr>
+        <p:style>
+          <a:lnRef idx="2">
+            <a:schemeClr val="accent1">
+              <a:shade val="50000"/>
+            </a:schemeClr>
+          </a:lnRef>
+          <a:fillRef idx="1">
+            <a:schemeClr val="accent1"/>
+          </a:fillRef>
+          <a:effectRef idx="0">
+            <a:schemeClr val="accent1"/>
+          </a:effectRef>
+          <a:fontRef idx="minor">
+            <a:schemeClr val="lt1"/>
+          </a:fontRef>
+        </p:style>
+        <p:txBody>
+          <a:bodyPr rtlCol="0" anchor="ctr"/>
+          <a:lstStyle/>
+          <a:p>
+            <a:pPr algn="ctr"/>
+            <a:endParaRPr lang="en-GB" sz="1350"/>
+          </a:p>
+        </p:txBody>
+      </p:sp>
+      <p:pic>
+        <p:nvPicPr>
+          <p:cNvPr id="92" name="Grafik 91">
+            <a:extLst>
+              <a:ext uri="{FF2B5EF4-FFF2-40B4-BE49-F238E27FC236}">
+                <a16:creationId xmlns:a16="http://schemas.microsoft.com/office/drawing/2014/main" id="{4C6E8205-1EB3-4D55-8B7E-DEC4A1C77CE5}"/>
+              </a:ext>
+            </a:extLst>
+          </p:cNvPr>
+          <p:cNvPicPr>
+            <a:picLocks noChangeAspect="1"/>
+          </p:cNvPicPr>
+          <p:nvPr/>
+        </p:nvPicPr>
+        <p:blipFill>
+          <a:blip r:embed="rId2"/>
+          <a:stretch>
+            <a:fillRect/>
+          </a:stretch>
+        </p:blipFill>
+        <p:spPr>
+          <a:xfrm>
+            <a:off x="792471" y="4025941"/>
+            <a:ext cx="868048" cy="663135"/>
+          </a:xfrm>
+          <a:prstGeom prst="rect">
+            <a:avLst/>
+          </a:prstGeom>
+        </p:spPr>
+      </p:pic>
+      <p:grpSp>
+        <p:nvGrpSpPr>
+          <p:cNvPr id="17" name="Gruppieren 16">
+            <a:extLst>
+              <a:ext uri="{FF2B5EF4-FFF2-40B4-BE49-F238E27FC236}">
+                <a16:creationId xmlns:a16="http://schemas.microsoft.com/office/drawing/2014/main" id="{5EACC380-4F22-4F6F-86B4-BF2535E2258E}"/>
+              </a:ext>
+            </a:extLst>
+          </p:cNvPr>
+          <p:cNvGrpSpPr/>
+          <p:nvPr/>
+        </p:nvGrpSpPr>
+        <p:grpSpPr>
+          <a:xfrm>
+            <a:off x="3650776" y="1747774"/>
+            <a:ext cx="949060" cy="957430"/>
+            <a:chOff x="3905433" y="1301287"/>
+            <a:chExt cx="949060" cy="957430"/>
+          </a:xfrm>
+        </p:grpSpPr>
+        <p:pic>
+          <p:nvPicPr>
+            <p:cNvPr id="93" name="Grafik 92">
+              <a:extLst>
+                <a:ext uri="{FF2B5EF4-FFF2-40B4-BE49-F238E27FC236}">
+                  <a16:creationId xmlns:a16="http://schemas.microsoft.com/office/drawing/2014/main" id="{F6E4E32B-B04E-47A2-BEC6-C66A939BEAC4}"/>
+                </a:ext>
+              </a:extLst>
+            </p:cNvPr>
+            <p:cNvPicPr>
+              <a:picLocks noChangeAspect="1"/>
+            </p:cNvPicPr>
+            <p:nvPr/>
+          </p:nvPicPr>
+          <p:blipFill>
+            <a:blip r:embed="rId3"/>
+            <a:stretch>
+              <a:fillRect/>
+            </a:stretch>
+          </p:blipFill>
+          <p:spPr>
+            <a:xfrm>
+              <a:off x="3905433" y="1301287"/>
+              <a:ext cx="926340" cy="957430"/>
+            </a:xfrm>
+            <a:prstGeom prst="rect">
+              <a:avLst/>
+            </a:prstGeom>
+          </p:spPr>
+        </p:pic>
+        <p:pic>
+          <p:nvPicPr>
+            <p:cNvPr id="72" name="Grafik 71">
+              <a:extLst>
+                <a:ext uri="{FF2B5EF4-FFF2-40B4-BE49-F238E27FC236}">
+                  <a16:creationId xmlns:a16="http://schemas.microsoft.com/office/drawing/2014/main" id="{422EE592-241D-4F02-8BF9-D181780D08EE}"/>
+                </a:ext>
+              </a:extLst>
+            </p:cNvPr>
+            <p:cNvPicPr>
+              <a:picLocks noChangeAspect="1"/>
+            </p:cNvPicPr>
+            <p:nvPr/>
+          </p:nvPicPr>
+          <p:blipFill>
+            <a:blip r:embed="rId4">
+              <a:extLst>
+                <a:ext uri="{28A0092B-C50C-407E-A947-70E740481C1C}">
+                  <a14:useLocalDpi xmlns:a14="http://schemas.microsoft.com/office/drawing/2010/main" val="0"/>
+                </a:ext>
+              </a:extLst>
+            </a:blip>
+            <a:stretch>
+              <a:fillRect/>
+            </a:stretch>
+          </p:blipFill>
+          <p:spPr>
+            <a:xfrm>
+              <a:off x="4357559" y="1663327"/>
+              <a:ext cx="496934" cy="513612"/>
+            </a:xfrm>
+            <a:prstGeom prst="rect">
+              <a:avLst/>
+            </a:prstGeom>
+          </p:spPr>
+        </p:pic>
+      </p:grpSp>
+      <p:sp>
+        <p:nvSpPr>
+          <p:cNvPr id="99" name="Rechteck: abgerundete Ecken 98">
+            <a:extLst>
+              <a:ext uri="{FF2B5EF4-FFF2-40B4-BE49-F238E27FC236}">
+                <a16:creationId xmlns:a16="http://schemas.microsoft.com/office/drawing/2014/main" id="{C40587F3-FB08-4311-A205-85AF672C9347}"/>
+              </a:ext>
+            </a:extLst>
+          </p:cNvPr>
+          <p:cNvSpPr/>
+          <p:nvPr/>
+        </p:nvSpPr>
+        <p:spPr>
+          <a:xfrm>
+            <a:off x="6881404" y="818653"/>
+            <a:ext cx="1906749" cy="5582146"/>
+          </a:xfrm>
+          <a:prstGeom prst="roundRect">
+            <a:avLst/>
+          </a:prstGeom>
+          <a:noFill/>
+          <a:ln w="19050">
+            <a:solidFill>
+              <a:srgbClr val="0070C0"/>
+            </a:solidFill>
+          </a:ln>
+        </p:spPr>
+        <p:style>
+          <a:lnRef idx="2">
+            <a:schemeClr val="accent1">
+              <a:shade val="50000"/>
+            </a:schemeClr>
+          </a:lnRef>
+          <a:fillRef idx="1">
+            <a:schemeClr val="accent1"/>
+          </a:fillRef>
+          <a:effectRef idx="0">
+            <a:schemeClr val="accent1"/>
+          </a:effectRef>
+          <a:fontRef idx="minor">
+            <a:schemeClr val="lt1"/>
+          </a:fontRef>
+        </p:style>
+        <p:txBody>
+          <a:bodyPr rtlCol="0" anchor="ctr"/>
+          <a:lstStyle/>
+          <a:p>
+            <a:pPr algn="ctr"/>
+            <a:endParaRPr lang="en-GB" sz="1350"/>
+          </a:p>
+        </p:txBody>
+      </p:sp>
+      <p:sp>
+        <p:nvSpPr>
+          <p:cNvPr id="42" name="Textfeld 41">
+            <a:extLst>
+              <a:ext uri="{FF2B5EF4-FFF2-40B4-BE49-F238E27FC236}">
+                <a16:creationId xmlns:a16="http://schemas.microsoft.com/office/drawing/2014/main" id="{6E092C4C-4AC9-417B-89C1-AB0BBD4047A1}"/>
+              </a:ext>
+            </a:extLst>
+          </p:cNvPr>
+          <p:cNvSpPr txBox="1"/>
+          <p:nvPr/>
+        </p:nvSpPr>
+        <p:spPr>
+          <a:xfrm>
+            <a:off x="7133777" y="1010576"/>
+            <a:ext cx="1489447" cy="369332"/>
+          </a:xfrm>
+          <a:prstGeom prst="rect">
+            <a:avLst/>
+          </a:prstGeom>
+          <a:noFill/>
+        </p:spPr>
+        <p:txBody>
+          <a:bodyPr wrap="none" rtlCol="0">
+            <a:spAutoFit/>
+          </a:bodyPr>
+          <a:lstStyle/>
+          <a:p>
+            <a:pPr algn="ctr"/>
+            <a:r>
+              <a:rPr lang="de-DE" b="1" dirty="0"/>
+              <a:t>UFTPD Server</a:t>
+            </a:r>
+            <a:endParaRPr lang="en-GB" dirty="0"/>
+          </a:p>
+        </p:txBody>
+      </p:sp>
+      <p:sp>
+        <p:nvSpPr>
+          <p:cNvPr id="43" name="Rechteck 42">
+            <a:extLst>
+              <a:ext uri="{FF2B5EF4-FFF2-40B4-BE49-F238E27FC236}">
+                <a16:creationId xmlns:a16="http://schemas.microsoft.com/office/drawing/2014/main" id="{CF37F80B-00B6-43FC-B00D-42A817E173EA}"/>
+              </a:ext>
+            </a:extLst>
+          </p:cNvPr>
+          <p:cNvSpPr/>
+          <p:nvPr/>
+        </p:nvSpPr>
+        <p:spPr>
+          <a:xfrm>
+            <a:off x="6772427" y="1759034"/>
+            <a:ext cx="339828" cy="292503"/>
+          </a:xfrm>
+          <a:prstGeom prst="rect">
+            <a:avLst/>
+          </a:prstGeom>
+          <a:solidFill>
+            <a:srgbClr val="00B0F0"/>
+          </a:solidFill>
+          <a:ln>
+            <a:solidFill>
+              <a:srgbClr val="0070C0"/>
+            </a:solidFill>
+          </a:ln>
+        </p:spPr>
+        <p:style>
+          <a:lnRef idx="2">
+            <a:schemeClr val="accent1">
+              <a:shade val="50000"/>
+            </a:schemeClr>
+          </a:lnRef>
+          <a:fillRef idx="1">
+            <a:schemeClr val="accent1"/>
+          </a:fillRef>
+          <a:effectRef idx="0">
+            <a:schemeClr val="accent1"/>
+          </a:effectRef>
+          <a:fontRef idx="minor">
+            <a:schemeClr val="lt1"/>
+          </a:fontRef>
+        </p:style>
+        <p:txBody>
+          <a:bodyPr rtlCol="0" anchor="ctr"/>
+          <a:lstStyle/>
+          <a:p>
+            <a:pPr algn="ctr"/>
+            <a:endParaRPr lang="en-GB" sz="1350"/>
+          </a:p>
+        </p:txBody>
+      </p:sp>
+      <p:sp>
+        <p:nvSpPr>
+          <p:cNvPr id="44" name="Rechteck 43">
+            <a:extLst>
+              <a:ext uri="{FF2B5EF4-FFF2-40B4-BE49-F238E27FC236}">
+                <a16:creationId xmlns:a16="http://schemas.microsoft.com/office/drawing/2014/main" id="{9A2CF124-8B16-4213-8943-707C6C61D000}"/>
+              </a:ext>
+            </a:extLst>
+          </p:cNvPr>
+          <p:cNvSpPr/>
+          <p:nvPr/>
+        </p:nvSpPr>
+        <p:spPr>
+          <a:xfrm>
+            <a:off x="6766164" y="3880581"/>
+            <a:ext cx="339828" cy="292503"/>
+          </a:xfrm>
+          <a:prstGeom prst="rect">
+            <a:avLst/>
+          </a:prstGeom>
+          <a:solidFill>
+            <a:srgbClr val="0070C0"/>
+          </a:solidFill>
+          <a:ln w="22225">
+            <a:solidFill>
+              <a:srgbClr val="0070C0"/>
+            </a:solidFill>
+          </a:ln>
+        </p:spPr>
+        <p:style>
+          <a:lnRef idx="2">
+            <a:schemeClr val="accent1">
+              <a:shade val="50000"/>
+            </a:schemeClr>
+          </a:lnRef>
+          <a:fillRef idx="1">
+            <a:schemeClr val="accent1"/>
+          </a:fillRef>
+          <a:effectRef idx="0">
+            <a:schemeClr val="accent1"/>
+          </a:effectRef>
+          <a:fontRef idx="minor">
+            <a:schemeClr val="lt1"/>
+          </a:fontRef>
+        </p:style>
+        <p:txBody>
+          <a:bodyPr rtlCol="0" anchor="ctr"/>
+          <a:lstStyle/>
+          <a:p>
+            <a:pPr algn="ctr"/>
+            <a:endParaRPr lang="en-GB" sz="1350" dirty="0"/>
+          </a:p>
+        </p:txBody>
+      </p:sp>
+      <p:sp>
+        <p:nvSpPr>
+          <p:cNvPr id="45" name="Rechteck 44">
+            <a:extLst>
+              <a:ext uri="{FF2B5EF4-FFF2-40B4-BE49-F238E27FC236}">
+                <a16:creationId xmlns:a16="http://schemas.microsoft.com/office/drawing/2014/main" id="{7CDC7DB5-5914-49C2-B017-83EFC50ABCEF}"/>
+              </a:ext>
+            </a:extLst>
+          </p:cNvPr>
+          <p:cNvSpPr/>
+          <p:nvPr/>
+        </p:nvSpPr>
+        <p:spPr>
+          <a:xfrm>
+            <a:off x="6696640" y="5316338"/>
+            <a:ext cx="318328" cy="189190"/>
+          </a:xfrm>
+          <a:prstGeom prst="rect">
+            <a:avLst/>
+          </a:prstGeom>
+          <a:solidFill>
+            <a:srgbClr val="00B050"/>
+          </a:solidFill>
+          <a:ln>
+            <a:solidFill>
+              <a:srgbClr val="0070C0"/>
+            </a:solidFill>
+          </a:ln>
+        </p:spPr>
+        <p:style>
+          <a:lnRef idx="2">
+            <a:schemeClr val="accent1">
+              <a:shade val="50000"/>
+            </a:schemeClr>
+          </a:lnRef>
+          <a:fillRef idx="1">
+            <a:schemeClr val="accent1"/>
+          </a:fillRef>
+          <a:effectRef idx="0">
+            <a:schemeClr val="accent1"/>
+          </a:effectRef>
+          <a:fontRef idx="minor">
+            <a:schemeClr val="lt1"/>
+          </a:fontRef>
+        </p:style>
+        <p:txBody>
+          <a:bodyPr rtlCol="0" anchor="ctr"/>
+          <a:lstStyle/>
+          <a:p>
+            <a:pPr algn="ctr"/>
+            <a:endParaRPr lang="en-GB" sz="1350"/>
+          </a:p>
+        </p:txBody>
+      </p:sp>
+      <p:sp>
+        <p:nvSpPr>
+          <p:cNvPr id="46" name="Rechteck 45">
+            <a:extLst>
+              <a:ext uri="{FF2B5EF4-FFF2-40B4-BE49-F238E27FC236}">
+                <a16:creationId xmlns:a16="http://schemas.microsoft.com/office/drawing/2014/main" id="{4033F9D3-DC4E-4BBE-A5F0-2197F1A5B39E}"/>
+              </a:ext>
+            </a:extLst>
+          </p:cNvPr>
+          <p:cNvSpPr/>
+          <p:nvPr/>
+        </p:nvSpPr>
+        <p:spPr>
+          <a:xfrm>
+            <a:off x="6750804" y="5409814"/>
+            <a:ext cx="318328" cy="189190"/>
+          </a:xfrm>
+          <a:prstGeom prst="rect">
+            <a:avLst/>
+          </a:prstGeom>
+          <a:solidFill>
+            <a:srgbClr val="00B050"/>
+          </a:solidFill>
+          <a:ln>
+            <a:solidFill>
+              <a:srgbClr val="0070C0"/>
+            </a:solidFill>
+          </a:ln>
+        </p:spPr>
+        <p:style>
+          <a:lnRef idx="2">
+            <a:schemeClr val="accent1">
+              <a:shade val="50000"/>
+            </a:schemeClr>
+          </a:lnRef>
+          <a:fillRef idx="1">
+            <a:schemeClr val="accent1"/>
+          </a:fillRef>
+          <a:effectRef idx="0">
+            <a:schemeClr val="accent1"/>
+          </a:effectRef>
+          <a:fontRef idx="minor">
+            <a:schemeClr val="lt1"/>
+          </a:fontRef>
+        </p:style>
+        <p:txBody>
+          <a:bodyPr rtlCol="0" anchor="ctr"/>
+          <a:lstStyle/>
+          <a:p>
+            <a:pPr algn="ctr"/>
+            <a:endParaRPr lang="en-GB" sz="1350"/>
+          </a:p>
+        </p:txBody>
+      </p:sp>
+      <p:sp>
+        <p:nvSpPr>
+          <p:cNvPr id="47" name="Rechteck 46">
+            <a:extLst>
+              <a:ext uri="{FF2B5EF4-FFF2-40B4-BE49-F238E27FC236}">
+                <a16:creationId xmlns:a16="http://schemas.microsoft.com/office/drawing/2014/main" id="{561E461A-BF9F-402B-B58F-4E2970C240A5}"/>
+              </a:ext>
+            </a:extLst>
+          </p:cNvPr>
+          <p:cNvSpPr/>
+          <p:nvPr/>
+        </p:nvSpPr>
+        <p:spPr>
+          <a:xfrm>
+            <a:off x="6816108" y="5512827"/>
+            <a:ext cx="318328" cy="189190"/>
+          </a:xfrm>
+          <a:prstGeom prst="rect">
+            <a:avLst/>
+          </a:prstGeom>
+          <a:solidFill>
+            <a:srgbClr val="00B050"/>
+          </a:solidFill>
+          <a:ln>
+            <a:solidFill>
+              <a:srgbClr val="0070C0"/>
+            </a:solidFill>
+          </a:ln>
+        </p:spPr>
+        <p:style>
+          <a:lnRef idx="2">
+            <a:schemeClr val="accent1">
+              <a:shade val="50000"/>
+            </a:schemeClr>
+          </a:lnRef>
+          <a:fillRef idx="1">
+            <a:schemeClr val="accent1"/>
+          </a:fillRef>
+          <a:effectRef idx="0">
+            <a:schemeClr val="accent1"/>
+          </a:effectRef>
+          <a:fontRef idx="minor">
+            <a:schemeClr val="lt1"/>
+          </a:fontRef>
+        </p:style>
+        <p:txBody>
+          <a:bodyPr rtlCol="0" anchor="ctr"/>
+          <a:lstStyle/>
+          <a:p>
+            <a:pPr algn="ctr"/>
+            <a:endParaRPr lang="en-GB" sz="1350"/>
+          </a:p>
+        </p:txBody>
+      </p:sp>
+      <p:sp>
+        <p:nvSpPr>
+          <p:cNvPr id="80" name="Textfeld 79">
+            <a:extLst>
+              <a:ext uri="{FF2B5EF4-FFF2-40B4-BE49-F238E27FC236}">
+                <a16:creationId xmlns:a16="http://schemas.microsoft.com/office/drawing/2014/main" id="{D5D798D5-8C66-432F-9176-7A715B9C0170}"/>
+              </a:ext>
+            </a:extLst>
+          </p:cNvPr>
+          <p:cNvSpPr txBox="1"/>
+          <p:nvPr/>
+        </p:nvSpPr>
+        <p:spPr>
+          <a:xfrm>
+            <a:off x="7118266" y="1751795"/>
+            <a:ext cx="1306768" cy="307777"/>
+          </a:xfrm>
+          <a:prstGeom prst="rect">
+            <a:avLst/>
+          </a:prstGeom>
+          <a:noFill/>
+        </p:spPr>
+        <p:txBody>
+          <a:bodyPr wrap="none" rtlCol="0">
+            <a:spAutoFit/>
+          </a:bodyPr>
+          <a:lstStyle/>
+          <a:p>
+            <a:r>
+              <a:rPr lang="de-DE" sz="1400" b="1" dirty="0"/>
+              <a:t>Command </a:t>
+            </a:r>
+            <a:r>
+              <a:rPr lang="de-DE" sz="1400" b="1" dirty="0" err="1"/>
+              <a:t>port</a:t>
+            </a:r>
+            <a:endParaRPr lang="en-GB" sz="1400" dirty="0"/>
+          </a:p>
+        </p:txBody>
+      </p:sp>
+      <p:sp>
+        <p:nvSpPr>
+          <p:cNvPr id="81" name="Textfeld 80">
+            <a:extLst>
+              <a:ext uri="{FF2B5EF4-FFF2-40B4-BE49-F238E27FC236}">
+                <a16:creationId xmlns:a16="http://schemas.microsoft.com/office/drawing/2014/main" id="{FC978FC2-35B3-4F1D-95B3-319D19302808}"/>
+              </a:ext>
+            </a:extLst>
+          </p:cNvPr>
+          <p:cNvSpPr txBox="1"/>
+          <p:nvPr/>
+        </p:nvSpPr>
+        <p:spPr>
+          <a:xfrm>
+            <a:off x="7121399" y="3865307"/>
+            <a:ext cx="980397" cy="307777"/>
+          </a:xfrm>
+          <a:prstGeom prst="rect">
+            <a:avLst/>
+          </a:prstGeom>
+          <a:noFill/>
+        </p:spPr>
+        <p:txBody>
+          <a:bodyPr wrap="none" rtlCol="0">
+            <a:spAutoFit/>
+          </a:bodyPr>
+          <a:lstStyle>
+            <a:defPPr>
+              <a:defRPr lang="en-US"/>
+            </a:defPPr>
+            <a:lvl1pPr algn="ctr"/>
+          </a:lstStyle>
+          <a:p>
+            <a:pPr algn="l"/>
+            <a:r>
+              <a:rPr lang="de-DE" sz="1400" b="1" dirty="0"/>
+              <a:t>Listen </a:t>
+            </a:r>
+            <a:r>
+              <a:rPr lang="de-DE" sz="1400" b="1" dirty="0" err="1"/>
+              <a:t>port</a:t>
+            </a:r>
+            <a:endParaRPr lang="en-GB" sz="1400" b="1" dirty="0"/>
+          </a:p>
+        </p:txBody>
+      </p:sp>
+      <p:sp>
+        <p:nvSpPr>
+          <p:cNvPr id="82" name="Textfeld 81">
+            <a:extLst>
+              <a:ext uri="{FF2B5EF4-FFF2-40B4-BE49-F238E27FC236}">
+                <a16:creationId xmlns:a16="http://schemas.microsoft.com/office/drawing/2014/main" id="{628665A9-6B92-45BF-B501-3E63E2BD6C25}"/>
+              </a:ext>
+            </a:extLst>
+          </p:cNvPr>
+          <p:cNvSpPr txBox="1"/>
+          <p:nvPr/>
+        </p:nvSpPr>
+        <p:spPr>
+          <a:xfrm>
+            <a:off x="7126299" y="5260719"/>
+            <a:ext cx="1373891" cy="307777"/>
+          </a:xfrm>
+          <a:prstGeom prst="rect">
+            <a:avLst/>
+          </a:prstGeom>
+          <a:noFill/>
+        </p:spPr>
+        <p:txBody>
+          <a:bodyPr wrap="square" rtlCol="0">
+            <a:spAutoFit/>
+          </a:bodyPr>
+          <a:lstStyle>
+            <a:defPPr>
+              <a:defRPr lang="en-US"/>
+            </a:defPPr>
+            <a:lvl1pPr algn="ctr"/>
+          </a:lstStyle>
+          <a:p>
+            <a:pPr algn="l"/>
+            <a:r>
+              <a:rPr lang="de-DE" sz="1400" b="1" dirty="0"/>
+              <a:t>Data </a:t>
+            </a:r>
+            <a:r>
+              <a:rPr lang="de-DE" sz="1400" b="1" dirty="0" err="1"/>
+              <a:t>ports</a:t>
+            </a:r>
+            <a:endParaRPr lang="de-DE" sz="1400" b="1" dirty="0"/>
+          </a:p>
+        </p:txBody>
+      </p:sp>
+      <p:sp>
+        <p:nvSpPr>
+          <p:cNvPr id="116" name="Textfeld 115">
+            <a:extLst>
+              <a:ext uri="{FF2B5EF4-FFF2-40B4-BE49-F238E27FC236}">
+                <a16:creationId xmlns:a16="http://schemas.microsoft.com/office/drawing/2014/main" id="{31470ACF-55D1-436D-BEA0-5B2184EE9B54}"/>
+              </a:ext>
+            </a:extLst>
+          </p:cNvPr>
+          <p:cNvSpPr txBox="1"/>
+          <p:nvPr/>
+        </p:nvSpPr>
+        <p:spPr>
+          <a:xfrm>
+            <a:off x="7184372" y="5497124"/>
+            <a:ext cx="1584761" cy="523220"/>
+          </a:xfrm>
+          <a:prstGeom prst="rect">
+            <a:avLst/>
+          </a:prstGeom>
+          <a:noFill/>
+        </p:spPr>
+        <p:txBody>
+          <a:bodyPr wrap="square" rtlCol="0">
+            <a:spAutoFit/>
+          </a:bodyPr>
+          <a:lstStyle>
+            <a:defPPr>
+              <a:defRPr lang="en-US"/>
+            </a:defPPr>
+            <a:lvl1pPr algn="ctr"/>
+          </a:lstStyle>
+          <a:p>
+            <a:pPr algn="l"/>
+            <a:r>
+              <a:rPr lang="de-DE" sz="1400" dirty="0"/>
+              <a:t>(</a:t>
+            </a:r>
+            <a:r>
+              <a:rPr lang="de-DE" sz="1200" i="1" dirty="0" err="1"/>
+              <a:t>dynamic</a:t>
+            </a:r>
+            <a:r>
+              <a:rPr lang="de-DE" sz="1200" i="1" dirty="0"/>
+              <a:t> </a:t>
+            </a:r>
+            <a:r>
+              <a:rPr lang="de-DE" sz="1200" i="1" dirty="0" err="1"/>
+              <a:t>or</a:t>
+            </a:r>
+            <a:r>
+              <a:rPr lang="de-DE" sz="1200" i="1" dirty="0"/>
+              <a:t> </a:t>
+            </a:r>
+            <a:br>
+              <a:rPr lang="de-DE" sz="1200" i="1" dirty="0"/>
+            </a:br>
+            <a:r>
+              <a:rPr lang="de-DE" sz="1200" i="1" dirty="0" err="1"/>
+              <a:t>configured</a:t>
+            </a:r>
+            <a:r>
+              <a:rPr lang="de-DE" sz="1200" i="1" dirty="0"/>
+              <a:t> </a:t>
+            </a:r>
+            <a:r>
+              <a:rPr lang="de-DE" sz="1200" i="1" dirty="0" err="1"/>
+              <a:t>range</a:t>
+            </a:r>
+            <a:r>
+              <a:rPr lang="de-DE" sz="1400" dirty="0"/>
+              <a:t>)</a:t>
+            </a:r>
+            <a:endParaRPr lang="en-GB" sz="1600" dirty="0"/>
+          </a:p>
+        </p:txBody>
+      </p:sp>
+      <p:pic>
+        <p:nvPicPr>
+          <p:cNvPr id="123" name="Grafik 122">
+            <a:extLst>
+              <a:ext uri="{FF2B5EF4-FFF2-40B4-BE49-F238E27FC236}">
+                <a16:creationId xmlns:a16="http://schemas.microsoft.com/office/drawing/2014/main" id="{5F608270-20C0-4C3D-912A-FE42750A8E87}"/>
+              </a:ext>
+            </a:extLst>
+          </p:cNvPr>
+          <p:cNvPicPr>
+            <a:picLocks noChangeAspect="1"/>
+          </p:cNvPicPr>
+          <p:nvPr/>
+        </p:nvPicPr>
+        <p:blipFill>
+          <a:blip r:embed="rId5">
+            <a:extLst>
+              <a:ext uri="{28A0092B-C50C-407E-A947-70E740481C1C}">
+                <a14:useLocalDpi xmlns:a14="http://schemas.microsoft.com/office/drawing/2010/main" val="0"/>
+              </a:ext>
+            </a:extLst>
+          </a:blip>
+          <a:stretch>
+            <a:fillRect/>
+          </a:stretch>
+        </p:blipFill>
+        <p:spPr>
+          <a:xfrm>
+            <a:off x="7498744" y="2428278"/>
+            <a:ext cx="731542" cy="1066928"/>
+          </a:xfrm>
+          <a:prstGeom prst="rect">
+            <a:avLst/>
+          </a:prstGeom>
+        </p:spPr>
+      </p:pic>
+      <p:sp>
+        <p:nvSpPr>
+          <p:cNvPr id="3" name="Textfeld 2">
+            <a:extLst>
+              <a:ext uri="{FF2B5EF4-FFF2-40B4-BE49-F238E27FC236}">
+                <a16:creationId xmlns:a16="http://schemas.microsoft.com/office/drawing/2014/main" id="{3B354CF3-9F23-4FDD-A1F6-1DA43EB81531}"/>
+              </a:ext>
+            </a:extLst>
+          </p:cNvPr>
+          <p:cNvSpPr txBox="1"/>
+          <p:nvPr/>
+        </p:nvSpPr>
+        <p:spPr>
+          <a:xfrm>
+            <a:off x="1796907" y="2096650"/>
+            <a:ext cx="928459" cy="430887"/>
+          </a:xfrm>
+          <a:prstGeom prst="rect">
+            <a:avLst/>
+          </a:prstGeom>
+          <a:noFill/>
+        </p:spPr>
+        <p:txBody>
+          <a:bodyPr wrap="none" rtlCol="0">
+            <a:spAutoFit/>
+          </a:bodyPr>
+          <a:lstStyle/>
+          <a:p>
+            <a:r>
+              <a:rPr lang="de-DE" sz="1100" i="1" dirty="0"/>
+              <a:t>(</a:t>
+            </a:r>
+            <a:r>
+              <a:rPr lang="de-DE" sz="1100" i="1" dirty="0" err="1"/>
+              <a:t>username</a:t>
+            </a:r>
+            <a:r>
+              <a:rPr lang="de-DE" sz="1100" i="1" dirty="0"/>
+              <a:t> + </a:t>
+            </a:r>
+            <a:br>
+              <a:rPr lang="de-DE" sz="1100" i="1" dirty="0"/>
+            </a:br>
+            <a:r>
+              <a:rPr lang="de-DE" sz="1100" i="1" dirty="0" err="1"/>
+              <a:t>password</a:t>
+            </a:r>
+            <a:r>
+              <a:rPr lang="de-DE" sz="1100" i="1" dirty="0"/>
+              <a:t>)</a:t>
+            </a:r>
+            <a:endParaRPr lang="en-GB" sz="1100" i="1" dirty="0"/>
+          </a:p>
+        </p:txBody>
+      </p:sp>
+      <p:sp>
+        <p:nvSpPr>
+          <p:cNvPr id="84" name="Textfeld 83">
+            <a:extLst>
+              <a:ext uri="{FF2B5EF4-FFF2-40B4-BE49-F238E27FC236}">
+                <a16:creationId xmlns:a16="http://schemas.microsoft.com/office/drawing/2014/main" id="{AECF1D1C-A345-4401-A4DD-555EA94B4EFA}"/>
+              </a:ext>
+            </a:extLst>
+          </p:cNvPr>
+          <p:cNvSpPr txBox="1"/>
+          <p:nvPr/>
+        </p:nvSpPr>
+        <p:spPr>
+          <a:xfrm>
+            <a:off x="5123050" y="1449976"/>
+            <a:ext cx="1698735" cy="307777"/>
+          </a:xfrm>
+          <a:prstGeom prst="rect">
+            <a:avLst/>
+          </a:prstGeom>
+          <a:noFill/>
+        </p:spPr>
+        <p:txBody>
+          <a:bodyPr wrap="none" rtlCol="0">
+            <a:spAutoFit/>
+          </a:bodyPr>
+          <a:lstStyle/>
+          <a:p>
+            <a:r>
+              <a:rPr lang="de-DE" sz="1400" b="1" i="1" dirty="0" err="1">
+                <a:solidFill>
+                  <a:srgbClr val="0070C0"/>
+                </a:solidFill>
+              </a:rPr>
+              <a:t>Prepare</a:t>
+            </a:r>
+            <a:r>
+              <a:rPr lang="de-DE" sz="1400" b="1" i="1" dirty="0">
+                <a:solidFill>
+                  <a:srgbClr val="0070C0"/>
+                </a:solidFill>
+              </a:rPr>
+              <a:t> FTP </a:t>
+            </a:r>
+            <a:r>
+              <a:rPr lang="de-DE" sz="1400" b="1" i="1" dirty="0" err="1">
+                <a:solidFill>
+                  <a:srgbClr val="0070C0"/>
+                </a:solidFill>
+              </a:rPr>
+              <a:t>session</a:t>
+            </a:r>
+            <a:r>
+              <a:rPr lang="de-DE" sz="1400" b="1" i="1" dirty="0">
+                <a:solidFill>
+                  <a:srgbClr val="0070C0"/>
+                </a:solidFill>
+              </a:rPr>
+              <a:t> </a:t>
+            </a:r>
+            <a:endParaRPr lang="en-GB" sz="1400" b="1" i="1" dirty="0">
+              <a:solidFill>
+                <a:srgbClr val="0070C0"/>
+              </a:solidFill>
+            </a:endParaRPr>
+          </a:p>
+        </p:txBody>
+      </p:sp>
+      <p:sp>
+        <p:nvSpPr>
+          <p:cNvPr id="62" name="Textfeld 61">
+            <a:extLst>
+              <a:ext uri="{FF2B5EF4-FFF2-40B4-BE49-F238E27FC236}">
+                <a16:creationId xmlns:a16="http://schemas.microsoft.com/office/drawing/2014/main" id="{F21398CE-8541-471B-8D1F-8282D4FEBD32}"/>
+              </a:ext>
+            </a:extLst>
+          </p:cNvPr>
+          <p:cNvSpPr txBox="1"/>
+          <p:nvPr/>
+        </p:nvSpPr>
+        <p:spPr>
+          <a:xfrm>
+            <a:off x="5293323" y="2091000"/>
+            <a:ext cx="1319592" cy="430887"/>
+          </a:xfrm>
+          <a:prstGeom prst="rect">
+            <a:avLst/>
+          </a:prstGeom>
+          <a:noFill/>
+        </p:spPr>
+        <p:txBody>
+          <a:bodyPr wrap="none" rtlCol="0">
+            <a:spAutoFit/>
+          </a:bodyPr>
+          <a:lstStyle/>
+          <a:p>
+            <a:pPr algn="ctr"/>
+            <a:r>
+              <a:rPr lang="de-DE" sz="1100" i="1" dirty="0"/>
+              <a:t>(</a:t>
+            </a:r>
+            <a:r>
+              <a:rPr lang="de-DE" sz="1100" i="1" dirty="0" err="1"/>
+              <a:t>local</a:t>
+            </a:r>
+            <a:r>
+              <a:rPr lang="de-DE" sz="1100" i="1" dirty="0"/>
+              <a:t> </a:t>
+            </a:r>
+            <a:r>
+              <a:rPr lang="de-DE" sz="1100" i="1" dirty="0" err="1"/>
+              <a:t>username</a:t>
+            </a:r>
+            <a:r>
+              <a:rPr lang="de-DE" sz="1100" i="1" dirty="0"/>
+              <a:t> +</a:t>
+            </a:r>
+            <a:br>
+              <a:rPr lang="de-DE" sz="1100" i="1" dirty="0"/>
+            </a:br>
+            <a:r>
+              <a:rPr lang="de-DE" sz="1100" i="1" dirty="0" err="1"/>
+              <a:t>one</a:t>
+            </a:r>
+            <a:r>
+              <a:rPr lang="de-DE" sz="1100" i="1" dirty="0"/>
+              <a:t>-time </a:t>
+            </a:r>
+            <a:r>
+              <a:rPr lang="de-DE" sz="1100" i="1" dirty="0" err="1"/>
+              <a:t>password</a:t>
+            </a:r>
+            <a:r>
+              <a:rPr lang="de-DE" sz="1100" i="1" dirty="0"/>
+              <a:t>)</a:t>
+            </a:r>
+            <a:endParaRPr lang="en-GB" sz="1100" i="1" dirty="0"/>
+          </a:p>
+        </p:txBody>
+      </p:sp>
+      <p:sp>
+        <p:nvSpPr>
+          <p:cNvPr id="63" name="Textfeld 62">
+            <a:extLst>
+              <a:ext uri="{FF2B5EF4-FFF2-40B4-BE49-F238E27FC236}">
+                <a16:creationId xmlns:a16="http://schemas.microsoft.com/office/drawing/2014/main" id="{49613CA5-FFF9-4495-9CCF-0FA24873BD0E}"/>
+              </a:ext>
+            </a:extLst>
+          </p:cNvPr>
+          <p:cNvSpPr txBox="1"/>
+          <p:nvPr/>
+        </p:nvSpPr>
+        <p:spPr>
+          <a:xfrm>
+            <a:off x="3509186" y="4227838"/>
+            <a:ext cx="1362874" cy="261610"/>
+          </a:xfrm>
+          <a:prstGeom prst="rect">
+            <a:avLst/>
+          </a:prstGeom>
+          <a:noFill/>
+        </p:spPr>
+        <p:txBody>
+          <a:bodyPr wrap="none" rtlCol="0">
+            <a:spAutoFit/>
+          </a:bodyPr>
+          <a:lstStyle/>
+          <a:p>
+            <a:r>
+              <a:rPr lang="de-DE" sz="1100" i="1" dirty="0"/>
+              <a:t>(</a:t>
+            </a:r>
+            <a:r>
+              <a:rPr lang="de-DE" sz="1100" i="1" dirty="0" err="1"/>
+              <a:t>one</a:t>
+            </a:r>
+            <a:r>
+              <a:rPr lang="de-DE" sz="1100" i="1" dirty="0"/>
+              <a:t>-time </a:t>
+            </a:r>
+            <a:r>
+              <a:rPr lang="de-DE" sz="1100" i="1" dirty="0" err="1"/>
+              <a:t>password</a:t>
+            </a:r>
+            <a:r>
+              <a:rPr lang="de-DE" sz="1100" i="1" dirty="0"/>
+              <a:t>)</a:t>
+            </a:r>
+            <a:endParaRPr lang="en-GB" sz="1100" i="1" dirty="0"/>
+          </a:p>
+        </p:txBody>
+      </p:sp>
+      <p:sp>
+        <p:nvSpPr>
+          <p:cNvPr id="95" name="Ellipse 94">
+            <a:extLst>
+              <a:ext uri="{FF2B5EF4-FFF2-40B4-BE49-F238E27FC236}">
+                <a16:creationId xmlns:a16="http://schemas.microsoft.com/office/drawing/2014/main" id="{EDA49B51-AA97-4B64-9D72-C8D8B3A6DC44}"/>
+              </a:ext>
+            </a:extLst>
+          </p:cNvPr>
+          <p:cNvSpPr/>
+          <p:nvPr/>
+        </p:nvSpPr>
+        <p:spPr>
+          <a:xfrm>
+            <a:off x="4036525" y="3890060"/>
+            <a:ext cx="295324" cy="310219"/>
+          </a:xfrm>
+          <a:prstGeom prst="ellipse">
+            <a:avLst/>
+          </a:prstGeom>
+          <a:solidFill>
+            <a:srgbClr val="0070C0"/>
+          </a:solidFill>
+        </p:spPr>
+        <p:style>
+          <a:lnRef idx="2">
+            <a:schemeClr val="accent1">
+              <a:shade val="50000"/>
+            </a:schemeClr>
+          </a:lnRef>
+          <a:fillRef idx="1">
+            <a:schemeClr val="accent1"/>
+          </a:fillRef>
+          <a:effectRef idx="0">
+            <a:schemeClr val="accent1"/>
+          </a:effectRef>
+          <a:fontRef idx="minor">
+            <a:schemeClr val="lt1"/>
+          </a:fontRef>
+        </p:style>
+        <p:txBody>
+          <a:bodyPr rtlCol="0" anchor="ctr"/>
+          <a:lstStyle/>
+          <a:p>
+            <a:pPr algn="ctr"/>
+            <a:r>
+              <a:rPr lang="de-DE" sz="1600" b="1" dirty="0"/>
+              <a:t>3</a:t>
+            </a:r>
+            <a:endParaRPr lang="en-GB" sz="1600" b="1" dirty="0"/>
+          </a:p>
+        </p:txBody>
+      </p:sp>
       <p:cxnSp>
         <p:nvCxnSpPr>
-          <p:cNvPr id="56" name="Verbinder: gewinkelt 55">
+          <p:cNvPr id="69" name="Verbinder: gewinkelt 68">
             <a:extLst>
               <a:ext uri="{FF2B5EF4-FFF2-40B4-BE49-F238E27FC236}">
-                <a16:creationId xmlns:a16="http://schemas.microsoft.com/office/drawing/2014/main" id="{308495E1-C0DA-4CD7-A12E-A0A7A3E36BB4}"/>
+                <a16:creationId xmlns:a16="http://schemas.microsoft.com/office/drawing/2014/main" id="{13A89900-6C54-43E0-B77F-5E8E641DFEB1}"/>
               </a:ext>
             </a:extLst>
           </p:cNvPr>
           <p:cNvCxnSpPr>
             <a:cxnSpLocks/>
-            <a:stCxn id="98" idx="2"/>
-            <a:endCxn id="43" idx="1"/>
+            <a:stCxn id="100" idx="2"/>
+            <a:endCxn id="46" idx="1"/>
           </p:cNvCxnSpPr>
           <p:nvPr/>
         </p:nvCxnSpPr>
         <p:spPr>
           <a:xfrm rot="16200000" flipH="1">
-            <a:off x="4708217" y="2116306"/>
-            <a:ext cx="1312955" cy="2014272"/>
+            <a:off x="3674031" y="2427635"/>
+            <a:ext cx="656837" cy="5496709"/>
           </a:xfrm>
           <a:prstGeom prst="bentConnector2">
             <a:avLst/>
           </a:prstGeom>
-          <a:ln w="34925">
+          <a:ln w="25400">
+            <a:solidFill>
+              <a:srgbClr val="008000"/>
+            </a:solidFill>
             <a:prstDash val="sysDash"/>
             <a:tailEnd type="triangle"/>
           </a:ln>
@@ -3137,55 +4567,8 @@
         </p:nvCxnSpPr>
         <p:spPr>
           <a:xfrm rot="16200000" flipH="1">
-            <a:off x="3390458" y="2637877"/>
-            <a:ext cx="1052954" cy="5087686"/>
-          </a:xfrm>
-          <a:prstGeom prst="bentConnector2">
-            <a:avLst/>
-          </a:prstGeom>
-          <a:ln w="25400">
-            <a:solidFill>
-              <a:srgbClr val="008000"/>
-            </a:solidFill>
-            <a:prstDash val="sysDash"/>
-            <a:tailEnd type="triangle"/>
-          </a:ln>
-        </p:spPr>
-        <p:style>
-          <a:lnRef idx="1">
-            <a:schemeClr val="accent1"/>
-          </a:lnRef>
-          <a:fillRef idx="0">
-            <a:schemeClr val="accent1"/>
-          </a:fillRef>
-          <a:effectRef idx="0">
-            <a:schemeClr val="accent1"/>
-          </a:effectRef>
-          <a:fontRef idx="minor">
-            <a:schemeClr val="tx1"/>
-          </a:fontRef>
-        </p:style>
-      </p:cxnSp>
-      <p:cxnSp>
-        <p:nvCxnSpPr>
-          <p:cNvPr id="69" name="Verbinder: gewinkelt 68">
-            <a:extLst>
-              <a:ext uri="{FF2B5EF4-FFF2-40B4-BE49-F238E27FC236}">
-                <a16:creationId xmlns:a16="http://schemas.microsoft.com/office/drawing/2014/main" id="{13A89900-6C54-43E0-B77F-5E8E641DFEB1}"/>
-              </a:ext>
-            </a:extLst>
-          </p:cNvPr>
-          <p:cNvCxnSpPr>
-            <a:cxnSpLocks/>
-            <a:stCxn id="100" idx="2"/>
-            <a:endCxn id="46" idx="1"/>
-          </p:cNvCxnSpPr>
-          <p:nvPr/>
-        </p:nvCxnSpPr>
-        <p:spPr>
-          <a:xfrm rot="16200000" flipH="1">
-            <a:off x="3413111" y="2615224"/>
-            <a:ext cx="921895" cy="5001932"/>
+            <a:off x="3655176" y="2446490"/>
+            <a:ext cx="759850" cy="5562013"/>
           </a:xfrm>
           <a:prstGeom prst="bentConnector2">
             <a:avLst/>
@@ -3231,8 +4614,8 @@
         </p:nvCxnSpPr>
         <p:spPr>
           <a:xfrm rot="16200000" flipH="1">
-            <a:off x="3429635" y="2598699"/>
-            <a:ext cx="790841" cy="4903927"/>
+            <a:off x="3693687" y="2407979"/>
+            <a:ext cx="563361" cy="5442545"/>
           </a:xfrm>
           <a:prstGeom prst="bentConnector2">
             <a:avLst/>
@@ -3263,219 +4646,10 @@
       </p:cxnSp>
       <p:sp>
         <p:nvSpPr>
-          <p:cNvPr id="83" name="Textfeld 82">
+          <p:cNvPr id="96" name="Ellipse 95">
             <a:extLst>
               <a:ext uri="{FF2B5EF4-FFF2-40B4-BE49-F238E27FC236}">
-                <a16:creationId xmlns:a16="http://schemas.microsoft.com/office/drawing/2014/main" id="{26D14A21-0B88-43DA-B0E1-0EBC713B37C8}"/>
-              </a:ext>
-            </a:extLst>
-          </p:cNvPr>
-          <p:cNvSpPr txBox="1"/>
-          <p:nvPr/>
-        </p:nvSpPr>
-        <p:spPr>
-          <a:xfrm>
-            <a:off x="1495634" y="1584896"/>
-            <a:ext cx="1907573" cy="307777"/>
-          </a:xfrm>
-          <a:prstGeom prst="rect">
-            <a:avLst/>
-          </a:prstGeom>
-          <a:noFill/>
-        </p:spPr>
-        <p:txBody>
-          <a:bodyPr wrap="none" rtlCol="0">
-            <a:spAutoFit/>
-          </a:bodyPr>
-          <a:lstStyle/>
-          <a:p>
-            <a:r>
-              <a:rPr lang="de-DE" sz="1400" b="1" dirty="0">
-                <a:solidFill>
-                  <a:srgbClr val="0070C0"/>
-                </a:solidFill>
-              </a:rPr>
-              <a:t>Authentication </a:t>
-            </a:r>
-            <a:r>
-              <a:rPr lang="de-DE" sz="1400" b="1" dirty="0" err="1">
-                <a:solidFill>
-                  <a:srgbClr val="0070C0"/>
-                </a:solidFill>
-              </a:rPr>
-              <a:t>request</a:t>
-            </a:r>
-            <a:endParaRPr lang="en-GB" sz="1400" b="1" dirty="0">
-              <a:solidFill>
-                <a:srgbClr val="0070C0"/>
-              </a:solidFill>
-            </a:endParaRPr>
-          </a:p>
-        </p:txBody>
-      </p:sp>
-      <p:sp>
-        <p:nvSpPr>
-          <p:cNvPr id="84" name="Textfeld 83">
-            <a:extLst>
-              <a:ext uri="{FF2B5EF4-FFF2-40B4-BE49-F238E27FC236}">
-                <a16:creationId xmlns:a16="http://schemas.microsoft.com/office/drawing/2014/main" id="{AECF1D1C-A345-4401-A4DD-555EA94B4EFA}"/>
-              </a:ext>
-            </a:extLst>
-          </p:cNvPr>
-          <p:cNvSpPr txBox="1"/>
-          <p:nvPr/>
-        </p:nvSpPr>
-        <p:spPr>
-          <a:xfrm>
-            <a:off x="4574428" y="2906957"/>
-            <a:ext cx="1698735" cy="307777"/>
-          </a:xfrm>
-          <a:prstGeom prst="rect">
-            <a:avLst/>
-          </a:prstGeom>
-          <a:noFill/>
-        </p:spPr>
-        <p:txBody>
-          <a:bodyPr wrap="none" rtlCol="0">
-            <a:spAutoFit/>
-          </a:bodyPr>
-          <a:lstStyle/>
-          <a:p>
-            <a:r>
-              <a:rPr lang="de-DE" sz="1400" b="1" dirty="0" err="1">
-                <a:solidFill>
-                  <a:srgbClr val="0070C0"/>
-                </a:solidFill>
-              </a:rPr>
-              <a:t>Prepare</a:t>
-            </a:r>
-            <a:r>
-              <a:rPr lang="de-DE" sz="1400" b="1" dirty="0">
-                <a:solidFill>
-                  <a:srgbClr val="0070C0"/>
-                </a:solidFill>
-              </a:rPr>
-              <a:t> FTP </a:t>
-            </a:r>
-            <a:r>
-              <a:rPr lang="de-DE" sz="1400" b="1" dirty="0" err="1">
-                <a:solidFill>
-                  <a:srgbClr val="0070C0"/>
-                </a:solidFill>
-              </a:rPr>
-              <a:t>session</a:t>
-            </a:r>
-            <a:r>
-              <a:rPr lang="de-DE" sz="1400" b="1" dirty="0">
-                <a:solidFill>
-                  <a:srgbClr val="0070C0"/>
-                </a:solidFill>
-              </a:rPr>
-              <a:t> </a:t>
-            </a:r>
-            <a:endParaRPr lang="en-GB" sz="1400" b="1" dirty="0">
-              <a:solidFill>
-                <a:srgbClr val="0070C0"/>
-              </a:solidFill>
-            </a:endParaRPr>
-          </a:p>
-        </p:txBody>
-      </p:sp>
-      <p:sp>
-        <p:nvSpPr>
-          <p:cNvPr id="85" name="Textfeld 84">
-            <a:extLst>
-              <a:ext uri="{FF2B5EF4-FFF2-40B4-BE49-F238E27FC236}">
-                <a16:creationId xmlns:a16="http://schemas.microsoft.com/office/drawing/2014/main" id="{A6A3D902-927E-448F-A1B0-BA89FCD59360}"/>
-              </a:ext>
-            </a:extLst>
-          </p:cNvPr>
-          <p:cNvSpPr txBox="1"/>
-          <p:nvPr/>
-        </p:nvSpPr>
-        <p:spPr>
-          <a:xfrm>
-            <a:off x="3475262" y="4031996"/>
-            <a:ext cx="1929695" cy="307777"/>
-          </a:xfrm>
-          <a:prstGeom prst="rect">
-            <a:avLst/>
-          </a:prstGeom>
-          <a:noFill/>
-        </p:spPr>
-        <p:txBody>
-          <a:bodyPr wrap="none" rtlCol="0">
-            <a:spAutoFit/>
-          </a:bodyPr>
-          <a:lstStyle/>
-          <a:p>
-            <a:r>
-              <a:rPr lang="de-DE" sz="1400" b="1" dirty="0">
-                <a:solidFill>
-                  <a:srgbClr val="0070C0"/>
-                </a:solidFill>
-              </a:rPr>
-              <a:t>FTP Control Connection</a:t>
-            </a:r>
-            <a:endParaRPr lang="en-GB" sz="1400" b="1" dirty="0">
-              <a:solidFill>
-                <a:srgbClr val="0070C0"/>
-              </a:solidFill>
-            </a:endParaRPr>
-          </a:p>
-        </p:txBody>
-      </p:sp>
-      <p:sp>
-        <p:nvSpPr>
-          <p:cNvPr id="86" name="Textfeld 85">
-            <a:extLst>
-              <a:ext uri="{FF2B5EF4-FFF2-40B4-BE49-F238E27FC236}">
-                <a16:creationId xmlns:a16="http://schemas.microsoft.com/office/drawing/2014/main" id="{0B57E1AD-EEB3-4F8C-8A56-7AB9D000514C}"/>
-              </a:ext>
-            </a:extLst>
-          </p:cNvPr>
-          <p:cNvSpPr txBox="1"/>
-          <p:nvPr/>
-        </p:nvSpPr>
-        <p:spPr>
-          <a:xfrm>
-            <a:off x="1549086" y="5023927"/>
-            <a:ext cx="2383409" cy="307777"/>
-          </a:xfrm>
-          <a:prstGeom prst="rect">
-            <a:avLst/>
-          </a:prstGeom>
-          <a:noFill/>
-        </p:spPr>
-        <p:txBody>
-          <a:bodyPr wrap="none" rtlCol="0">
-            <a:spAutoFit/>
-          </a:bodyPr>
-          <a:lstStyle/>
-          <a:p>
-            <a:pPr algn="ctr"/>
-            <a:r>
-              <a:rPr lang="de-DE" sz="1400" b="1" dirty="0">
-                <a:solidFill>
-                  <a:srgbClr val="008000"/>
-                </a:solidFill>
-              </a:rPr>
-              <a:t>Passive FTP Data Connections</a:t>
-            </a:r>
-            <a:endParaRPr lang="en-GB" sz="1400" b="1" dirty="0">
-              <a:solidFill>
-                <a:srgbClr val="008000"/>
-              </a:solidFill>
-            </a:endParaRPr>
-          </a:p>
-        </p:txBody>
-      </p:sp>
-      <p:sp>
-        <p:nvSpPr>
-          <p:cNvPr id="87" name="Ellipse 86">
-            <a:extLst>
-              <a:ext uri="{FF2B5EF4-FFF2-40B4-BE49-F238E27FC236}">
-                <a16:creationId xmlns:a16="http://schemas.microsoft.com/office/drawing/2014/main" id="{C7ED80CB-00A2-4FC7-80B1-852CEF67B7FB}"/>
+                <a16:creationId xmlns:a16="http://schemas.microsoft.com/office/drawing/2014/main" id="{94ED6BBD-B25A-42AA-9367-3C6FEAA6EEF8}"/>
               </a:ext>
             </a:extLst>
           </p:cNvPr>
@@ -3484,12 +4658,15 @@
         </p:nvSpPr>
         <p:spPr>
           <a:xfrm>
-            <a:off x="1209211" y="1726429"/>
+            <a:off x="4019789" y="5351921"/>
             <a:ext cx="295324" cy="310219"/>
           </a:xfrm>
           <a:prstGeom prst="ellipse">
             <a:avLst/>
           </a:prstGeom>
+          <a:solidFill>
+            <a:srgbClr val="00B050"/>
+          </a:solidFill>
         </p:spPr>
         <p:style>
           <a:lnRef idx="2">
@@ -3514,12 +4691,56 @@
             <a:pPr algn="ctr"/>
             <a:r>
               <a:rPr lang="de-DE" sz="1600" b="1" dirty="0"/>
-              <a:t>1</a:t>
+              <a:t>4</a:t>
             </a:r>
             <a:endParaRPr lang="en-GB" sz="1600" b="1" dirty="0"/>
           </a:p>
         </p:txBody>
       </p:sp>
+      <p:cxnSp>
+        <p:nvCxnSpPr>
+          <p:cNvPr id="75" name="Gerade Verbindung mit Pfeil 74">
+            <a:extLst>
+              <a:ext uri="{FF2B5EF4-FFF2-40B4-BE49-F238E27FC236}">
+                <a16:creationId xmlns:a16="http://schemas.microsoft.com/office/drawing/2014/main" id="{E04BBB39-2302-4A83-A3C0-BDADBFD902D5}"/>
+              </a:ext>
+            </a:extLst>
+          </p:cNvPr>
+          <p:cNvCxnSpPr>
+            <a:cxnSpLocks/>
+            <a:stCxn id="98" idx="3"/>
+            <a:endCxn id="43" idx="1"/>
+          </p:cNvCxnSpPr>
+          <p:nvPr/>
+        </p:nvCxnSpPr>
+        <p:spPr>
+          <a:xfrm>
+            <a:off x="5071941" y="1890198"/>
+            <a:ext cx="1700486" cy="15088"/>
+          </a:xfrm>
+          <a:prstGeom prst="straightConnector1">
+            <a:avLst/>
+          </a:prstGeom>
+          <a:ln w="25400">
+            <a:prstDash val="sysDash"/>
+            <a:tailEnd type="triangle"/>
+          </a:ln>
+        </p:spPr>
+        <p:style>
+          <a:lnRef idx="1">
+            <a:schemeClr val="accent1"/>
+          </a:lnRef>
+          <a:fillRef idx="0">
+            <a:schemeClr val="accent1"/>
+          </a:fillRef>
+          <a:effectRef idx="0">
+            <a:schemeClr val="accent1"/>
+          </a:effectRef>
+          <a:fontRef idx="minor">
+            <a:schemeClr val="tx1"/>
+          </a:fontRef>
+        </p:style>
+      </p:cxnSp>
       <p:sp>
         <p:nvSpPr>
           <p:cNvPr id="89" name="Ellipse 88">
@@ -3534,12 +4755,15 @@
         </p:nvSpPr>
         <p:spPr>
           <a:xfrm>
-            <a:off x="4211825" y="3004627"/>
+            <a:off x="5805644" y="1757753"/>
             <a:ext cx="295324" cy="310219"/>
           </a:xfrm>
           <a:prstGeom prst="ellipse">
             <a:avLst/>
           </a:prstGeom>
+          <a:solidFill>
+            <a:srgbClr val="00B0F0"/>
+          </a:solidFill>
         </p:spPr>
         <p:style>
           <a:lnRef idx="2">
@@ -3565,1531 +4789,6 @@
             <a:r>
               <a:rPr lang="de-DE" sz="1600" b="1" dirty="0"/>
               <a:t>2</a:t>
-            </a:r>
-            <a:endParaRPr lang="en-GB" sz="1600" b="1" dirty="0"/>
-          </a:p>
-        </p:txBody>
-      </p:sp>
-      <p:sp>
-        <p:nvSpPr>
-          <p:cNvPr id="96" name="Ellipse 95">
-            <a:extLst>
-              <a:ext uri="{FF2B5EF4-FFF2-40B4-BE49-F238E27FC236}">
-                <a16:creationId xmlns:a16="http://schemas.microsoft.com/office/drawing/2014/main" id="{94ED6BBD-B25A-42AA-9367-3C6FEAA6EEF8}"/>
-              </a:ext>
-            </a:extLst>
-          </p:cNvPr>
-          <p:cNvSpPr/>
-          <p:nvPr/>
-        </p:nvSpPr>
-        <p:spPr>
-          <a:xfrm>
-            <a:off x="1225429" y="4990151"/>
-            <a:ext cx="295324" cy="310219"/>
-          </a:xfrm>
-          <a:prstGeom prst="ellipse">
-            <a:avLst/>
-          </a:prstGeom>
-          <a:solidFill>
-            <a:srgbClr val="008000"/>
-          </a:solidFill>
-        </p:spPr>
-        <p:style>
-          <a:lnRef idx="2">
-            <a:schemeClr val="accent1">
-              <a:shade val="50000"/>
-            </a:schemeClr>
-          </a:lnRef>
-          <a:fillRef idx="1">
-            <a:schemeClr val="accent1"/>
-          </a:fillRef>
-          <a:effectRef idx="0">
-            <a:schemeClr val="accent1"/>
-          </a:effectRef>
-          <a:fontRef idx="minor">
-            <a:schemeClr val="lt1"/>
-          </a:fontRef>
-        </p:style>
-        <p:txBody>
-          <a:bodyPr rtlCol="0" anchor="ctr"/>
-          <a:lstStyle/>
-          <a:p>
-            <a:pPr algn="ctr"/>
-            <a:r>
-              <a:rPr lang="de-DE" sz="1600" b="1" dirty="0"/>
-              <a:t>4</a:t>
-            </a:r>
-            <a:endParaRPr lang="en-GB" sz="1600" b="1" dirty="0"/>
-          </a:p>
-        </p:txBody>
-      </p:sp>
-      <p:sp>
-        <p:nvSpPr>
-          <p:cNvPr id="98" name="Rechteck: abgerundete Ecken 97">
-            <a:extLst>
-              <a:ext uri="{FF2B5EF4-FFF2-40B4-BE49-F238E27FC236}">
-                <a16:creationId xmlns:a16="http://schemas.microsoft.com/office/drawing/2014/main" id="{A51B0A78-7D82-42A1-BE29-97A41F65A540}"/>
-              </a:ext>
-            </a:extLst>
-          </p:cNvPr>
-          <p:cNvSpPr/>
-          <p:nvPr/>
-        </p:nvSpPr>
-        <p:spPr>
-          <a:xfrm>
-            <a:off x="3386391" y="323876"/>
-            <a:ext cx="1942333" cy="2143089"/>
-          </a:xfrm>
-          <a:prstGeom prst="roundRect">
-            <a:avLst/>
-          </a:prstGeom>
-          <a:noFill/>
-          <a:ln w="19050">
-            <a:solidFill>
-              <a:srgbClr val="0070C0"/>
-            </a:solidFill>
-          </a:ln>
-        </p:spPr>
-        <p:style>
-          <a:lnRef idx="2">
-            <a:schemeClr val="accent1">
-              <a:shade val="50000"/>
-            </a:schemeClr>
-          </a:lnRef>
-          <a:fillRef idx="1">
-            <a:schemeClr val="accent1"/>
-          </a:fillRef>
-          <a:effectRef idx="0">
-            <a:schemeClr val="accent1"/>
-          </a:effectRef>
-          <a:fontRef idx="minor">
-            <a:schemeClr val="lt1"/>
-          </a:fontRef>
-        </p:style>
-        <p:txBody>
-          <a:bodyPr rtlCol="0" anchor="ctr"/>
-          <a:lstStyle/>
-          <a:p>
-            <a:pPr algn="ctr"/>
-            <a:endParaRPr lang="en-GB" sz="1350"/>
-          </a:p>
-        </p:txBody>
-      </p:sp>
-      <p:sp>
-        <p:nvSpPr>
-          <p:cNvPr id="39" name="Textfeld 38">
-            <a:extLst>
-              <a:ext uri="{FF2B5EF4-FFF2-40B4-BE49-F238E27FC236}">
-                <a16:creationId xmlns:a16="http://schemas.microsoft.com/office/drawing/2014/main" id="{A191F60E-7B25-4957-8278-5EBD374A961A}"/>
-              </a:ext>
-            </a:extLst>
-          </p:cNvPr>
-          <p:cNvSpPr txBox="1"/>
-          <p:nvPr/>
-        </p:nvSpPr>
-        <p:spPr>
-          <a:xfrm>
-            <a:off x="494261" y="3017366"/>
-            <a:ext cx="1848519" cy="615553"/>
-          </a:xfrm>
-          <a:prstGeom prst="rect">
-            <a:avLst/>
-          </a:prstGeom>
-          <a:noFill/>
-        </p:spPr>
-        <p:txBody>
-          <a:bodyPr wrap="none" rtlCol="0">
-            <a:spAutoFit/>
-          </a:bodyPr>
-          <a:lstStyle/>
-          <a:p>
-            <a:pPr algn="ctr"/>
-            <a:r>
-              <a:rPr lang="de-DE" b="1" dirty="0"/>
-              <a:t>UFTP </a:t>
-            </a:r>
-            <a:r>
-              <a:rPr lang="de-DE" b="1" dirty="0" err="1"/>
-              <a:t>Cient</a:t>
-            </a:r>
-            <a:br>
-              <a:rPr lang="de-DE" sz="1600" dirty="0"/>
-            </a:br>
-            <a:r>
-              <a:rPr lang="de-DE" sz="1600" dirty="0"/>
-              <a:t>(end-user </a:t>
-            </a:r>
-            <a:r>
-              <a:rPr lang="de-DE" sz="1600" dirty="0" err="1"/>
-              <a:t>or</a:t>
-            </a:r>
-            <a:r>
-              <a:rPr lang="de-DE" sz="1600" dirty="0"/>
-              <a:t> </a:t>
-            </a:r>
-            <a:r>
-              <a:rPr lang="de-DE" sz="1600" dirty="0" err="1"/>
-              <a:t>server</a:t>
-            </a:r>
-            <a:r>
-              <a:rPr lang="de-DE" sz="1600" dirty="0"/>
-              <a:t>)</a:t>
-            </a:r>
-            <a:endParaRPr lang="en-GB" sz="1600" dirty="0"/>
-          </a:p>
-        </p:txBody>
-      </p:sp>
-      <p:sp>
-        <p:nvSpPr>
-          <p:cNvPr id="100" name="Rechteck: abgerundete Ecken 99">
-            <a:extLst>
-              <a:ext uri="{FF2B5EF4-FFF2-40B4-BE49-F238E27FC236}">
-                <a16:creationId xmlns:a16="http://schemas.microsoft.com/office/drawing/2014/main" id="{EB8AFB6D-3B50-4048-BE43-6F9F4E11FDB3}"/>
-              </a:ext>
-            </a:extLst>
-          </p:cNvPr>
-          <p:cNvSpPr/>
-          <p:nvPr/>
-        </p:nvSpPr>
-        <p:spPr>
-          <a:xfrm>
-            <a:off x="390837" y="2857533"/>
-            <a:ext cx="1964510" cy="1797710"/>
-          </a:xfrm>
-          <a:prstGeom prst="roundRect">
-            <a:avLst/>
-          </a:prstGeom>
-          <a:noFill/>
-          <a:ln w="19050">
-            <a:solidFill>
-              <a:srgbClr val="0070C0"/>
-            </a:solidFill>
-          </a:ln>
-        </p:spPr>
-        <p:style>
-          <a:lnRef idx="2">
-            <a:schemeClr val="accent1">
-              <a:shade val="50000"/>
-            </a:schemeClr>
-          </a:lnRef>
-          <a:fillRef idx="1">
-            <a:schemeClr val="accent1"/>
-          </a:fillRef>
-          <a:effectRef idx="0">
-            <a:schemeClr val="accent1"/>
-          </a:effectRef>
-          <a:fontRef idx="minor">
-            <a:schemeClr val="lt1"/>
-          </a:fontRef>
-        </p:style>
-        <p:txBody>
-          <a:bodyPr rtlCol="0" anchor="ctr"/>
-          <a:lstStyle/>
-          <a:p>
-            <a:pPr algn="ctr"/>
-            <a:endParaRPr lang="en-GB" sz="1350"/>
-          </a:p>
-        </p:txBody>
-      </p:sp>
-      <p:grpSp>
-        <p:nvGrpSpPr>
-          <p:cNvPr id="130" name="Gruppieren 129">
-            <a:extLst>
-              <a:ext uri="{FF2B5EF4-FFF2-40B4-BE49-F238E27FC236}">
-                <a16:creationId xmlns:a16="http://schemas.microsoft.com/office/drawing/2014/main" id="{09841C67-8BDA-4624-BFA8-733F6B389752}"/>
-              </a:ext>
-            </a:extLst>
-          </p:cNvPr>
-          <p:cNvGrpSpPr/>
-          <p:nvPr/>
-        </p:nvGrpSpPr>
-        <p:grpSpPr>
-          <a:xfrm>
-            <a:off x="6693352" y="305336"/>
-            <a:ext cx="1525386" cy="904002"/>
-            <a:chOff x="1111447" y="961185"/>
-            <a:chExt cx="1293803" cy="741859"/>
-          </a:xfrm>
-        </p:grpSpPr>
-        <p:sp>
-          <p:nvSpPr>
-            <p:cNvPr id="102" name="Rechteck 101">
-              <a:extLst>
-                <a:ext uri="{FF2B5EF4-FFF2-40B4-BE49-F238E27FC236}">
-                  <a16:creationId xmlns:a16="http://schemas.microsoft.com/office/drawing/2014/main" id="{DCF18ED4-3E75-4165-8531-9C8FCD19EE89}"/>
-                </a:ext>
-              </a:extLst>
-            </p:cNvPr>
-            <p:cNvSpPr/>
-            <p:nvPr/>
-          </p:nvSpPr>
-          <p:spPr>
-            <a:xfrm>
-              <a:off x="1111447" y="961185"/>
-              <a:ext cx="1251993" cy="741859"/>
-            </a:xfrm>
-            <a:prstGeom prst="rect">
-              <a:avLst/>
-            </a:prstGeom>
-            <a:noFill/>
-          </p:spPr>
-          <p:style>
-            <a:lnRef idx="2">
-              <a:schemeClr val="accent1">
-                <a:shade val="50000"/>
-              </a:schemeClr>
-            </a:lnRef>
-            <a:fillRef idx="1">
-              <a:schemeClr val="accent1"/>
-            </a:fillRef>
-            <a:effectRef idx="0">
-              <a:schemeClr val="accent1"/>
-            </a:effectRef>
-            <a:fontRef idx="minor">
-              <a:schemeClr val="lt1"/>
-            </a:fontRef>
-          </p:style>
-          <p:txBody>
-            <a:bodyPr rtlCol="0" anchor="ctr"/>
-            <a:lstStyle/>
-            <a:p>
-              <a:pPr algn="ctr"/>
-              <a:endParaRPr lang="en-GB" sz="1350"/>
-            </a:p>
-          </p:txBody>
-        </p:sp>
-        <p:cxnSp>
-          <p:nvCxnSpPr>
-            <p:cNvPr id="104" name="Gerader Verbinder 103">
-              <a:extLst>
-                <a:ext uri="{FF2B5EF4-FFF2-40B4-BE49-F238E27FC236}">
-                  <a16:creationId xmlns:a16="http://schemas.microsoft.com/office/drawing/2014/main" id="{484743F3-0D4C-4DD1-86AE-B08A2CD142D4}"/>
-                </a:ext>
-              </a:extLst>
-            </p:cNvPr>
-            <p:cNvCxnSpPr>
-              <a:cxnSpLocks/>
-            </p:cNvCxnSpPr>
-            <p:nvPr/>
-          </p:nvCxnSpPr>
-          <p:spPr>
-            <a:xfrm flipV="1">
-              <a:off x="1232046" y="1321597"/>
-              <a:ext cx="309635" cy="5142"/>
-            </a:xfrm>
-            <a:prstGeom prst="line">
-              <a:avLst/>
-            </a:prstGeom>
-            <a:ln w="25400"/>
-          </p:spPr>
-          <p:style>
-            <a:lnRef idx="1">
-              <a:schemeClr val="accent1"/>
-            </a:lnRef>
-            <a:fillRef idx="0">
-              <a:schemeClr val="accent1"/>
-            </a:fillRef>
-            <a:effectRef idx="0">
-              <a:schemeClr val="accent1"/>
-            </a:effectRef>
-            <a:fontRef idx="minor">
-              <a:schemeClr val="tx1"/>
-            </a:fontRef>
-          </p:style>
-        </p:cxnSp>
-        <p:sp>
-          <p:nvSpPr>
-            <p:cNvPr id="105" name="Textfeld 104">
-              <a:extLst>
-                <a:ext uri="{FF2B5EF4-FFF2-40B4-BE49-F238E27FC236}">
-                  <a16:creationId xmlns:a16="http://schemas.microsoft.com/office/drawing/2014/main" id="{A9BD19B9-0B08-478D-8009-EB2310A41156}"/>
-                </a:ext>
-              </a:extLst>
-            </p:cNvPr>
-            <p:cNvSpPr txBox="1"/>
-            <p:nvPr/>
-          </p:nvSpPr>
-          <p:spPr>
-            <a:xfrm>
-              <a:off x="1150859" y="976400"/>
-              <a:ext cx="740908" cy="252574"/>
-            </a:xfrm>
-            <a:prstGeom prst="rect">
-              <a:avLst/>
-            </a:prstGeom>
-            <a:noFill/>
-          </p:spPr>
-          <p:txBody>
-            <a:bodyPr wrap="square" rtlCol="0">
-              <a:spAutoFit/>
-            </a:bodyPr>
-            <a:lstStyle/>
-            <a:p>
-              <a:pPr algn="ctr"/>
-              <a:r>
-                <a:rPr lang="de-DE" sz="1400" b="1" dirty="0"/>
-                <a:t>Legend</a:t>
-              </a:r>
-              <a:endParaRPr lang="en-GB" sz="1100" dirty="0"/>
-            </a:p>
-          </p:txBody>
-        </p:sp>
-        <p:cxnSp>
-          <p:nvCxnSpPr>
-            <p:cNvPr id="106" name="Gerader Verbinder 105">
-              <a:extLst>
-                <a:ext uri="{FF2B5EF4-FFF2-40B4-BE49-F238E27FC236}">
-                  <a16:creationId xmlns:a16="http://schemas.microsoft.com/office/drawing/2014/main" id="{D8096E60-956D-4C45-BE45-B3C1B64C2E82}"/>
-                </a:ext>
-              </a:extLst>
-            </p:cNvPr>
-            <p:cNvCxnSpPr>
-              <a:cxnSpLocks/>
-            </p:cNvCxnSpPr>
-            <p:nvPr/>
-          </p:nvCxnSpPr>
-          <p:spPr>
-            <a:xfrm flipV="1">
-              <a:off x="1238475" y="1544925"/>
-              <a:ext cx="309635" cy="5142"/>
-            </a:xfrm>
-            <a:prstGeom prst="line">
-              <a:avLst/>
-            </a:prstGeom>
-            <a:ln w="25400">
-              <a:solidFill>
-                <a:srgbClr val="008000"/>
-              </a:solidFill>
-              <a:prstDash val="sysDash"/>
-            </a:ln>
-          </p:spPr>
-          <p:style>
-            <a:lnRef idx="1">
-              <a:schemeClr val="accent1"/>
-            </a:lnRef>
-            <a:fillRef idx="0">
-              <a:schemeClr val="accent1"/>
-            </a:fillRef>
-            <a:effectRef idx="0">
-              <a:schemeClr val="accent1"/>
-            </a:effectRef>
-            <a:fontRef idx="minor">
-              <a:schemeClr val="tx1"/>
-            </a:fontRef>
-          </p:style>
-        </p:cxnSp>
-        <p:sp>
-          <p:nvSpPr>
-            <p:cNvPr id="111" name="Textfeld 110">
-              <a:extLst>
-                <a:ext uri="{FF2B5EF4-FFF2-40B4-BE49-F238E27FC236}">
-                  <a16:creationId xmlns:a16="http://schemas.microsoft.com/office/drawing/2014/main" id="{194DC1A1-72A6-49E1-8718-4856689E1A30}"/>
-                </a:ext>
-              </a:extLst>
-            </p:cNvPr>
-            <p:cNvSpPr txBox="1"/>
-            <p:nvPr/>
-          </p:nvSpPr>
-          <p:spPr>
-            <a:xfrm>
-              <a:off x="1515263" y="1209157"/>
-              <a:ext cx="889987" cy="227316"/>
-            </a:xfrm>
-            <a:prstGeom prst="rect">
-              <a:avLst/>
-            </a:prstGeom>
-            <a:noFill/>
-          </p:spPr>
-          <p:txBody>
-            <a:bodyPr wrap="square" rtlCol="0">
-              <a:spAutoFit/>
-            </a:bodyPr>
-            <a:lstStyle/>
-            <a:p>
-              <a:r>
-                <a:rPr lang="de-DE" sz="1200" dirty="0">
-                  <a:solidFill>
-                    <a:srgbClr val="0070C0"/>
-                  </a:solidFill>
-                </a:rPr>
-                <a:t>Control </a:t>
-              </a:r>
-              <a:r>
-                <a:rPr lang="de-DE" sz="1200" dirty="0" err="1">
-                  <a:solidFill>
-                    <a:srgbClr val="0070C0"/>
-                  </a:solidFill>
-                </a:rPr>
-                <a:t>flow</a:t>
-              </a:r>
-              <a:r>
-                <a:rPr lang="de-DE" sz="1200" dirty="0">
-                  <a:solidFill>
-                    <a:srgbClr val="0070C0"/>
-                  </a:solidFill>
-                </a:rPr>
-                <a:t> </a:t>
-              </a:r>
-              <a:endParaRPr lang="en-GB" sz="1200" dirty="0">
-                <a:solidFill>
-                  <a:srgbClr val="0070C0"/>
-                </a:solidFill>
-              </a:endParaRPr>
-            </a:p>
-          </p:txBody>
-        </p:sp>
-        <p:sp>
-          <p:nvSpPr>
-            <p:cNvPr id="112" name="Textfeld 111">
-              <a:extLst>
-                <a:ext uri="{FF2B5EF4-FFF2-40B4-BE49-F238E27FC236}">
-                  <a16:creationId xmlns:a16="http://schemas.microsoft.com/office/drawing/2014/main" id="{CE18E5CA-AB8A-4145-889E-FD209395C113}"/>
-                </a:ext>
-              </a:extLst>
-            </p:cNvPr>
-            <p:cNvSpPr txBox="1"/>
-            <p:nvPr/>
-          </p:nvSpPr>
-          <p:spPr>
-            <a:xfrm>
-              <a:off x="1522437" y="1408178"/>
-              <a:ext cx="740908" cy="227316"/>
-            </a:xfrm>
-            <a:prstGeom prst="rect">
-              <a:avLst/>
-            </a:prstGeom>
-            <a:noFill/>
-          </p:spPr>
-          <p:txBody>
-            <a:bodyPr wrap="square" rtlCol="0">
-              <a:spAutoFit/>
-            </a:bodyPr>
-            <a:lstStyle/>
-            <a:p>
-              <a:r>
-                <a:rPr lang="de-DE" sz="1200" dirty="0">
-                  <a:solidFill>
-                    <a:srgbClr val="008000"/>
-                  </a:solidFill>
-                </a:rPr>
-                <a:t>Data </a:t>
-              </a:r>
-              <a:r>
-                <a:rPr lang="de-DE" sz="1200" dirty="0" err="1">
-                  <a:solidFill>
-                    <a:srgbClr val="008000"/>
-                  </a:solidFill>
-                </a:rPr>
-                <a:t>flow</a:t>
-              </a:r>
-              <a:r>
-                <a:rPr lang="de-DE" sz="1200" dirty="0">
-                  <a:solidFill>
-                    <a:srgbClr val="008000"/>
-                  </a:solidFill>
-                </a:rPr>
-                <a:t> </a:t>
-              </a:r>
-              <a:endParaRPr lang="en-GB" sz="1200" dirty="0">
-                <a:solidFill>
-                  <a:srgbClr val="008000"/>
-                </a:solidFill>
-              </a:endParaRPr>
-            </a:p>
-          </p:txBody>
-        </p:sp>
-      </p:grpSp>
-      <p:pic>
-        <p:nvPicPr>
-          <p:cNvPr id="92" name="Grafik 91">
-            <a:extLst>
-              <a:ext uri="{FF2B5EF4-FFF2-40B4-BE49-F238E27FC236}">
-                <a16:creationId xmlns:a16="http://schemas.microsoft.com/office/drawing/2014/main" id="{4C6E8205-1EB3-4D55-8B7E-DEC4A1C77CE5}"/>
-              </a:ext>
-            </a:extLst>
-          </p:cNvPr>
-          <p:cNvPicPr>
-            <a:picLocks noChangeAspect="1"/>
-          </p:cNvPicPr>
-          <p:nvPr/>
-        </p:nvPicPr>
-        <p:blipFill>
-          <a:blip r:embed="rId2"/>
-          <a:stretch>
-            <a:fillRect/>
-          </a:stretch>
-        </p:blipFill>
-        <p:spPr>
-          <a:xfrm>
-            <a:off x="911468" y="3631372"/>
-            <a:ext cx="868048" cy="663135"/>
-          </a:xfrm>
-          <a:prstGeom prst="rect">
-            <a:avLst/>
-          </a:prstGeom>
-        </p:spPr>
-      </p:pic>
-      <p:pic>
-        <p:nvPicPr>
-          <p:cNvPr id="93" name="Grafik 92">
-            <a:extLst>
-              <a:ext uri="{FF2B5EF4-FFF2-40B4-BE49-F238E27FC236}">
-                <a16:creationId xmlns:a16="http://schemas.microsoft.com/office/drawing/2014/main" id="{F6E4E32B-B04E-47A2-BEC6-C66A939BEAC4}"/>
-              </a:ext>
-            </a:extLst>
-          </p:cNvPr>
-          <p:cNvPicPr>
-            <a:picLocks noChangeAspect="1"/>
-          </p:cNvPicPr>
-          <p:nvPr/>
-        </p:nvPicPr>
-        <p:blipFill>
-          <a:blip r:embed="rId3"/>
-          <a:stretch>
-            <a:fillRect/>
-          </a:stretch>
-        </p:blipFill>
-        <p:spPr>
-          <a:xfrm>
-            <a:off x="3905433" y="1301287"/>
-            <a:ext cx="926340" cy="957430"/>
-          </a:xfrm>
-          <a:prstGeom prst="rect">
-            <a:avLst/>
-          </a:prstGeom>
-        </p:spPr>
-      </p:pic>
-      <p:pic>
-        <p:nvPicPr>
-          <p:cNvPr id="72" name="Grafik 71">
-            <a:extLst>
-              <a:ext uri="{FF2B5EF4-FFF2-40B4-BE49-F238E27FC236}">
-                <a16:creationId xmlns:a16="http://schemas.microsoft.com/office/drawing/2014/main" id="{422EE592-241D-4F02-8BF9-D181780D08EE}"/>
-              </a:ext>
-            </a:extLst>
-          </p:cNvPr>
-          <p:cNvPicPr>
-            <a:picLocks noChangeAspect="1"/>
-          </p:cNvPicPr>
-          <p:nvPr/>
-        </p:nvPicPr>
-        <p:blipFill>
-          <a:blip r:embed="rId4">
-            <a:extLst>
-              <a:ext uri="{28A0092B-C50C-407E-A947-70E740481C1C}">
-                <a14:useLocalDpi xmlns:a14="http://schemas.microsoft.com/office/drawing/2010/main" val="0"/>
-              </a:ext>
-            </a:extLst>
-          </a:blip>
-          <a:stretch>
-            <a:fillRect/>
-          </a:stretch>
-        </p:blipFill>
-        <p:spPr>
-          <a:xfrm>
-            <a:off x="4357559" y="1663327"/>
-            <a:ext cx="496934" cy="513612"/>
-          </a:xfrm>
-          <a:prstGeom prst="rect">
-            <a:avLst/>
-          </a:prstGeom>
-        </p:spPr>
-      </p:pic>
-      <p:cxnSp>
-        <p:nvCxnSpPr>
-          <p:cNvPr id="103" name="Verbinder: gewinkelt 102">
-            <a:extLst>
-              <a:ext uri="{FF2B5EF4-FFF2-40B4-BE49-F238E27FC236}">
-                <a16:creationId xmlns:a16="http://schemas.microsoft.com/office/drawing/2014/main" id="{DCE624EC-F4A2-4870-B06E-34A1E3493FD9}"/>
-              </a:ext>
-            </a:extLst>
-          </p:cNvPr>
-          <p:cNvCxnSpPr>
-            <a:cxnSpLocks/>
-            <a:stCxn id="100" idx="3"/>
-            <a:endCxn id="44" idx="1"/>
-          </p:cNvCxnSpPr>
-          <p:nvPr/>
-        </p:nvCxnSpPr>
-        <p:spPr>
-          <a:xfrm>
-            <a:off x="2355347" y="3756388"/>
-            <a:ext cx="4035037" cy="894318"/>
-          </a:xfrm>
-          <a:prstGeom prst="bentConnector3">
-            <a:avLst>
-              <a:gd name="adj1" fmla="val 23562"/>
-            </a:avLst>
-          </a:prstGeom>
-          <a:ln w="34925">
-            <a:prstDash val="sysDash"/>
-            <a:tailEnd type="triangle"/>
-          </a:ln>
-        </p:spPr>
-        <p:style>
-          <a:lnRef idx="1">
-            <a:schemeClr val="accent1"/>
-          </a:lnRef>
-          <a:fillRef idx="0">
-            <a:schemeClr val="accent1"/>
-          </a:fillRef>
-          <a:effectRef idx="0">
-            <a:schemeClr val="accent1"/>
-          </a:effectRef>
-          <a:fontRef idx="minor">
-            <a:schemeClr val="tx1"/>
-          </a:fontRef>
-        </p:style>
-      </p:cxnSp>
-      <p:grpSp>
-        <p:nvGrpSpPr>
-          <p:cNvPr id="5" name="Gruppieren 4">
-            <a:extLst>
-              <a:ext uri="{FF2B5EF4-FFF2-40B4-BE49-F238E27FC236}">
-                <a16:creationId xmlns:a16="http://schemas.microsoft.com/office/drawing/2014/main" id="{4A243A41-BB41-4C8E-87A5-7E74A88ADFF5}"/>
-              </a:ext>
-            </a:extLst>
-          </p:cNvPr>
-          <p:cNvGrpSpPr/>
-          <p:nvPr/>
-        </p:nvGrpSpPr>
-        <p:grpSpPr>
-          <a:xfrm>
-            <a:off x="6277019" y="1683694"/>
-            <a:ext cx="2160406" cy="4814088"/>
-            <a:chOff x="6180034" y="1993141"/>
-            <a:chExt cx="2160406" cy="4185986"/>
-          </a:xfrm>
-        </p:grpSpPr>
-        <p:sp>
-          <p:nvSpPr>
-            <p:cNvPr id="99" name="Rechteck: abgerundete Ecken 98">
-              <a:extLst>
-                <a:ext uri="{FF2B5EF4-FFF2-40B4-BE49-F238E27FC236}">
-                  <a16:creationId xmlns:a16="http://schemas.microsoft.com/office/drawing/2014/main" id="{C40587F3-FB08-4311-A205-85AF672C9347}"/>
-                </a:ext>
-              </a:extLst>
-            </p:cNvPr>
-            <p:cNvSpPr/>
-            <p:nvPr/>
-          </p:nvSpPr>
-          <p:spPr>
-            <a:xfrm>
-              <a:off x="6433691" y="1993141"/>
-              <a:ext cx="1906749" cy="4185986"/>
-            </a:xfrm>
-            <a:prstGeom prst="roundRect">
-              <a:avLst/>
-            </a:prstGeom>
-            <a:noFill/>
-            <a:ln w="19050">
-              <a:solidFill>
-                <a:srgbClr val="0070C0"/>
-              </a:solidFill>
-            </a:ln>
-          </p:spPr>
-          <p:style>
-            <a:lnRef idx="2">
-              <a:schemeClr val="accent1">
-                <a:shade val="50000"/>
-              </a:schemeClr>
-            </a:lnRef>
-            <a:fillRef idx="1">
-              <a:schemeClr val="accent1"/>
-            </a:fillRef>
-            <a:effectRef idx="0">
-              <a:schemeClr val="accent1"/>
-            </a:effectRef>
-            <a:fontRef idx="minor">
-              <a:schemeClr val="lt1"/>
-            </a:fontRef>
-          </p:style>
-          <p:txBody>
-            <a:bodyPr rtlCol="0" anchor="ctr"/>
-            <a:lstStyle/>
-            <a:p>
-              <a:pPr algn="ctr"/>
-              <a:endParaRPr lang="en-GB" sz="1350"/>
-            </a:p>
-          </p:txBody>
-        </p:sp>
-        <p:sp>
-          <p:nvSpPr>
-            <p:cNvPr id="42" name="Textfeld 41">
-              <a:extLst>
-                <a:ext uri="{FF2B5EF4-FFF2-40B4-BE49-F238E27FC236}">
-                  <a16:creationId xmlns:a16="http://schemas.microsoft.com/office/drawing/2014/main" id="{6E092C4C-4AC9-417B-89C1-AB0BBD4047A1}"/>
-                </a:ext>
-              </a:extLst>
-            </p:cNvPr>
-            <p:cNvSpPr txBox="1"/>
-            <p:nvPr/>
-          </p:nvSpPr>
-          <p:spPr>
-            <a:xfrm>
-              <a:off x="6675967" y="2205492"/>
-              <a:ext cx="1489447" cy="321145"/>
-            </a:xfrm>
-            <a:prstGeom prst="rect">
-              <a:avLst/>
-            </a:prstGeom>
-            <a:noFill/>
-          </p:spPr>
-          <p:txBody>
-            <a:bodyPr wrap="none" rtlCol="0">
-              <a:spAutoFit/>
-            </a:bodyPr>
-            <a:lstStyle/>
-            <a:p>
-              <a:pPr algn="ctr"/>
-              <a:r>
-                <a:rPr lang="de-DE" b="1" dirty="0"/>
-                <a:t>UFTPD Server</a:t>
-              </a:r>
-              <a:endParaRPr lang="en-GB" dirty="0"/>
-            </a:p>
-          </p:txBody>
-        </p:sp>
-        <p:sp>
-          <p:nvSpPr>
-            <p:cNvPr id="43" name="Rechteck 42">
-              <a:extLst>
-                <a:ext uri="{FF2B5EF4-FFF2-40B4-BE49-F238E27FC236}">
-                  <a16:creationId xmlns:a16="http://schemas.microsoft.com/office/drawing/2014/main" id="{CF37F80B-00B6-43FC-B00D-42A817E173EA}"/>
-                </a:ext>
-              </a:extLst>
-            </p:cNvPr>
-            <p:cNvSpPr/>
-            <p:nvPr/>
-          </p:nvSpPr>
-          <p:spPr>
-            <a:xfrm>
-              <a:off x="6274845" y="3688699"/>
-              <a:ext cx="339828" cy="254340"/>
-            </a:xfrm>
-            <a:prstGeom prst="rect">
-              <a:avLst/>
-            </a:prstGeom>
-            <a:solidFill>
-              <a:srgbClr val="0070C0"/>
-            </a:solidFill>
-            <a:ln>
-              <a:solidFill>
-                <a:srgbClr val="0070C0"/>
-              </a:solidFill>
-            </a:ln>
-          </p:spPr>
-          <p:style>
-            <a:lnRef idx="2">
-              <a:schemeClr val="accent1">
-                <a:shade val="50000"/>
-              </a:schemeClr>
-            </a:lnRef>
-            <a:fillRef idx="1">
-              <a:schemeClr val="accent1"/>
-            </a:fillRef>
-            <a:effectRef idx="0">
-              <a:schemeClr val="accent1"/>
-            </a:effectRef>
-            <a:fontRef idx="minor">
-              <a:schemeClr val="lt1"/>
-            </a:fontRef>
-          </p:style>
-          <p:txBody>
-            <a:bodyPr rtlCol="0" anchor="ctr"/>
-            <a:lstStyle/>
-            <a:p>
-              <a:pPr algn="ctr"/>
-              <a:endParaRPr lang="en-GB" sz="1350"/>
-            </a:p>
-          </p:txBody>
-        </p:sp>
-        <p:sp>
-          <p:nvSpPr>
-            <p:cNvPr id="44" name="Rechteck 43">
-              <a:extLst>
-                <a:ext uri="{FF2B5EF4-FFF2-40B4-BE49-F238E27FC236}">
-                  <a16:creationId xmlns:a16="http://schemas.microsoft.com/office/drawing/2014/main" id="{9A2CF124-8B16-4213-8943-707C6C61D000}"/>
-                </a:ext>
-              </a:extLst>
-            </p:cNvPr>
-            <p:cNvSpPr/>
-            <p:nvPr/>
-          </p:nvSpPr>
-          <p:spPr>
-            <a:xfrm>
-              <a:off x="6293399" y="4445872"/>
-              <a:ext cx="339828" cy="254340"/>
-            </a:xfrm>
-            <a:prstGeom prst="rect">
-              <a:avLst/>
-            </a:prstGeom>
-            <a:solidFill>
-              <a:srgbClr val="008000"/>
-            </a:solidFill>
-            <a:ln w="22225">
-              <a:solidFill>
-                <a:srgbClr val="008000"/>
-              </a:solidFill>
-            </a:ln>
-          </p:spPr>
-          <p:style>
-            <a:lnRef idx="2">
-              <a:schemeClr val="accent1">
-                <a:shade val="50000"/>
-              </a:schemeClr>
-            </a:lnRef>
-            <a:fillRef idx="1">
-              <a:schemeClr val="accent1"/>
-            </a:fillRef>
-            <a:effectRef idx="0">
-              <a:schemeClr val="accent1"/>
-            </a:effectRef>
-            <a:fontRef idx="minor">
-              <a:schemeClr val="lt1"/>
-            </a:fontRef>
-          </p:style>
-          <p:txBody>
-            <a:bodyPr rtlCol="0" anchor="ctr"/>
-            <a:lstStyle/>
-            <a:p>
-              <a:pPr algn="ctr"/>
-              <a:endParaRPr lang="en-GB" sz="1350" dirty="0"/>
-            </a:p>
-          </p:txBody>
-        </p:sp>
-        <p:sp>
-          <p:nvSpPr>
-            <p:cNvPr id="45" name="Rechteck 44">
-              <a:extLst>
-                <a:ext uri="{FF2B5EF4-FFF2-40B4-BE49-F238E27FC236}">
-                  <a16:creationId xmlns:a16="http://schemas.microsoft.com/office/drawing/2014/main" id="{7CDC7DB5-5914-49C2-B017-83EFC50ABCEF}"/>
-                </a:ext>
-              </a:extLst>
-            </p:cNvPr>
-            <p:cNvSpPr/>
-            <p:nvPr/>
-          </p:nvSpPr>
-          <p:spPr>
-            <a:xfrm>
-              <a:off x="6180034" y="5182393"/>
-              <a:ext cx="318328" cy="164506"/>
-            </a:xfrm>
-            <a:prstGeom prst="rect">
-              <a:avLst/>
-            </a:prstGeom>
-            <a:solidFill>
-              <a:srgbClr val="92D050"/>
-            </a:solidFill>
-            <a:ln>
-              <a:solidFill>
-                <a:srgbClr val="0070C0"/>
-              </a:solidFill>
-            </a:ln>
-          </p:spPr>
-          <p:style>
-            <a:lnRef idx="2">
-              <a:schemeClr val="accent1">
-                <a:shade val="50000"/>
-              </a:schemeClr>
-            </a:lnRef>
-            <a:fillRef idx="1">
-              <a:schemeClr val="accent1"/>
-            </a:fillRef>
-            <a:effectRef idx="0">
-              <a:schemeClr val="accent1"/>
-            </a:effectRef>
-            <a:fontRef idx="minor">
-              <a:schemeClr val="lt1"/>
-            </a:fontRef>
-          </p:style>
-          <p:txBody>
-            <a:bodyPr rtlCol="0" anchor="ctr"/>
-            <a:lstStyle/>
-            <a:p>
-              <a:pPr algn="ctr"/>
-              <a:endParaRPr lang="en-GB" sz="1350"/>
-            </a:p>
-          </p:txBody>
-        </p:sp>
-        <p:sp>
-          <p:nvSpPr>
-            <p:cNvPr id="46" name="Rechteck 45">
-              <a:extLst>
-                <a:ext uri="{FF2B5EF4-FFF2-40B4-BE49-F238E27FC236}">
-                  <a16:creationId xmlns:a16="http://schemas.microsoft.com/office/drawing/2014/main" id="{4033F9D3-DC4E-4BBE-A5F0-2197F1A5B39E}"/>
-                </a:ext>
-              </a:extLst>
-            </p:cNvPr>
-            <p:cNvSpPr/>
-            <p:nvPr/>
-          </p:nvSpPr>
-          <p:spPr>
-            <a:xfrm>
-              <a:off x="6278039" y="5296348"/>
-              <a:ext cx="318328" cy="164506"/>
-            </a:xfrm>
-            <a:prstGeom prst="rect">
-              <a:avLst/>
-            </a:prstGeom>
-            <a:solidFill>
-              <a:srgbClr val="92D050"/>
-            </a:solidFill>
-            <a:ln>
-              <a:solidFill>
-                <a:srgbClr val="0070C0"/>
-              </a:solidFill>
-            </a:ln>
-          </p:spPr>
-          <p:style>
-            <a:lnRef idx="2">
-              <a:schemeClr val="accent1">
-                <a:shade val="50000"/>
-              </a:schemeClr>
-            </a:lnRef>
-            <a:fillRef idx="1">
-              <a:schemeClr val="accent1"/>
-            </a:fillRef>
-            <a:effectRef idx="0">
-              <a:schemeClr val="accent1"/>
-            </a:effectRef>
-            <a:fontRef idx="minor">
-              <a:schemeClr val="lt1"/>
-            </a:fontRef>
-          </p:style>
-          <p:txBody>
-            <a:bodyPr rtlCol="0" anchor="ctr"/>
-            <a:lstStyle/>
-            <a:p>
-              <a:pPr algn="ctr"/>
-              <a:endParaRPr lang="en-GB" sz="1350"/>
-            </a:p>
-          </p:txBody>
-        </p:sp>
-        <p:sp>
-          <p:nvSpPr>
-            <p:cNvPr id="47" name="Rechteck 46">
-              <a:extLst>
-                <a:ext uri="{FF2B5EF4-FFF2-40B4-BE49-F238E27FC236}">
-                  <a16:creationId xmlns:a16="http://schemas.microsoft.com/office/drawing/2014/main" id="{561E461A-BF9F-402B-B58F-4E2970C240A5}"/>
-                </a:ext>
-              </a:extLst>
-            </p:cNvPr>
-            <p:cNvSpPr/>
-            <p:nvPr/>
-          </p:nvSpPr>
-          <p:spPr>
-            <a:xfrm>
-              <a:off x="6363793" y="5410307"/>
-              <a:ext cx="318328" cy="164506"/>
-            </a:xfrm>
-            <a:prstGeom prst="rect">
-              <a:avLst/>
-            </a:prstGeom>
-            <a:solidFill>
-              <a:srgbClr val="92D050"/>
-            </a:solidFill>
-            <a:ln>
-              <a:solidFill>
-                <a:srgbClr val="0070C0"/>
-              </a:solidFill>
-            </a:ln>
-          </p:spPr>
-          <p:style>
-            <a:lnRef idx="2">
-              <a:schemeClr val="accent1">
-                <a:shade val="50000"/>
-              </a:schemeClr>
-            </a:lnRef>
-            <a:fillRef idx="1">
-              <a:schemeClr val="accent1"/>
-            </a:fillRef>
-            <a:effectRef idx="0">
-              <a:schemeClr val="accent1"/>
-            </a:effectRef>
-            <a:fontRef idx="minor">
-              <a:schemeClr val="lt1"/>
-            </a:fontRef>
-          </p:style>
-          <p:txBody>
-            <a:bodyPr rtlCol="0" anchor="ctr"/>
-            <a:lstStyle/>
-            <a:p>
-              <a:pPr algn="ctr"/>
-              <a:endParaRPr lang="en-GB" sz="1350"/>
-            </a:p>
-          </p:txBody>
-        </p:sp>
-        <p:sp>
-          <p:nvSpPr>
-            <p:cNvPr id="80" name="Textfeld 79">
-              <a:extLst>
-                <a:ext uri="{FF2B5EF4-FFF2-40B4-BE49-F238E27FC236}">
-                  <a16:creationId xmlns:a16="http://schemas.microsoft.com/office/drawing/2014/main" id="{D5D798D5-8C66-432F-9176-7A715B9C0170}"/>
-                </a:ext>
-              </a:extLst>
-            </p:cNvPr>
-            <p:cNvSpPr txBox="1"/>
-            <p:nvPr/>
-          </p:nvSpPr>
-          <p:spPr>
-            <a:xfrm>
-              <a:off x="6638116" y="3669481"/>
-              <a:ext cx="1306768" cy="454955"/>
-            </a:xfrm>
-            <a:prstGeom prst="rect">
-              <a:avLst/>
-            </a:prstGeom>
-            <a:noFill/>
-          </p:spPr>
-          <p:txBody>
-            <a:bodyPr wrap="none" rtlCol="0">
-              <a:spAutoFit/>
-            </a:bodyPr>
-            <a:lstStyle/>
-            <a:p>
-              <a:r>
-                <a:rPr lang="de-DE" sz="1400" b="1" dirty="0"/>
-                <a:t>Command </a:t>
-              </a:r>
-              <a:r>
-                <a:rPr lang="de-DE" sz="1400" b="1" dirty="0" err="1"/>
-                <a:t>port</a:t>
-              </a:r>
-              <a:br>
-                <a:rPr lang="de-DE" sz="1400" dirty="0"/>
-              </a:br>
-              <a:endParaRPr lang="en-GB" sz="1400" dirty="0"/>
-            </a:p>
-          </p:txBody>
-        </p:sp>
-        <p:sp>
-          <p:nvSpPr>
-            <p:cNvPr id="81" name="Textfeld 80">
-              <a:extLst>
-                <a:ext uri="{FF2B5EF4-FFF2-40B4-BE49-F238E27FC236}">
-                  <a16:creationId xmlns:a16="http://schemas.microsoft.com/office/drawing/2014/main" id="{FC978FC2-35B3-4F1D-95B3-319D19302808}"/>
-                </a:ext>
-              </a:extLst>
-            </p:cNvPr>
-            <p:cNvSpPr txBox="1"/>
-            <p:nvPr/>
-          </p:nvSpPr>
-          <p:spPr>
-            <a:xfrm>
-              <a:off x="6661560" y="4443953"/>
-              <a:ext cx="980397" cy="454955"/>
-            </a:xfrm>
-            <a:prstGeom prst="rect">
-              <a:avLst/>
-            </a:prstGeom>
-            <a:noFill/>
-          </p:spPr>
-          <p:txBody>
-            <a:bodyPr wrap="none" rtlCol="0">
-              <a:spAutoFit/>
-            </a:bodyPr>
-            <a:lstStyle>
-              <a:defPPr>
-                <a:defRPr lang="en-US"/>
-              </a:defPPr>
-              <a:lvl1pPr algn="ctr"/>
-            </a:lstStyle>
-            <a:p>
-              <a:pPr algn="l"/>
-              <a:r>
-                <a:rPr lang="de-DE" sz="1400" b="1" dirty="0"/>
-                <a:t>Listen </a:t>
-              </a:r>
-              <a:r>
-                <a:rPr lang="de-DE" sz="1400" b="1" dirty="0" err="1"/>
-                <a:t>port</a:t>
-              </a:r>
-              <a:br>
-                <a:rPr lang="de-DE" sz="1400" b="1" dirty="0"/>
-              </a:br>
-              <a:endParaRPr lang="en-GB" sz="1400" b="1" dirty="0"/>
-            </a:p>
-          </p:txBody>
-        </p:sp>
-        <p:sp>
-          <p:nvSpPr>
-            <p:cNvPr id="82" name="Textfeld 81">
-              <a:extLst>
-                <a:ext uri="{FF2B5EF4-FFF2-40B4-BE49-F238E27FC236}">
-                  <a16:creationId xmlns:a16="http://schemas.microsoft.com/office/drawing/2014/main" id="{628665A9-6B92-45BF-B501-3E63E2BD6C25}"/>
-                </a:ext>
-              </a:extLst>
-            </p:cNvPr>
-            <p:cNvSpPr txBox="1"/>
-            <p:nvPr/>
-          </p:nvSpPr>
-          <p:spPr>
-            <a:xfrm>
-              <a:off x="6692511" y="5158597"/>
-              <a:ext cx="1373891" cy="267621"/>
-            </a:xfrm>
-            <a:prstGeom prst="rect">
-              <a:avLst/>
-            </a:prstGeom>
-            <a:noFill/>
-          </p:spPr>
-          <p:txBody>
-            <a:bodyPr wrap="square" rtlCol="0">
-              <a:spAutoFit/>
-            </a:bodyPr>
-            <a:lstStyle>
-              <a:defPPr>
-                <a:defRPr lang="en-US"/>
-              </a:defPPr>
-              <a:lvl1pPr algn="ctr"/>
-            </a:lstStyle>
-            <a:p>
-              <a:pPr algn="l"/>
-              <a:r>
-                <a:rPr lang="de-DE" sz="1400" b="1" dirty="0"/>
-                <a:t>Data </a:t>
-              </a:r>
-              <a:r>
-                <a:rPr lang="de-DE" sz="1400" b="1" dirty="0" err="1"/>
-                <a:t>ports</a:t>
-              </a:r>
-              <a:endParaRPr lang="de-DE" sz="1400" b="1" dirty="0"/>
-            </a:p>
-          </p:txBody>
-        </p:sp>
-        <p:sp>
-          <p:nvSpPr>
-            <p:cNvPr id="116" name="Textfeld 115">
-              <a:extLst>
-                <a:ext uri="{FF2B5EF4-FFF2-40B4-BE49-F238E27FC236}">
-                  <a16:creationId xmlns:a16="http://schemas.microsoft.com/office/drawing/2014/main" id="{31470ACF-55D1-436D-BEA0-5B2184EE9B54}"/>
-                </a:ext>
-              </a:extLst>
-            </p:cNvPr>
-            <p:cNvSpPr txBox="1"/>
-            <p:nvPr/>
-          </p:nvSpPr>
-          <p:spPr>
-            <a:xfrm>
-              <a:off x="6681239" y="5398997"/>
-              <a:ext cx="1578906" cy="454955"/>
-            </a:xfrm>
-            <a:prstGeom prst="rect">
-              <a:avLst/>
-            </a:prstGeom>
-            <a:noFill/>
-          </p:spPr>
-          <p:txBody>
-            <a:bodyPr wrap="square" rtlCol="0">
-              <a:spAutoFit/>
-            </a:bodyPr>
-            <a:lstStyle>
-              <a:defPPr>
-                <a:defRPr lang="en-US"/>
-              </a:defPPr>
-              <a:lvl1pPr algn="ctr"/>
-            </a:lstStyle>
-            <a:p>
-              <a:pPr algn="l"/>
-              <a:r>
-                <a:rPr lang="de-DE" sz="1400" dirty="0"/>
-                <a:t>(</a:t>
-              </a:r>
-              <a:r>
-                <a:rPr lang="de-DE" sz="1400" dirty="0" err="1"/>
-                <a:t>dynamic</a:t>
-              </a:r>
-              <a:r>
-                <a:rPr lang="de-DE" sz="1400" dirty="0"/>
-                <a:t> </a:t>
-              </a:r>
-              <a:r>
-                <a:rPr lang="de-DE" sz="1400" dirty="0" err="1"/>
-                <a:t>or</a:t>
-              </a:r>
-              <a:r>
-                <a:rPr lang="de-DE" sz="1400" dirty="0"/>
-                <a:t> </a:t>
-              </a:r>
-              <a:r>
-                <a:rPr lang="de-DE" sz="1400" dirty="0" err="1"/>
-                <a:t>configured</a:t>
-              </a:r>
-              <a:r>
-                <a:rPr lang="de-DE" sz="1400" dirty="0"/>
-                <a:t> </a:t>
-              </a:r>
-              <a:r>
-                <a:rPr lang="de-DE" sz="1400" dirty="0" err="1"/>
-                <a:t>range</a:t>
-              </a:r>
-              <a:r>
-                <a:rPr lang="de-DE" sz="1400" dirty="0"/>
-                <a:t>)</a:t>
-              </a:r>
-              <a:endParaRPr lang="en-GB" sz="1600" dirty="0"/>
-            </a:p>
-          </p:txBody>
-        </p:sp>
-        <p:pic>
-          <p:nvPicPr>
-            <p:cNvPr id="123" name="Grafik 122">
-              <a:extLst>
-                <a:ext uri="{FF2B5EF4-FFF2-40B4-BE49-F238E27FC236}">
-                  <a16:creationId xmlns:a16="http://schemas.microsoft.com/office/drawing/2014/main" id="{5F608270-20C0-4C3D-912A-FE42750A8E87}"/>
-                </a:ext>
-              </a:extLst>
-            </p:cNvPr>
-            <p:cNvPicPr>
-              <a:picLocks noChangeAspect="1"/>
-            </p:cNvPicPr>
-            <p:nvPr/>
-          </p:nvPicPr>
-          <p:blipFill>
-            <a:blip r:embed="rId5">
-              <a:extLst>
-                <a:ext uri="{28A0092B-C50C-407E-A947-70E740481C1C}">
-                  <a14:useLocalDpi xmlns:a14="http://schemas.microsoft.com/office/drawing/2010/main" val="0"/>
-                </a:ext>
-              </a:extLst>
-            </a:blip>
-            <a:stretch>
-              <a:fillRect/>
-            </a:stretch>
-          </p:blipFill>
-          <p:spPr>
-            <a:xfrm>
-              <a:off x="7066898" y="2621061"/>
-              <a:ext cx="731542" cy="927724"/>
-            </a:xfrm>
-            <a:prstGeom prst="rect">
-              <a:avLst/>
-            </a:prstGeom>
-          </p:spPr>
-        </p:pic>
-      </p:grpSp>
-      <p:sp>
-        <p:nvSpPr>
-          <p:cNvPr id="3" name="Textfeld 2">
-            <a:extLst>
-              <a:ext uri="{FF2B5EF4-FFF2-40B4-BE49-F238E27FC236}">
-                <a16:creationId xmlns:a16="http://schemas.microsoft.com/office/drawing/2014/main" id="{3B354CF3-9F23-4FDD-A1F6-1DA43EB81531}"/>
-              </a:ext>
-            </a:extLst>
-          </p:cNvPr>
-          <p:cNvSpPr txBox="1"/>
-          <p:nvPr/>
-        </p:nvSpPr>
-        <p:spPr>
-          <a:xfrm>
-            <a:off x="1503323" y="1829080"/>
-            <a:ext cx="1886029" cy="307777"/>
-          </a:xfrm>
-          <a:prstGeom prst="rect">
-            <a:avLst/>
-          </a:prstGeom>
-          <a:noFill/>
-        </p:spPr>
-        <p:txBody>
-          <a:bodyPr wrap="none" rtlCol="0">
-            <a:spAutoFit/>
-          </a:bodyPr>
-          <a:lstStyle/>
-          <a:p>
-            <a:r>
-              <a:rPr lang="de-DE" sz="1400" i="1" dirty="0"/>
-              <a:t>(</a:t>
-            </a:r>
-            <a:r>
-              <a:rPr lang="de-DE" sz="1400" i="1" dirty="0" err="1"/>
-              <a:t>username</a:t>
-            </a:r>
-            <a:r>
-              <a:rPr lang="de-DE" sz="1400" i="1" dirty="0"/>
-              <a:t> + </a:t>
-            </a:r>
-            <a:r>
-              <a:rPr lang="de-DE" sz="1400" i="1" dirty="0" err="1"/>
-              <a:t>password</a:t>
-            </a:r>
-            <a:r>
-              <a:rPr lang="de-DE" sz="1400" i="1" dirty="0"/>
-              <a:t>)</a:t>
-            </a:r>
-            <a:endParaRPr lang="en-GB" sz="1400" i="1" dirty="0"/>
-          </a:p>
-        </p:txBody>
-      </p:sp>
-      <p:sp>
-        <p:nvSpPr>
-          <p:cNvPr id="62" name="Textfeld 61">
-            <a:extLst>
-              <a:ext uri="{FF2B5EF4-FFF2-40B4-BE49-F238E27FC236}">
-                <a16:creationId xmlns:a16="http://schemas.microsoft.com/office/drawing/2014/main" id="{F21398CE-8541-471B-8D1F-8282D4FEBD32}"/>
-              </a:ext>
-            </a:extLst>
-          </p:cNvPr>
-          <p:cNvSpPr txBox="1"/>
-          <p:nvPr/>
-        </p:nvSpPr>
-        <p:spPr>
-          <a:xfrm>
-            <a:off x="4556865" y="3164191"/>
-            <a:ext cx="1632755" cy="523220"/>
-          </a:xfrm>
-          <a:prstGeom prst="rect">
-            <a:avLst/>
-          </a:prstGeom>
-          <a:noFill/>
-        </p:spPr>
-        <p:txBody>
-          <a:bodyPr wrap="none" rtlCol="0">
-            <a:spAutoFit/>
-          </a:bodyPr>
-          <a:lstStyle/>
-          <a:p>
-            <a:pPr algn="ctr"/>
-            <a:r>
-              <a:rPr lang="de-DE" sz="1400" i="1" dirty="0"/>
-              <a:t>(</a:t>
-            </a:r>
-            <a:r>
-              <a:rPr lang="de-DE" sz="1400" i="1" dirty="0" err="1"/>
-              <a:t>local</a:t>
-            </a:r>
-            <a:r>
-              <a:rPr lang="de-DE" sz="1400" i="1" dirty="0"/>
-              <a:t> </a:t>
-            </a:r>
-            <a:r>
-              <a:rPr lang="de-DE" sz="1400" i="1" dirty="0" err="1"/>
-              <a:t>username</a:t>
-            </a:r>
-            <a:r>
-              <a:rPr lang="de-DE" sz="1400" i="1" dirty="0"/>
-              <a:t> +</a:t>
-            </a:r>
-            <a:br>
-              <a:rPr lang="de-DE" sz="1400" i="1" dirty="0"/>
-            </a:br>
-            <a:r>
-              <a:rPr lang="de-DE" sz="1400" i="1" dirty="0" err="1"/>
-              <a:t>one</a:t>
-            </a:r>
-            <a:r>
-              <a:rPr lang="de-DE" sz="1400" i="1" dirty="0"/>
-              <a:t>-time </a:t>
-            </a:r>
-            <a:r>
-              <a:rPr lang="de-DE" sz="1400" i="1" dirty="0" err="1"/>
-              <a:t>password</a:t>
-            </a:r>
-            <a:r>
-              <a:rPr lang="de-DE" sz="1400" i="1" dirty="0"/>
-              <a:t>)</a:t>
-            </a:r>
-            <a:endParaRPr lang="en-GB" sz="1400" i="1" dirty="0"/>
-          </a:p>
-        </p:txBody>
-      </p:sp>
-      <p:sp>
-        <p:nvSpPr>
-          <p:cNvPr id="63" name="Textfeld 62">
-            <a:extLst>
-              <a:ext uri="{FF2B5EF4-FFF2-40B4-BE49-F238E27FC236}">
-                <a16:creationId xmlns:a16="http://schemas.microsoft.com/office/drawing/2014/main" id="{49613CA5-FFF9-4495-9CCF-0FA24873BD0E}"/>
-              </a:ext>
-            </a:extLst>
-          </p:cNvPr>
-          <p:cNvSpPr txBox="1"/>
-          <p:nvPr/>
-        </p:nvSpPr>
-        <p:spPr>
-          <a:xfrm>
-            <a:off x="3511007" y="4255718"/>
-            <a:ext cx="1687257" cy="307777"/>
-          </a:xfrm>
-          <a:prstGeom prst="rect">
-            <a:avLst/>
-          </a:prstGeom>
-          <a:noFill/>
-        </p:spPr>
-        <p:txBody>
-          <a:bodyPr wrap="none" rtlCol="0">
-            <a:spAutoFit/>
-          </a:bodyPr>
-          <a:lstStyle/>
-          <a:p>
-            <a:r>
-              <a:rPr lang="de-DE" sz="1400" i="1" dirty="0"/>
-              <a:t>(</a:t>
-            </a:r>
-            <a:r>
-              <a:rPr lang="de-DE" sz="1400" i="1" dirty="0" err="1"/>
-              <a:t>one</a:t>
-            </a:r>
-            <a:r>
-              <a:rPr lang="de-DE" sz="1400" i="1" dirty="0"/>
-              <a:t>-time </a:t>
-            </a:r>
-            <a:r>
-              <a:rPr lang="de-DE" sz="1400" i="1" dirty="0" err="1"/>
-              <a:t>password</a:t>
-            </a:r>
-            <a:r>
-              <a:rPr lang="de-DE" sz="1400" i="1" dirty="0"/>
-              <a:t>)</a:t>
-            </a:r>
-            <a:endParaRPr lang="en-GB" sz="1400" i="1" dirty="0"/>
-          </a:p>
-        </p:txBody>
-      </p:sp>
-      <p:sp>
-        <p:nvSpPr>
-          <p:cNvPr id="95" name="Ellipse 94">
-            <a:extLst>
-              <a:ext uri="{FF2B5EF4-FFF2-40B4-BE49-F238E27FC236}">
-                <a16:creationId xmlns:a16="http://schemas.microsoft.com/office/drawing/2014/main" id="{EDA49B51-AA97-4B64-9D72-C8D8B3A6DC44}"/>
-              </a:ext>
-            </a:extLst>
-          </p:cNvPr>
-          <p:cNvSpPr/>
-          <p:nvPr/>
-        </p:nvSpPr>
-        <p:spPr>
-          <a:xfrm>
-            <a:off x="3160263" y="4066236"/>
-            <a:ext cx="295324" cy="310219"/>
-          </a:xfrm>
-          <a:prstGeom prst="ellipse">
-            <a:avLst/>
-          </a:prstGeom>
-        </p:spPr>
-        <p:style>
-          <a:lnRef idx="2">
-            <a:schemeClr val="accent1">
-              <a:shade val="50000"/>
-            </a:schemeClr>
-          </a:lnRef>
-          <a:fillRef idx="1">
-            <a:schemeClr val="accent1"/>
-          </a:fillRef>
-          <a:effectRef idx="0">
-            <a:schemeClr val="accent1"/>
-          </a:effectRef>
-          <a:fontRef idx="minor">
-            <a:schemeClr val="lt1"/>
-          </a:fontRef>
-        </p:style>
-        <p:txBody>
-          <a:bodyPr rtlCol="0" anchor="ctr"/>
-          <a:lstStyle/>
-          <a:p>
-            <a:pPr algn="ctr"/>
-            <a:r>
-              <a:rPr lang="de-DE" sz="1600" b="1" dirty="0"/>
-              <a:t>3</a:t>
             </a:r>
             <a:endParaRPr lang="en-GB" sz="1600" b="1" dirty="0"/>
           </a:p>

</xml_diff>

<commit_message>
test installation figure updated
</commit_message>
<xml_diff>
--- a/source/_static/test-uftp-setup.pptx
+++ b/source/_static/test-uftp-setup.pptx
@@ -243,7 +243,7 @@
           <a:p>
             <a:fld id="{F89FD5E3-9FE6-47D6-82DD-5BFE33800862}" type="datetimeFigureOut">
               <a:rPr lang="en-GB" smtClean="0"/>
-              <a:t>08/10/2026</a:t>
+              <a:t>14/10/2026</a:t>
             </a:fld>
             <a:endParaRPr lang="en-GB"/>
           </a:p>
@@ -413,7 +413,7 @@
           <a:p>
             <a:fld id="{F89FD5E3-9FE6-47D6-82DD-5BFE33800862}" type="datetimeFigureOut">
               <a:rPr lang="en-GB" smtClean="0"/>
-              <a:t>08/10/2026</a:t>
+              <a:t>14/10/2026</a:t>
             </a:fld>
             <a:endParaRPr lang="en-GB"/>
           </a:p>
@@ -593,7 +593,7 @@
           <a:p>
             <a:fld id="{F89FD5E3-9FE6-47D6-82DD-5BFE33800862}" type="datetimeFigureOut">
               <a:rPr lang="en-GB" smtClean="0"/>
-              <a:t>08/10/2026</a:t>
+              <a:t>14/10/2026</a:t>
             </a:fld>
             <a:endParaRPr lang="en-GB"/>
           </a:p>
@@ -763,7 +763,7 @@
           <a:p>
             <a:fld id="{F89FD5E3-9FE6-47D6-82DD-5BFE33800862}" type="datetimeFigureOut">
               <a:rPr lang="en-GB" smtClean="0"/>
-              <a:t>08/10/2026</a:t>
+              <a:t>14/10/2026</a:t>
             </a:fld>
             <a:endParaRPr lang="en-GB"/>
           </a:p>
@@ -1007,7 +1007,7 @@
           <a:p>
             <a:fld id="{F89FD5E3-9FE6-47D6-82DD-5BFE33800862}" type="datetimeFigureOut">
               <a:rPr lang="en-GB" smtClean="0"/>
-              <a:t>08/10/2026</a:t>
+              <a:t>14/10/2026</a:t>
             </a:fld>
             <a:endParaRPr lang="en-GB"/>
           </a:p>
@@ -1239,7 +1239,7 @@
           <a:p>
             <a:fld id="{F89FD5E3-9FE6-47D6-82DD-5BFE33800862}" type="datetimeFigureOut">
               <a:rPr lang="en-GB" smtClean="0"/>
-              <a:t>08/10/2026</a:t>
+              <a:t>14/10/2026</a:t>
             </a:fld>
             <a:endParaRPr lang="en-GB"/>
           </a:p>
@@ -1606,7 +1606,7 @@
           <a:p>
             <a:fld id="{F89FD5E3-9FE6-47D6-82DD-5BFE33800862}" type="datetimeFigureOut">
               <a:rPr lang="en-GB" smtClean="0"/>
-              <a:t>08/10/2026</a:t>
+              <a:t>14/10/2026</a:t>
             </a:fld>
             <a:endParaRPr lang="en-GB"/>
           </a:p>
@@ -1724,7 +1724,7 @@
           <a:p>
             <a:fld id="{F89FD5E3-9FE6-47D6-82DD-5BFE33800862}" type="datetimeFigureOut">
               <a:rPr lang="en-GB" smtClean="0"/>
-              <a:t>08/10/2026</a:t>
+              <a:t>14/10/2026</a:t>
             </a:fld>
             <a:endParaRPr lang="en-GB"/>
           </a:p>
@@ -1819,7 +1819,7 @@
           <a:p>
             <a:fld id="{F89FD5E3-9FE6-47D6-82DD-5BFE33800862}" type="datetimeFigureOut">
               <a:rPr lang="en-GB" smtClean="0"/>
-              <a:t>08/10/2026</a:t>
+              <a:t>14/10/2026</a:t>
             </a:fld>
             <a:endParaRPr lang="en-GB"/>
           </a:p>
@@ -2096,7 +2096,7 @@
           <a:p>
             <a:fld id="{F89FD5E3-9FE6-47D6-82DD-5BFE33800862}" type="datetimeFigureOut">
               <a:rPr lang="en-GB" smtClean="0"/>
-              <a:t>08/10/2026</a:t>
+              <a:t>14/10/2026</a:t>
             </a:fld>
             <a:endParaRPr lang="en-GB"/>
           </a:p>
@@ -2353,7 +2353,7 @@
           <a:p>
             <a:fld id="{F89FD5E3-9FE6-47D6-82DD-5BFE33800862}" type="datetimeFigureOut">
               <a:rPr lang="en-GB" smtClean="0"/>
-              <a:t>08/10/2026</a:t>
+              <a:t>14/10/2026</a:t>
             </a:fld>
             <a:endParaRPr lang="en-GB"/>
           </a:p>
@@ -2566,7 +2566,7 @@
           <a:p>
             <a:fld id="{F89FD5E3-9FE6-47D6-82DD-5BFE33800862}" type="datetimeFigureOut">
               <a:rPr lang="en-GB" smtClean="0"/>
-              <a:t>08/10/2026</a:t>
+              <a:t>14/10/2026</a:t>
             </a:fld>
             <a:endParaRPr lang="en-GB"/>
           </a:p>
@@ -2981,15 +2981,16 @@
             </a:extLst>
           </p:cNvPr>
           <p:cNvCxnSpPr>
+            <a:cxnSpLocks/>
             <a:stCxn id="100" idx="3"/>
             <a:endCxn id="44" idx="1"/>
           </p:cNvCxnSpPr>
           <p:nvPr/>
         </p:nvCxnSpPr>
         <p:spPr>
-          <a:xfrm flipV="1">
-            <a:off x="2236350" y="4026833"/>
-            <a:ext cx="4529814" cy="7347"/>
+          <a:xfrm>
+            <a:off x="2236350" y="4034180"/>
+            <a:ext cx="4529814" cy="4930"/>
           </a:xfrm>
           <a:prstGeom prst="straightConnector1">
             <a:avLst/>
@@ -3028,8 +3029,8 @@
         </p:nvSpPr>
         <p:spPr>
           <a:xfrm>
-            <a:off x="3188536" y="964306"/>
-            <a:ext cx="1824474" cy="584775"/>
+            <a:off x="3329610" y="620372"/>
+            <a:ext cx="1715470" cy="584775"/>
           </a:xfrm>
           <a:prstGeom prst="rect">
             <a:avLst/>
@@ -3051,10 +3052,6 @@
               <a:rPr lang="de-DE" sz="1600" dirty="0"/>
             </a:br>
             <a:r>
-              <a:rPr lang="de-DE" sz="1400" dirty="0"/>
-              <a:t>(</a:t>
-            </a:r>
-            <a:r>
               <a:rPr lang="de-DE" sz="1400" dirty="0" err="1"/>
               <a:t>or</a:t>
             </a:r>
@@ -3066,11 +3063,7 @@
               <a:rPr lang="de-DE" sz="1400" dirty="0" err="1"/>
               <a:t>server</a:t>
             </a:r>
-            <a:r>
-              <a:rPr lang="de-DE" sz="1400" dirty="0"/>
-              <a:t>)</a:t>
-            </a:r>
-            <a:endParaRPr lang="en-GB" sz="1600" dirty="0"/>
+            <a:endParaRPr lang="de-DE" sz="1400" dirty="0"/>
           </a:p>
         </p:txBody>
       </p:sp>
@@ -3086,14 +3079,14 @@
           <p:cNvCxnSpPr>
             <a:cxnSpLocks/>
             <a:stCxn id="100" idx="0"/>
-            <a:endCxn id="98" idx="1"/>
+            <a:endCxn id="50" idx="1"/>
           </p:cNvCxnSpPr>
           <p:nvPr/>
         </p:nvCxnSpPr>
         <p:spPr>
           <a:xfrm rot="5400000" flipH="1" flipV="1">
-            <a:off x="1526557" y="1617737"/>
-            <a:ext cx="1330589" cy="1875513"/>
+            <a:off x="1452535" y="1477069"/>
+            <a:ext cx="1545279" cy="1942158"/>
           </a:xfrm>
           <a:prstGeom prst="bentConnector2">
             <a:avLst/>
@@ -3132,7 +3125,7 @@
         </p:nvSpPr>
         <p:spPr>
           <a:xfrm>
-            <a:off x="1212534" y="1425971"/>
+            <a:off x="1226495" y="1207003"/>
             <a:ext cx="1907573" cy="307777"/>
           </a:xfrm>
           <a:prstGeom prst="rect">
@@ -3274,7 +3267,7 @@
         </p:nvSpPr>
         <p:spPr>
           <a:xfrm>
-            <a:off x="2078720" y="1744263"/>
+            <a:off x="2038361" y="1528860"/>
             <a:ext cx="295324" cy="310219"/>
           </a:xfrm>
           <a:prstGeom prst="ellipse">
@@ -3327,8 +3320,8 @@
         </p:nvSpPr>
         <p:spPr>
           <a:xfrm>
-            <a:off x="3129608" y="818653"/>
-            <a:ext cx="1942333" cy="2143089"/>
+            <a:off x="3338357" y="457200"/>
+            <a:ext cx="1733584" cy="2610503"/>
           </a:xfrm>
           <a:prstGeom prst="roundRect">
             <a:avLst/>
@@ -3379,7 +3372,7 @@
         </p:nvSpPr>
         <p:spPr>
           <a:xfrm>
-            <a:off x="480261" y="3411935"/>
+            <a:off x="435436" y="3394005"/>
             <a:ext cx="1638525" cy="584775"/>
           </a:xfrm>
           <a:prstGeom prst="rect">
@@ -3503,8 +3496,8 @@
         </p:blipFill>
         <p:spPr>
           <a:xfrm>
-            <a:off x="792471" y="4025941"/>
-            <a:ext cx="868048" cy="663135"/>
+            <a:off x="900177" y="4041272"/>
+            <a:ext cx="752986" cy="575235"/>
           </a:xfrm>
           <a:prstGeom prst="rect">
             <a:avLst/>
@@ -3525,8 +3518,8 @@
         </p:nvGrpSpPr>
         <p:grpSpPr>
           <a:xfrm>
-            <a:off x="3650776" y="1747774"/>
-            <a:ext cx="949060" cy="957430"/>
+            <a:off x="3811311" y="1974721"/>
+            <a:ext cx="809380" cy="847425"/>
             <a:chOff x="3905433" y="1301287"/>
             <a:chExt cx="949060" cy="957430"/>
           </a:xfrm>
@@ -3612,8 +3605,8 @@
         </p:nvSpPr>
         <p:spPr>
           <a:xfrm>
-            <a:off x="6881404" y="818653"/>
-            <a:ext cx="1906749" cy="5582146"/>
+            <a:off x="6881404" y="457200"/>
+            <a:ext cx="2081832" cy="5943599"/>
           </a:xfrm>
           <a:prstGeom prst="roundRect">
             <a:avLst/>
@@ -3664,7 +3657,7 @@
         </p:nvSpPr>
         <p:spPr>
           <a:xfrm>
-            <a:off x="7133777" y="1010576"/>
+            <a:off x="7135618" y="712592"/>
             <a:ext cx="1489447" cy="369332"/>
           </a:xfrm>
           <a:prstGeom prst="rect">
@@ -3701,14 +3694,14 @@
         </p:nvSpPr>
         <p:spPr>
           <a:xfrm>
-            <a:off x="6772427" y="1759034"/>
-            <a:ext cx="339828" cy="292503"/>
+            <a:off x="6772427" y="1597815"/>
+            <a:ext cx="288000" cy="180000"/>
           </a:xfrm>
           <a:prstGeom prst="rect">
             <a:avLst/>
           </a:prstGeom>
           <a:solidFill>
-            <a:srgbClr val="00B0F0"/>
+            <a:srgbClr val="009AD0"/>
           </a:solidFill>
           <a:ln>
             <a:solidFill>
@@ -3755,8 +3748,8 @@
         </p:nvSpPr>
         <p:spPr>
           <a:xfrm>
-            <a:off x="6766164" y="3880581"/>
-            <a:ext cx="339828" cy="292503"/>
+            <a:off x="6766164" y="3949110"/>
+            <a:ext cx="288000" cy="180000"/>
           </a:xfrm>
           <a:prstGeom prst="rect">
             <a:avLst/>
@@ -3810,7 +3803,7 @@
         <p:spPr>
           <a:xfrm>
             <a:off x="6696640" y="5316338"/>
-            <a:ext cx="318328" cy="189190"/>
+            <a:ext cx="288000" cy="180000"/>
           </a:xfrm>
           <a:prstGeom prst="rect">
             <a:avLst/>
@@ -3864,7 +3857,7 @@
         <p:spPr>
           <a:xfrm>
             <a:off x="6750804" y="5409814"/>
-            <a:ext cx="318328" cy="189190"/>
+            <a:ext cx="288000" cy="180000"/>
           </a:xfrm>
           <a:prstGeom prst="rect">
             <a:avLst/>
@@ -3918,7 +3911,7 @@
         <p:spPr>
           <a:xfrm>
             <a:off x="6816108" y="5512827"/>
-            <a:ext cx="318328" cy="189190"/>
+            <a:ext cx="288000" cy="180000"/>
           </a:xfrm>
           <a:prstGeom prst="rect">
             <a:avLst/>
@@ -3957,215 +3950,123 @@
           </a:p>
         </p:txBody>
       </p:sp>
-      <p:sp>
-        <p:nvSpPr>
-          <p:cNvPr id="80" name="Textfeld 79">
+      <p:grpSp>
+        <p:nvGrpSpPr>
+          <p:cNvPr id="12" name="Gruppieren 11">
             <a:extLst>
               <a:ext uri="{FF2B5EF4-FFF2-40B4-BE49-F238E27FC236}">
-                <a16:creationId xmlns:a16="http://schemas.microsoft.com/office/drawing/2014/main" id="{D5D798D5-8C66-432F-9176-7A715B9C0170}"/>
+                <a16:creationId xmlns:a16="http://schemas.microsoft.com/office/drawing/2014/main" id="{03DE91A1-D770-4696-9205-2BE438F01105}"/>
               </a:ext>
             </a:extLst>
           </p:cNvPr>
-          <p:cNvSpPr txBox="1"/>
+          <p:cNvGrpSpPr/>
           <p:nvPr/>
-        </p:nvSpPr>
-        <p:spPr>
-          <a:xfrm>
-            <a:off x="7118266" y="1751795"/>
-            <a:ext cx="1306768" cy="307777"/>
-          </a:xfrm>
-          <a:prstGeom prst="rect">
-            <a:avLst/>
-          </a:prstGeom>
-          <a:noFill/>
-        </p:spPr>
-        <p:txBody>
-          <a:bodyPr wrap="none" rtlCol="0">
-            <a:spAutoFit/>
-          </a:bodyPr>
-          <a:lstStyle/>
-          <a:p>
-            <a:r>
-              <a:rPr lang="de-DE" sz="1400" b="1" dirty="0"/>
-              <a:t>Command </a:t>
-            </a:r>
-            <a:r>
-              <a:rPr lang="de-DE" sz="1400" b="1" dirty="0" err="1"/>
-              <a:t>port</a:t>
-            </a:r>
-            <a:endParaRPr lang="en-GB" sz="1400" dirty="0"/>
-          </a:p>
-        </p:txBody>
-      </p:sp>
-      <p:sp>
-        <p:nvSpPr>
-          <p:cNvPr id="81" name="Textfeld 80">
-            <a:extLst>
-              <a:ext uri="{FF2B5EF4-FFF2-40B4-BE49-F238E27FC236}">
-                <a16:creationId xmlns:a16="http://schemas.microsoft.com/office/drawing/2014/main" id="{FC978FC2-35B3-4F1D-95B3-319D19302808}"/>
-              </a:ext>
-            </a:extLst>
-          </p:cNvPr>
-          <p:cNvSpPr txBox="1"/>
-          <p:nvPr/>
-        </p:nvSpPr>
-        <p:spPr>
-          <a:xfrm>
-            <a:off x="7121399" y="3865307"/>
-            <a:ext cx="980397" cy="307777"/>
-          </a:xfrm>
-          <a:prstGeom prst="rect">
-            <a:avLst/>
-          </a:prstGeom>
-          <a:noFill/>
-        </p:spPr>
-        <p:txBody>
-          <a:bodyPr wrap="none" rtlCol="0">
-            <a:spAutoFit/>
-          </a:bodyPr>
-          <a:lstStyle>
-            <a:defPPr>
-              <a:defRPr lang="en-US"/>
-            </a:defPPr>
-            <a:lvl1pPr algn="ctr"/>
-          </a:lstStyle>
-          <a:p>
-            <a:pPr algn="l"/>
-            <a:r>
-              <a:rPr lang="de-DE" sz="1400" b="1" dirty="0"/>
-              <a:t>Listen </a:t>
-            </a:r>
-            <a:r>
-              <a:rPr lang="de-DE" sz="1400" b="1" dirty="0" err="1"/>
-              <a:t>port</a:t>
-            </a:r>
-            <a:endParaRPr lang="en-GB" sz="1400" b="1" dirty="0"/>
-          </a:p>
-        </p:txBody>
-      </p:sp>
-      <p:sp>
-        <p:nvSpPr>
-          <p:cNvPr id="82" name="Textfeld 81">
-            <a:extLst>
-              <a:ext uri="{FF2B5EF4-FFF2-40B4-BE49-F238E27FC236}">
-                <a16:creationId xmlns:a16="http://schemas.microsoft.com/office/drawing/2014/main" id="{628665A9-6B92-45BF-B501-3E63E2BD6C25}"/>
-              </a:ext>
-            </a:extLst>
-          </p:cNvPr>
-          <p:cNvSpPr txBox="1"/>
-          <p:nvPr/>
-        </p:nvSpPr>
-        <p:spPr>
-          <a:xfrm>
-            <a:off x="7126299" y="5260719"/>
-            <a:ext cx="1373891" cy="307777"/>
-          </a:xfrm>
-          <a:prstGeom prst="rect">
-            <a:avLst/>
-          </a:prstGeom>
-          <a:noFill/>
-        </p:spPr>
-        <p:txBody>
-          <a:bodyPr wrap="square" rtlCol="0">
-            <a:spAutoFit/>
-          </a:bodyPr>
-          <a:lstStyle>
-            <a:defPPr>
-              <a:defRPr lang="en-US"/>
-            </a:defPPr>
-            <a:lvl1pPr algn="ctr"/>
-          </a:lstStyle>
-          <a:p>
-            <a:pPr algn="l"/>
-            <a:r>
-              <a:rPr lang="de-DE" sz="1400" b="1" dirty="0"/>
-              <a:t>Data </a:t>
-            </a:r>
-            <a:r>
-              <a:rPr lang="de-DE" sz="1400" b="1" dirty="0" err="1"/>
-              <a:t>ports</a:t>
-            </a:r>
-            <a:endParaRPr lang="de-DE" sz="1400" b="1" dirty="0"/>
-          </a:p>
-        </p:txBody>
-      </p:sp>
-      <p:sp>
-        <p:nvSpPr>
-          <p:cNvPr id="116" name="Textfeld 115">
-            <a:extLst>
-              <a:ext uri="{FF2B5EF4-FFF2-40B4-BE49-F238E27FC236}">
-                <a16:creationId xmlns:a16="http://schemas.microsoft.com/office/drawing/2014/main" id="{31470ACF-55D1-436D-BEA0-5B2184EE9B54}"/>
-              </a:ext>
-            </a:extLst>
-          </p:cNvPr>
-          <p:cNvSpPr txBox="1"/>
-          <p:nvPr/>
-        </p:nvSpPr>
-        <p:spPr>
-          <a:xfrm>
-            <a:off x="7184372" y="5497124"/>
-            <a:ext cx="1584761" cy="523220"/>
-          </a:xfrm>
-          <a:prstGeom prst="rect">
-            <a:avLst/>
-          </a:prstGeom>
-          <a:noFill/>
-        </p:spPr>
-        <p:txBody>
-          <a:bodyPr wrap="square" rtlCol="0">
-            <a:spAutoFit/>
-          </a:bodyPr>
-          <a:lstStyle>
-            <a:defPPr>
-              <a:defRPr lang="en-US"/>
-            </a:defPPr>
-            <a:lvl1pPr algn="ctr"/>
-          </a:lstStyle>
-          <a:p>
-            <a:pPr algn="l"/>
-            <a:r>
-              <a:rPr lang="de-DE" sz="1400" dirty="0"/>
-              <a:t>(</a:t>
-            </a:r>
-            <a:r>
-              <a:rPr lang="de-DE" sz="1200" i="1" dirty="0" err="1"/>
-              <a:t>dynamic</a:t>
-            </a:r>
-            <a:r>
-              <a:rPr lang="de-DE" sz="1200" i="1" dirty="0"/>
-              <a:t> </a:t>
-            </a:r>
-            <a:r>
-              <a:rPr lang="de-DE" sz="1200" i="1" dirty="0" err="1"/>
-              <a:t>or</a:t>
-            </a:r>
-            <a:r>
-              <a:rPr lang="de-DE" sz="1200" i="1" dirty="0"/>
-              <a:t> </a:t>
-            </a:r>
-            <a:br>
-              <a:rPr lang="de-DE" sz="1200" i="1" dirty="0"/>
-            </a:br>
-            <a:r>
-              <a:rPr lang="de-DE" sz="1200" i="1" dirty="0" err="1"/>
-              <a:t>configured</a:t>
-            </a:r>
-            <a:r>
-              <a:rPr lang="de-DE" sz="1200" i="1" dirty="0"/>
-              <a:t> </a:t>
-            </a:r>
-            <a:r>
-              <a:rPr lang="de-DE" sz="1200" i="1" dirty="0" err="1"/>
-              <a:t>range</a:t>
-            </a:r>
-            <a:r>
-              <a:rPr lang="de-DE" sz="1400" dirty="0"/>
-              <a:t>)</a:t>
-            </a:r>
-            <a:endParaRPr lang="en-GB" sz="1600" dirty="0"/>
-          </a:p>
-        </p:txBody>
-      </p:sp>
+        </p:nvGrpSpPr>
+        <p:grpSpPr>
+          <a:xfrm>
+            <a:off x="7108845" y="5259189"/>
+            <a:ext cx="1687183" cy="527782"/>
+            <a:chOff x="7099880" y="5312979"/>
+            <a:chExt cx="1687183" cy="527782"/>
+          </a:xfrm>
+        </p:grpSpPr>
+        <p:sp>
+          <p:nvSpPr>
+            <p:cNvPr id="82" name="Textfeld 81">
+              <a:extLst>
+                <a:ext uri="{FF2B5EF4-FFF2-40B4-BE49-F238E27FC236}">
+                  <a16:creationId xmlns:a16="http://schemas.microsoft.com/office/drawing/2014/main" id="{628665A9-6B92-45BF-B501-3E63E2BD6C25}"/>
+                </a:ext>
+              </a:extLst>
+            </p:cNvPr>
+            <p:cNvSpPr txBox="1"/>
+            <p:nvPr/>
+          </p:nvSpPr>
+          <p:spPr>
+            <a:xfrm>
+              <a:off x="7099880" y="5312979"/>
+              <a:ext cx="1373891" cy="307777"/>
+            </a:xfrm>
+            <a:prstGeom prst="rect">
+              <a:avLst/>
+            </a:prstGeom>
+            <a:noFill/>
+          </p:spPr>
+          <p:txBody>
+            <a:bodyPr wrap="square" rtlCol="0">
+              <a:spAutoFit/>
+            </a:bodyPr>
+            <a:lstStyle>
+              <a:defPPr>
+                <a:defRPr lang="en-US"/>
+              </a:defPPr>
+              <a:lvl1pPr algn="ctr"/>
+            </a:lstStyle>
+            <a:p>
+              <a:pPr algn="l"/>
+              <a:r>
+                <a:rPr lang="de-DE" sz="1400" b="1" dirty="0"/>
+                <a:t>Data </a:t>
+              </a:r>
+              <a:r>
+                <a:rPr lang="de-DE" sz="1400" b="1" dirty="0" err="1"/>
+                <a:t>ports</a:t>
+              </a:r>
+              <a:endParaRPr lang="de-DE" sz="1400" b="1" dirty="0"/>
+            </a:p>
+          </p:txBody>
+        </p:sp>
+        <p:sp>
+          <p:nvSpPr>
+            <p:cNvPr id="116" name="Textfeld 115">
+              <a:extLst>
+                <a:ext uri="{FF2B5EF4-FFF2-40B4-BE49-F238E27FC236}">
+                  <a16:creationId xmlns:a16="http://schemas.microsoft.com/office/drawing/2014/main" id="{31470ACF-55D1-436D-BEA0-5B2184EE9B54}"/>
+                </a:ext>
+              </a:extLst>
+            </p:cNvPr>
+            <p:cNvSpPr txBox="1"/>
+            <p:nvPr/>
+          </p:nvSpPr>
+          <p:spPr>
+            <a:xfrm>
+              <a:off x="7202302" y="5532984"/>
+              <a:ext cx="1584761" cy="307777"/>
+            </a:xfrm>
+            <a:prstGeom prst="rect">
+              <a:avLst/>
+            </a:prstGeom>
+            <a:noFill/>
+          </p:spPr>
+          <p:txBody>
+            <a:bodyPr wrap="square" rtlCol="0">
+              <a:spAutoFit/>
+            </a:bodyPr>
+            <a:lstStyle>
+              <a:defPPr>
+                <a:defRPr lang="en-US"/>
+              </a:defPPr>
+              <a:lvl1pPr algn="ctr"/>
+            </a:lstStyle>
+            <a:p>
+              <a:pPr algn="l"/>
+              <a:r>
+                <a:rPr lang="de-DE" sz="1400" i="1" dirty="0"/>
+                <a:t>(</a:t>
+              </a:r>
+              <a:r>
+                <a:rPr lang="de-DE" sz="1200" i="1" dirty="0" err="1"/>
+                <a:t>dynamic</a:t>
+              </a:r>
+              <a:r>
+                <a:rPr lang="de-DE" sz="1400" i="1" dirty="0"/>
+                <a:t>)</a:t>
+              </a:r>
+              <a:endParaRPr lang="en-GB" sz="1600" i="1" dirty="0"/>
+            </a:p>
+          </p:txBody>
+        </p:sp>
+      </p:grpSp>
       <p:pic>
         <p:nvPicPr>
           <p:cNvPr id="123" name="Grafik 122">
@@ -4194,8 +4095,8 @@
         </p:blipFill>
         <p:spPr>
           <a:xfrm>
-            <a:off x="7498744" y="2428278"/>
-            <a:ext cx="731542" cy="1066928"/>
+            <a:off x="7645109" y="2326527"/>
+            <a:ext cx="699532" cy="1020242"/>
           </a:xfrm>
           <a:prstGeom prst="rect">
             <a:avLst/>
@@ -4216,8 +4117,8 @@
         </p:nvSpPr>
         <p:spPr>
           <a:xfrm>
-            <a:off x="1796907" y="2096650"/>
-            <a:ext cx="928459" cy="430887"/>
+            <a:off x="1756150" y="1821390"/>
+            <a:ext cx="894200" cy="430887"/>
           </a:xfrm>
           <a:prstGeom prst="rect">
             <a:avLst/>
@@ -4225,7 +4126,7 @@
           <a:noFill/>
         </p:spPr>
         <p:txBody>
-          <a:bodyPr wrap="none" rtlCol="0">
+          <a:bodyPr wrap="square" rtlCol="0">
             <a:spAutoFit/>
           </a:bodyPr>
           <a:lstStyle/>
@@ -4271,7 +4172,7 @@
         </p:nvSpPr>
         <p:spPr>
           <a:xfrm>
-            <a:off x="5123050" y="1449976"/>
+            <a:off x="5142979" y="1215935"/>
             <a:ext cx="1698735" cy="307777"/>
           </a:xfrm>
           <a:prstGeom prst="rect">
@@ -4339,7 +4240,7 @@
         </p:nvSpPr>
         <p:spPr>
           <a:xfrm>
-            <a:off x="5293323" y="2091000"/>
+            <a:off x="5287652" y="1840558"/>
             <a:ext cx="1319592" cy="430887"/>
           </a:xfrm>
           <a:prstGeom prst="rect">
@@ -4411,7 +4312,7 @@
         </p:nvSpPr>
         <p:spPr>
           <a:xfrm>
-            <a:off x="3509186" y="4227838"/>
+            <a:off x="3509186" y="4165083"/>
             <a:ext cx="1362874" cy="261610"/>
           </a:xfrm>
           <a:prstGeom prst="rect">
@@ -4463,7 +4364,7 @@
         </p:nvSpPr>
         <p:spPr>
           <a:xfrm>
-            <a:off x="4036525" y="3890060"/>
+            <a:off x="4036525" y="3881095"/>
             <a:ext cx="295324" cy="310219"/>
           </a:xfrm>
           <a:prstGeom prst="ellipse">
@@ -4520,8 +4421,8 @@
         </p:nvCxnSpPr>
         <p:spPr>
           <a:xfrm rot="16200000" flipH="1">
-            <a:off x="3674031" y="2427635"/>
-            <a:ext cx="656837" cy="5496709"/>
+            <a:off x="3676328" y="2425338"/>
+            <a:ext cx="652242" cy="5496709"/>
           </a:xfrm>
           <a:prstGeom prst="bentConnector2">
             <a:avLst/>
@@ -4567,8 +4468,8 @@
         </p:nvCxnSpPr>
         <p:spPr>
           <a:xfrm rot="16200000" flipH="1">
-            <a:off x="3655176" y="2446490"/>
-            <a:ext cx="759850" cy="5562013"/>
+            <a:off x="3657474" y="2444192"/>
+            <a:ext cx="755255" cy="5562013"/>
           </a:xfrm>
           <a:prstGeom prst="bentConnector2">
             <a:avLst/>
@@ -4614,8 +4515,8 @@
         </p:nvCxnSpPr>
         <p:spPr>
           <a:xfrm rot="16200000" flipH="1">
-            <a:off x="3693687" y="2407979"/>
-            <a:ext cx="563361" cy="5442545"/>
+            <a:off x="3695984" y="2405682"/>
+            <a:ext cx="558766" cy="5442545"/>
           </a:xfrm>
           <a:prstGeom prst="bentConnector2">
             <a:avLst/>
@@ -4708,15 +4609,14 @@
           </p:cNvPr>
           <p:cNvCxnSpPr>
             <a:cxnSpLocks/>
-            <a:stCxn id="98" idx="3"/>
             <a:endCxn id="43" idx="1"/>
           </p:cNvCxnSpPr>
           <p:nvPr/>
         </p:nvCxnSpPr>
         <p:spPr>
           <a:xfrm>
-            <a:off x="5071941" y="1890198"/>
-            <a:ext cx="1700486" cy="15088"/>
+            <a:off x="5071941" y="1673951"/>
+            <a:ext cx="1700486" cy="13864"/>
           </a:xfrm>
           <a:prstGeom prst="straightConnector1">
             <a:avLst/>
@@ -4755,14 +4655,14 @@
         </p:nvSpPr>
         <p:spPr>
           <a:xfrm>
-            <a:off x="5805644" y="1757753"/>
+            <a:off x="5814422" y="1516139"/>
             <a:ext cx="295324" cy="310219"/>
           </a:xfrm>
           <a:prstGeom prst="ellipse">
             <a:avLst/>
           </a:prstGeom>
           <a:solidFill>
-            <a:srgbClr val="00B0F0"/>
+            <a:srgbClr val="009AD0"/>
           </a:solidFill>
         </p:spPr>
         <p:style>
@@ -4794,6 +4694,384 @@
           </a:p>
         </p:txBody>
       </p:sp>
+      <p:grpSp>
+        <p:nvGrpSpPr>
+          <p:cNvPr id="11" name="Gruppieren 10">
+            <a:extLst>
+              <a:ext uri="{FF2B5EF4-FFF2-40B4-BE49-F238E27FC236}">
+                <a16:creationId xmlns:a16="http://schemas.microsoft.com/office/drawing/2014/main" id="{A659B9A2-10A8-4123-86DC-49A1ACD3199C}"/>
+              </a:ext>
+            </a:extLst>
+          </p:cNvPr>
+          <p:cNvGrpSpPr/>
+          <p:nvPr/>
+        </p:nvGrpSpPr>
+        <p:grpSpPr>
+          <a:xfrm>
+            <a:off x="7118266" y="3793587"/>
+            <a:ext cx="998937" cy="534180"/>
+            <a:chOff x="7073441" y="3874272"/>
+            <a:chExt cx="998937" cy="534180"/>
+          </a:xfrm>
+        </p:grpSpPr>
+        <p:sp>
+          <p:nvSpPr>
+            <p:cNvPr id="81" name="Textfeld 80">
+              <a:extLst>
+                <a:ext uri="{FF2B5EF4-FFF2-40B4-BE49-F238E27FC236}">
+                  <a16:creationId xmlns:a16="http://schemas.microsoft.com/office/drawing/2014/main" id="{FC978FC2-35B3-4F1D-95B3-319D19302808}"/>
+                </a:ext>
+              </a:extLst>
+            </p:cNvPr>
+            <p:cNvSpPr txBox="1"/>
+            <p:nvPr/>
+          </p:nvSpPr>
+          <p:spPr>
+            <a:xfrm>
+              <a:off x="7076574" y="3874272"/>
+              <a:ext cx="980397" cy="307777"/>
+            </a:xfrm>
+            <a:prstGeom prst="rect">
+              <a:avLst/>
+            </a:prstGeom>
+            <a:noFill/>
+          </p:spPr>
+          <p:txBody>
+            <a:bodyPr wrap="none" rtlCol="0">
+              <a:spAutoFit/>
+            </a:bodyPr>
+            <a:lstStyle>
+              <a:defPPr>
+                <a:defRPr lang="en-US"/>
+              </a:defPPr>
+              <a:lvl1pPr algn="ctr"/>
+            </a:lstStyle>
+            <a:p>
+              <a:pPr algn="l"/>
+              <a:r>
+                <a:rPr lang="de-DE" sz="1400" b="1" dirty="0"/>
+                <a:t>Listen </a:t>
+              </a:r>
+              <a:r>
+                <a:rPr lang="de-DE" sz="1400" b="1" dirty="0" err="1"/>
+                <a:t>port</a:t>
+              </a:r>
+              <a:endParaRPr lang="en-GB" sz="1400" b="1" dirty="0"/>
+            </a:p>
+          </p:txBody>
+        </p:sp>
+        <p:sp>
+          <p:nvSpPr>
+            <p:cNvPr id="41" name="Textfeld 40">
+              <a:extLst>
+                <a:ext uri="{FF2B5EF4-FFF2-40B4-BE49-F238E27FC236}">
+                  <a16:creationId xmlns:a16="http://schemas.microsoft.com/office/drawing/2014/main" id="{746E10DE-9CAB-467B-B662-76E86EB3CB7E}"/>
+                </a:ext>
+              </a:extLst>
+            </p:cNvPr>
+            <p:cNvSpPr txBox="1"/>
+            <p:nvPr/>
+          </p:nvSpPr>
+          <p:spPr>
+            <a:xfrm>
+              <a:off x="7073441" y="4100675"/>
+              <a:ext cx="998937" cy="307777"/>
+            </a:xfrm>
+            <a:prstGeom prst="rect">
+              <a:avLst/>
+            </a:prstGeom>
+            <a:noFill/>
+          </p:spPr>
+          <p:txBody>
+            <a:bodyPr wrap="square" rtlCol="0">
+              <a:spAutoFit/>
+            </a:bodyPr>
+            <a:lstStyle>
+              <a:defPPr>
+                <a:defRPr lang="en-US"/>
+              </a:defPPr>
+              <a:lvl1pPr algn="ctr"/>
+            </a:lstStyle>
+            <a:p>
+              <a:r>
+                <a:rPr lang="de-DE" sz="1400" i="1" dirty="0"/>
+                <a:t>(</a:t>
+              </a:r>
+              <a:r>
+                <a:rPr lang="de-DE" sz="1200" i="1" dirty="0"/>
+                <a:t>64434</a:t>
+              </a:r>
+              <a:r>
+                <a:rPr lang="de-DE" sz="1400" i="1" dirty="0"/>
+                <a:t>)</a:t>
+              </a:r>
+              <a:endParaRPr lang="en-GB" sz="1600" i="1" dirty="0"/>
+            </a:p>
+          </p:txBody>
+        </p:sp>
+      </p:grpSp>
+      <p:grpSp>
+        <p:nvGrpSpPr>
+          <p:cNvPr id="10" name="Gruppieren 9">
+            <a:extLst>
+              <a:ext uri="{FF2B5EF4-FFF2-40B4-BE49-F238E27FC236}">
+                <a16:creationId xmlns:a16="http://schemas.microsoft.com/office/drawing/2014/main" id="{9DD91F54-5820-41DF-8208-F3AE3283D91E}"/>
+              </a:ext>
+            </a:extLst>
+          </p:cNvPr>
+          <p:cNvGrpSpPr/>
+          <p:nvPr/>
+        </p:nvGrpSpPr>
+        <p:grpSpPr>
+          <a:xfrm>
+            <a:off x="7078811" y="1429184"/>
+            <a:ext cx="1306768" cy="526483"/>
+            <a:chOff x="7078811" y="1527799"/>
+            <a:chExt cx="1306768" cy="526483"/>
+          </a:xfrm>
+        </p:grpSpPr>
+        <p:sp>
+          <p:nvSpPr>
+            <p:cNvPr id="80" name="Textfeld 79">
+              <a:extLst>
+                <a:ext uri="{FF2B5EF4-FFF2-40B4-BE49-F238E27FC236}">
+                  <a16:creationId xmlns:a16="http://schemas.microsoft.com/office/drawing/2014/main" id="{D5D798D5-8C66-432F-9176-7A715B9C0170}"/>
+                </a:ext>
+              </a:extLst>
+            </p:cNvPr>
+            <p:cNvSpPr txBox="1"/>
+            <p:nvPr/>
+          </p:nvSpPr>
+          <p:spPr>
+            <a:xfrm>
+              <a:off x="7078811" y="1527799"/>
+              <a:ext cx="1306768" cy="307777"/>
+            </a:xfrm>
+            <a:prstGeom prst="rect">
+              <a:avLst/>
+            </a:prstGeom>
+            <a:noFill/>
+          </p:spPr>
+          <p:txBody>
+            <a:bodyPr wrap="none" rtlCol="0">
+              <a:spAutoFit/>
+            </a:bodyPr>
+            <a:lstStyle/>
+            <a:p>
+              <a:r>
+                <a:rPr lang="de-DE" sz="1400" b="1" dirty="0"/>
+                <a:t>Command </a:t>
+              </a:r>
+              <a:r>
+                <a:rPr lang="de-DE" sz="1400" b="1" dirty="0" err="1"/>
+                <a:t>port</a:t>
+              </a:r>
+              <a:endParaRPr lang="en-GB" sz="1400" dirty="0"/>
+            </a:p>
+          </p:txBody>
+        </p:sp>
+        <p:sp>
+          <p:nvSpPr>
+            <p:cNvPr id="48" name="Textfeld 47">
+              <a:extLst>
+                <a:ext uri="{FF2B5EF4-FFF2-40B4-BE49-F238E27FC236}">
+                  <a16:creationId xmlns:a16="http://schemas.microsoft.com/office/drawing/2014/main" id="{DC453651-1C11-4A41-A88D-51D242C07A46}"/>
+                </a:ext>
+              </a:extLst>
+            </p:cNvPr>
+            <p:cNvSpPr txBox="1"/>
+            <p:nvPr/>
+          </p:nvSpPr>
+          <p:spPr>
+            <a:xfrm>
+              <a:off x="7359275" y="1746505"/>
+              <a:ext cx="699532" cy="307777"/>
+            </a:xfrm>
+            <a:prstGeom prst="rect">
+              <a:avLst/>
+            </a:prstGeom>
+            <a:noFill/>
+          </p:spPr>
+          <p:txBody>
+            <a:bodyPr wrap="square" rtlCol="0">
+              <a:spAutoFit/>
+            </a:bodyPr>
+            <a:lstStyle>
+              <a:defPPr>
+                <a:defRPr lang="en-US"/>
+              </a:defPPr>
+              <a:lvl1pPr algn="ctr"/>
+            </a:lstStyle>
+            <a:p>
+              <a:r>
+                <a:rPr lang="de-DE" sz="1400" i="1" dirty="0"/>
+                <a:t>(</a:t>
+              </a:r>
+              <a:r>
+                <a:rPr lang="de-DE" sz="1200" i="1" dirty="0"/>
+                <a:t>64435</a:t>
+              </a:r>
+              <a:r>
+                <a:rPr lang="de-DE" sz="1400" i="1" dirty="0"/>
+                <a:t>)</a:t>
+              </a:r>
+              <a:endParaRPr lang="en-GB" sz="1600" i="1" dirty="0"/>
+            </a:p>
+          </p:txBody>
+        </p:sp>
+      </p:grpSp>
+      <p:sp>
+        <p:nvSpPr>
+          <p:cNvPr id="50" name="Rechteck 49">
+            <a:extLst>
+              <a:ext uri="{FF2B5EF4-FFF2-40B4-BE49-F238E27FC236}">
+                <a16:creationId xmlns:a16="http://schemas.microsoft.com/office/drawing/2014/main" id="{37633738-1586-4146-B162-BCF218A3B8B1}"/>
+              </a:ext>
+            </a:extLst>
+          </p:cNvPr>
+          <p:cNvSpPr/>
+          <p:nvPr/>
+        </p:nvSpPr>
+        <p:spPr>
+          <a:xfrm>
+            <a:off x="3196253" y="1585508"/>
+            <a:ext cx="288000" cy="180000"/>
+          </a:xfrm>
+          <a:prstGeom prst="rect">
+            <a:avLst/>
+          </a:prstGeom>
+          <a:solidFill>
+            <a:srgbClr val="00B0F0"/>
+          </a:solidFill>
+          <a:ln>
+            <a:solidFill>
+              <a:srgbClr val="0070C0"/>
+            </a:solidFill>
+          </a:ln>
+        </p:spPr>
+        <p:style>
+          <a:lnRef idx="2">
+            <a:schemeClr val="accent1">
+              <a:shade val="50000"/>
+            </a:schemeClr>
+          </a:lnRef>
+          <a:fillRef idx="1">
+            <a:schemeClr val="accent1"/>
+          </a:fillRef>
+          <a:effectRef idx="0">
+            <a:schemeClr val="accent1"/>
+          </a:effectRef>
+          <a:fontRef idx="minor">
+            <a:schemeClr val="lt1"/>
+          </a:fontRef>
+        </p:style>
+        <p:txBody>
+          <a:bodyPr rtlCol="0" anchor="ctr"/>
+          <a:lstStyle/>
+          <a:p>
+            <a:pPr algn="ctr"/>
+            <a:endParaRPr lang="en-GB" sz="1350"/>
+          </a:p>
+        </p:txBody>
+      </p:sp>
+      <p:grpSp>
+        <p:nvGrpSpPr>
+          <p:cNvPr id="13" name="Gruppieren 12">
+            <a:extLst>
+              <a:ext uri="{FF2B5EF4-FFF2-40B4-BE49-F238E27FC236}">
+                <a16:creationId xmlns:a16="http://schemas.microsoft.com/office/drawing/2014/main" id="{2A985729-809F-4817-9DC3-7C3CD8298F76}"/>
+              </a:ext>
+            </a:extLst>
+          </p:cNvPr>
+          <p:cNvGrpSpPr/>
+          <p:nvPr/>
+        </p:nvGrpSpPr>
+        <p:grpSpPr>
+          <a:xfrm>
+            <a:off x="3134068" y="1449339"/>
+            <a:ext cx="1233366" cy="499246"/>
+            <a:chOff x="3134068" y="1494164"/>
+            <a:chExt cx="1233366" cy="499246"/>
+          </a:xfrm>
+        </p:grpSpPr>
+        <p:sp>
+          <p:nvSpPr>
+            <p:cNvPr id="49" name="Textfeld 48">
+              <a:extLst>
+                <a:ext uri="{FF2B5EF4-FFF2-40B4-BE49-F238E27FC236}">
+                  <a16:creationId xmlns:a16="http://schemas.microsoft.com/office/drawing/2014/main" id="{6D3BDD77-1D8F-41B5-B177-55EA84734BF7}"/>
+                </a:ext>
+              </a:extLst>
+            </p:cNvPr>
+            <p:cNvSpPr txBox="1"/>
+            <p:nvPr/>
+          </p:nvSpPr>
+          <p:spPr>
+            <a:xfrm>
+              <a:off x="3134068" y="1716411"/>
+              <a:ext cx="1233366" cy="276999"/>
+            </a:xfrm>
+            <a:prstGeom prst="rect">
+              <a:avLst/>
+            </a:prstGeom>
+            <a:noFill/>
+          </p:spPr>
+          <p:txBody>
+            <a:bodyPr wrap="square" rtlCol="0">
+              <a:spAutoFit/>
+            </a:bodyPr>
+            <a:lstStyle>
+              <a:defPPr>
+                <a:defRPr lang="en-US"/>
+              </a:defPPr>
+              <a:lvl1pPr algn="ctr"/>
+            </a:lstStyle>
+            <a:p>
+              <a:r>
+                <a:rPr lang="de-DE" sz="1200" i="1" dirty="0"/>
+                <a:t>(9000)</a:t>
+              </a:r>
+              <a:endParaRPr lang="en-GB" sz="1600" dirty="0"/>
+            </a:p>
+          </p:txBody>
+        </p:sp>
+        <p:sp>
+          <p:nvSpPr>
+            <p:cNvPr id="51" name="Textfeld 50">
+              <a:extLst>
+                <a:ext uri="{FF2B5EF4-FFF2-40B4-BE49-F238E27FC236}">
+                  <a16:creationId xmlns:a16="http://schemas.microsoft.com/office/drawing/2014/main" id="{D123356D-692E-4AEC-A589-A04B3771E8B9}"/>
+                </a:ext>
+              </a:extLst>
+            </p:cNvPr>
+            <p:cNvSpPr txBox="1"/>
+            <p:nvPr/>
+          </p:nvSpPr>
+          <p:spPr>
+            <a:xfrm>
+              <a:off x="3500362" y="1494164"/>
+              <a:ext cx="500778" cy="307777"/>
+            </a:xfrm>
+            <a:prstGeom prst="rect">
+              <a:avLst/>
+            </a:prstGeom>
+            <a:noFill/>
+          </p:spPr>
+          <p:txBody>
+            <a:bodyPr wrap="none" rtlCol="0">
+              <a:spAutoFit/>
+            </a:bodyPr>
+            <a:lstStyle/>
+            <a:p>
+              <a:r>
+                <a:rPr lang="de-DE" sz="1400" b="1" dirty="0"/>
+                <a:t>Port</a:t>
+              </a:r>
+              <a:endParaRPr lang="en-GB" sz="1400" dirty="0"/>
+            </a:p>
+          </p:txBody>
+        </p:sp>
+      </p:grpSp>
     </p:spTree>
     <p:extLst>
       <p:ext uri="{BB962C8B-B14F-4D97-AF65-F5344CB8AC3E}">

</xml_diff>

<commit_message>
add additional info for test installation
</commit_message>
<xml_diff>
--- a/source/_static/test-uftp-setup.pptx
+++ b/source/_static/test-uftp-setup.pptx
@@ -3950,123 +3950,126 @@
           </a:p>
         </p:txBody>
       </p:sp>
-      <p:grpSp>
-        <p:nvGrpSpPr>
-          <p:cNvPr id="12" name="Gruppieren 11">
+      <p:sp>
+        <p:nvSpPr>
+          <p:cNvPr id="82" name="Textfeld 81">
             <a:extLst>
               <a:ext uri="{FF2B5EF4-FFF2-40B4-BE49-F238E27FC236}">
-                <a16:creationId xmlns:a16="http://schemas.microsoft.com/office/drawing/2014/main" id="{03DE91A1-D770-4696-9205-2BE438F01105}"/>
+                <a16:creationId xmlns:a16="http://schemas.microsoft.com/office/drawing/2014/main" id="{628665A9-6B92-45BF-B501-3E63E2BD6C25}"/>
               </a:ext>
             </a:extLst>
           </p:cNvPr>
-          <p:cNvGrpSpPr/>
+          <p:cNvSpPr txBox="1"/>
           <p:nvPr/>
-        </p:nvGrpSpPr>
-        <p:grpSpPr>
+        </p:nvSpPr>
+        <p:spPr>
           <a:xfrm>
             <a:off x="7108845" y="5259189"/>
-            <a:ext cx="1687183" cy="527782"/>
-            <a:chOff x="7099880" y="5312979"/>
-            <a:chExt cx="1687183" cy="527782"/>
-          </a:xfrm>
-        </p:grpSpPr>
-        <p:sp>
-          <p:nvSpPr>
-            <p:cNvPr id="82" name="Textfeld 81">
-              <a:extLst>
-                <a:ext uri="{FF2B5EF4-FFF2-40B4-BE49-F238E27FC236}">
-                  <a16:creationId xmlns:a16="http://schemas.microsoft.com/office/drawing/2014/main" id="{628665A9-6B92-45BF-B501-3E63E2BD6C25}"/>
-                </a:ext>
-              </a:extLst>
-            </p:cNvPr>
-            <p:cNvSpPr txBox="1"/>
-            <p:nvPr/>
-          </p:nvSpPr>
-          <p:spPr>
-            <a:xfrm>
-              <a:off x="7099880" y="5312979"/>
-              <a:ext cx="1373891" cy="307777"/>
-            </a:xfrm>
-            <a:prstGeom prst="rect">
-              <a:avLst/>
-            </a:prstGeom>
-            <a:noFill/>
-          </p:spPr>
-          <p:txBody>
-            <a:bodyPr wrap="square" rtlCol="0">
-              <a:spAutoFit/>
-            </a:bodyPr>
-            <a:lstStyle>
-              <a:defPPr>
-                <a:defRPr lang="en-US"/>
-              </a:defPPr>
-              <a:lvl1pPr algn="ctr"/>
-            </a:lstStyle>
-            <a:p>
-              <a:pPr algn="l"/>
-              <a:r>
-                <a:rPr lang="de-DE" sz="1400" b="1" dirty="0"/>
-                <a:t>Data </a:t>
-              </a:r>
-              <a:r>
-                <a:rPr lang="de-DE" sz="1400" b="1" dirty="0" err="1"/>
-                <a:t>ports</a:t>
-              </a:r>
-              <a:endParaRPr lang="de-DE" sz="1400" b="1" dirty="0"/>
-            </a:p>
-          </p:txBody>
-        </p:sp>
-        <p:sp>
-          <p:nvSpPr>
-            <p:cNvPr id="116" name="Textfeld 115">
-              <a:extLst>
-                <a:ext uri="{FF2B5EF4-FFF2-40B4-BE49-F238E27FC236}">
-                  <a16:creationId xmlns:a16="http://schemas.microsoft.com/office/drawing/2014/main" id="{31470ACF-55D1-436D-BEA0-5B2184EE9B54}"/>
-                </a:ext>
-              </a:extLst>
-            </p:cNvPr>
-            <p:cNvSpPr txBox="1"/>
-            <p:nvPr/>
-          </p:nvSpPr>
-          <p:spPr>
-            <a:xfrm>
-              <a:off x="7202302" y="5532984"/>
-              <a:ext cx="1584761" cy="307777"/>
-            </a:xfrm>
-            <a:prstGeom prst="rect">
-              <a:avLst/>
-            </a:prstGeom>
-            <a:noFill/>
-          </p:spPr>
-          <p:txBody>
-            <a:bodyPr wrap="square" rtlCol="0">
-              <a:spAutoFit/>
-            </a:bodyPr>
-            <a:lstStyle>
-              <a:defPPr>
-                <a:defRPr lang="en-US"/>
-              </a:defPPr>
-              <a:lvl1pPr algn="ctr"/>
-            </a:lstStyle>
-            <a:p>
-              <a:pPr algn="l"/>
-              <a:r>
-                <a:rPr lang="de-DE" sz="1400" i="1" dirty="0"/>
-                <a:t>(</a:t>
-              </a:r>
-              <a:r>
-                <a:rPr lang="de-DE" sz="1200" i="1" dirty="0" err="1"/>
-                <a:t>dynamic</a:t>
-              </a:r>
-              <a:r>
-                <a:rPr lang="de-DE" sz="1400" i="1" dirty="0"/>
-                <a:t>)</a:t>
-              </a:r>
-              <a:endParaRPr lang="en-GB" sz="1600" i="1" dirty="0"/>
-            </a:p>
-          </p:txBody>
-        </p:sp>
-      </p:grpSp>
+            <a:ext cx="1373891" cy="307777"/>
+          </a:xfrm>
+          <a:prstGeom prst="rect">
+            <a:avLst/>
+          </a:prstGeom>
+          <a:noFill/>
+        </p:spPr>
+        <p:txBody>
+          <a:bodyPr wrap="square" rtlCol="0">
+            <a:spAutoFit/>
+          </a:bodyPr>
+          <a:lstStyle>
+            <a:defPPr>
+              <a:defRPr lang="en-US"/>
+            </a:defPPr>
+            <a:lvl1pPr algn="ctr"/>
+          </a:lstStyle>
+          <a:p>
+            <a:pPr algn="l"/>
+            <a:r>
+              <a:rPr lang="de-DE" sz="1400" b="1" dirty="0"/>
+              <a:t>Data </a:t>
+            </a:r>
+            <a:r>
+              <a:rPr lang="de-DE" sz="1400" b="1" dirty="0" err="1"/>
+              <a:t>ports</a:t>
+            </a:r>
+            <a:endParaRPr lang="de-DE" sz="1400" b="1" dirty="0"/>
+          </a:p>
+        </p:txBody>
+      </p:sp>
+      <p:sp>
+        <p:nvSpPr>
+          <p:cNvPr id="116" name="Textfeld 115">
+            <a:extLst>
+              <a:ext uri="{FF2B5EF4-FFF2-40B4-BE49-F238E27FC236}">
+                <a16:creationId xmlns:a16="http://schemas.microsoft.com/office/drawing/2014/main" id="{31470ACF-55D1-436D-BEA0-5B2184EE9B54}"/>
+              </a:ext>
+            </a:extLst>
+          </p:cNvPr>
+          <p:cNvSpPr txBox="1"/>
+          <p:nvPr/>
+        </p:nvSpPr>
+        <p:spPr>
+          <a:xfrm>
+            <a:off x="7094722" y="5479194"/>
+            <a:ext cx="2040532" cy="307777"/>
+          </a:xfrm>
+          <a:prstGeom prst="rect">
+            <a:avLst/>
+          </a:prstGeom>
+          <a:noFill/>
+        </p:spPr>
+        <p:txBody>
+          <a:bodyPr wrap="square" rtlCol="0">
+            <a:spAutoFit/>
+          </a:bodyPr>
+          <a:lstStyle>
+            <a:defPPr>
+              <a:defRPr lang="en-US"/>
+            </a:defPPr>
+            <a:lvl1pPr algn="ctr"/>
+          </a:lstStyle>
+          <a:p>
+            <a:pPr algn="l"/>
+            <a:r>
+              <a:rPr lang="de-DE" sz="1400" i="1" dirty="0"/>
+              <a:t>(</a:t>
+            </a:r>
+            <a:r>
+              <a:rPr lang="de-DE" sz="1200" i="1" dirty="0" err="1"/>
+              <a:t>dynamic</a:t>
+            </a:r>
+            <a:r>
+              <a:rPr lang="de-DE" sz="1200" i="1" dirty="0"/>
+              <a:t> </a:t>
+            </a:r>
+            <a:r>
+              <a:rPr lang="de-DE" sz="1200" i="1" dirty="0" err="1"/>
+              <a:t>or</a:t>
+            </a:r>
+            <a:r>
+              <a:rPr lang="de-DE" sz="1200" i="1" dirty="0"/>
+              <a:t> </a:t>
+            </a:r>
+            <a:r>
+              <a:rPr lang="de-DE" sz="1200" i="1" dirty="0" err="1"/>
+              <a:t>fixed</a:t>
+            </a:r>
+            <a:r>
+              <a:rPr lang="de-DE" sz="1200" i="1" dirty="0"/>
+              <a:t> </a:t>
+            </a:r>
+            <a:r>
+              <a:rPr lang="de-DE" sz="1200" i="1" dirty="0" err="1"/>
+              <a:t>range</a:t>
+            </a:r>
+            <a:r>
+              <a:rPr lang="de-DE" sz="1400" i="1" dirty="0"/>
+              <a:t>)</a:t>
+            </a:r>
+            <a:endParaRPr lang="en-GB" sz="1600" i="1" dirty="0"/>
+          </a:p>
+        </p:txBody>
+      </p:sp>
       <p:pic>
         <p:nvPicPr>
           <p:cNvPr id="123" name="Grafik 122">

</xml_diff>

<commit_message>
small corrections on figure
</commit_message>
<xml_diff>
--- a/source/_static/test-uftp-setup.pptx
+++ b/source/_static/test-uftp-setup.pptx
@@ -2989,7 +2989,7 @@
         </p:nvCxnSpPr>
         <p:spPr>
           <a:xfrm>
-            <a:off x="2236350" y="4034180"/>
+            <a:off x="2101875" y="4034180"/>
             <a:ext cx="4529814" cy="4930"/>
           </a:xfrm>
           <a:prstGeom prst="straightConnector1">
@@ -3029,7 +3029,7 @@
         </p:nvSpPr>
         <p:spPr>
           <a:xfrm>
-            <a:off x="3329610" y="620372"/>
+            <a:off x="3195135" y="620372"/>
             <a:ext cx="1715470" cy="584775"/>
           </a:xfrm>
           <a:prstGeom prst="rect">
@@ -3085,7 +3085,7 @@
         </p:nvCxnSpPr>
         <p:spPr>
           <a:xfrm rot="5400000" flipH="1" flipV="1">
-            <a:off x="1452535" y="1477069"/>
+            <a:off x="1318060" y="1477069"/>
             <a:ext cx="1545279" cy="1942158"/>
           </a:xfrm>
           <a:prstGeom prst="bentConnector2">
@@ -3125,7 +3125,7 @@
         </p:nvSpPr>
         <p:spPr>
           <a:xfrm>
-            <a:off x="1226495" y="1207003"/>
+            <a:off x="1092020" y="1207003"/>
             <a:ext cx="1907573" cy="307777"/>
           </a:xfrm>
           <a:prstGeom prst="rect">
@@ -3178,8 +3178,8 @@
         </p:nvSpPr>
         <p:spPr>
           <a:xfrm>
-            <a:off x="3212964" y="3562451"/>
-            <a:ext cx="1929695" cy="307777"/>
+            <a:off x="3078489" y="3562451"/>
+            <a:ext cx="1869230" cy="307777"/>
           </a:xfrm>
           <a:prstGeom prst="rect">
             <a:avLst/>
@@ -3198,7 +3198,31 @@
                   <a:srgbClr val="0070C0"/>
                 </a:solidFill>
               </a:rPr>
-              <a:t>FTP Control Connection</a:t>
+              <a:t>FTP </a:t>
+            </a:r>
+            <a:r>
+              <a:rPr lang="de-DE" sz="1400" b="1" i="1" dirty="0" err="1">
+                <a:solidFill>
+                  <a:srgbClr val="0070C0"/>
+                </a:solidFill>
+              </a:rPr>
+              <a:t>control</a:t>
+            </a:r>
+            <a:r>
+              <a:rPr lang="de-DE" sz="1400" b="1" i="1" dirty="0">
+                <a:solidFill>
+                  <a:srgbClr val="0070C0"/>
+                </a:solidFill>
+              </a:rPr>
+              <a:t> </a:t>
+            </a:r>
+            <a:r>
+              <a:rPr lang="de-DE" sz="1400" b="1" i="1" dirty="0" err="1">
+                <a:solidFill>
+                  <a:srgbClr val="0070C0"/>
+                </a:solidFill>
+              </a:rPr>
+              <a:t>connection</a:t>
             </a:r>
             <a:endParaRPr lang="en-GB" sz="1400" b="1" i="1" dirty="0">
               <a:solidFill>
@@ -3222,8 +3246,8 @@
         </p:nvSpPr>
         <p:spPr>
           <a:xfrm>
-            <a:off x="2968245" y="5005402"/>
-            <a:ext cx="2383409" cy="307777"/>
+            <a:off x="2851787" y="5005402"/>
+            <a:ext cx="2347374" cy="307777"/>
           </a:xfrm>
           <a:prstGeom prst="rect">
             <a:avLst/>
@@ -3243,7 +3267,31 @@
                   <a:srgbClr val="008000"/>
                 </a:solidFill>
               </a:rPr>
-              <a:t>Passive FTP Data Connections</a:t>
+              <a:t>Passive FTP </a:t>
+            </a:r>
+            <a:r>
+              <a:rPr lang="de-DE" sz="1400" b="1" i="1" dirty="0" err="1">
+                <a:solidFill>
+                  <a:srgbClr val="008000"/>
+                </a:solidFill>
+              </a:rPr>
+              <a:t>data</a:t>
+            </a:r>
+            <a:r>
+              <a:rPr lang="de-DE" sz="1400" b="1" i="1" dirty="0">
+                <a:solidFill>
+                  <a:srgbClr val="008000"/>
+                </a:solidFill>
+              </a:rPr>
+              <a:t> </a:t>
+            </a:r>
+            <a:r>
+              <a:rPr lang="de-DE" sz="1400" b="1" i="1" dirty="0" err="1">
+                <a:solidFill>
+                  <a:srgbClr val="008000"/>
+                </a:solidFill>
+              </a:rPr>
+              <a:t>connections</a:t>
             </a:r>
             <a:endParaRPr lang="en-GB" sz="1400" b="1" i="1" dirty="0">
               <a:solidFill>
@@ -3267,7 +3315,7 @@
         </p:nvSpPr>
         <p:spPr>
           <a:xfrm>
-            <a:off x="2038361" y="1528860"/>
+            <a:off x="1903886" y="1528860"/>
             <a:ext cx="295324" cy="310219"/>
           </a:xfrm>
           <a:prstGeom prst="ellipse">
@@ -3320,7 +3368,7 @@
         </p:nvSpPr>
         <p:spPr>
           <a:xfrm>
-            <a:off x="3338357" y="457200"/>
+            <a:off x="3203882" y="457200"/>
             <a:ext cx="1733584" cy="2610503"/>
           </a:xfrm>
           <a:prstGeom prst="roundRect">
@@ -3372,7 +3420,7 @@
         </p:nvSpPr>
         <p:spPr>
           <a:xfrm>
-            <a:off x="435436" y="3394005"/>
+            <a:off x="300961" y="3394005"/>
             <a:ext cx="1638525" cy="584775"/>
           </a:xfrm>
           <a:prstGeom prst="rect">
@@ -3389,11 +3437,7 @@
             <a:pPr algn="ctr"/>
             <a:r>
               <a:rPr lang="de-DE" b="1" dirty="0"/>
-              <a:t>UFTP </a:t>
-            </a:r>
-            <a:r>
-              <a:rPr lang="de-DE" b="1" dirty="0" err="1"/>
-              <a:t>Cient</a:t>
+              <a:t>UFTP Client</a:t>
             </a:r>
             <a:br>
               <a:rPr lang="de-DE" sz="1600" dirty="0"/>
@@ -3436,7 +3480,7 @@
         </p:nvSpPr>
         <p:spPr>
           <a:xfrm>
-            <a:off x="271840" y="3220787"/>
+            <a:off x="137365" y="3220787"/>
             <a:ext cx="1964510" cy="1626785"/>
           </a:xfrm>
           <a:prstGeom prst="roundRect">
@@ -3496,7 +3540,7 @@
         </p:blipFill>
         <p:spPr>
           <a:xfrm>
-            <a:off x="900177" y="4041272"/>
+            <a:off x="765702" y="4041272"/>
             <a:ext cx="752986" cy="575235"/>
           </a:xfrm>
           <a:prstGeom prst="rect">
@@ -3518,7 +3562,7 @@
         </p:nvGrpSpPr>
         <p:grpSpPr>
           <a:xfrm>
-            <a:off x="3811311" y="1974721"/>
+            <a:off x="3676836" y="1974721"/>
             <a:ext cx="809380" cy="847425"/>
             <a:chOff x="3905433" y="1301287"/>
             <a:chExt cx="949060" cy="957430"/>
@@ -3605,8 +3649,8 @@
         </p:nvSpPr>
         <p:spPr>
           <a:xfrm>
-            <a:off x="6881404" y="457200"/>
-            <a:ext cx="2081832" cy="5943599"/>
+            <a:off x="6746928" y="457200"/>
+            <a:ext cx="2238057" cy="5943599"/>
           </a:xfrm>
           <a:prstGeom prst="roundRect">
             <a:avLst/>
@@ -3657,7 +3701,7 @@
         </p:nvSpPr>
         <p:spPr>
           <a:xfrm>
-            <a:off x="7135618" y="712592"/>
+            <a:off x="7001143" y="712592"/>
             <a:ext cx="1489447" cy="369332"/>
           </a:xfrm>
           <a:prstGeom prst="rect">
@@ -3694,7 +3738,7 @@
         </p:nvSpPr>
         <p:spPr>
           <a:xfrm>
-            <a:off x="6772427" y="1597815"/>
+            <a:off x="6637952" y="1597815"/>
             <a:ext cx="288000" cy="180000"/>
           </a:xfrm>
           <a:prstGeom prst="rect">
@@ -3748,7 +3792,7 @@
         </p:nvSpPr>
         <p:spPr>
           <a:xfrm>
-            <a:off x="6766164" y="3949110"/>
+            <a:off x="6631689" y="3949110"/>
             <a:ext cx="288000" cy="180000"/>
           </a:xfrm>
           <a:prstGeom prst="rect">
@@ -3802,7 +3846,7 @@
         </p:nvSpPr>
         <p:spPr>
           <a:xfrm>
-            <a:off x="6696640" y="5316338"/>
+            <a:off x="6562165" y="5316338"/>
             <a:ext cx="288000" cy="180000"/>
           </a:xfrm>
           <a:prstGeom prst="rect">
@@ -3856,7 +3900,7 @@
         </p:nvSpPr>
         <p:spPr>
           <a:xfrm>
-            <a:off x="6750804" y="5409814"/>
+            <a:off x="6616329" y="5409814"/>
             <a:ext cx="288000" cy="180000"/>
           </a:xfrm>
           <a:prstGeom prst="rect">
@@ -3910,7 +3954,7 @@
         </p:nvSpPr>
         <p:spPr>
           <a:xfrm>
-            <a:off x="6816108" y="5512827"/>
+            <a:off x="6681633" y="5512827"/>
             <a:ext cx="288000" cy="180000"/>
           </a:xfrm>
           <a:prstGeom prst="rect">
@@ -3964,7 +4008,7 @@
         </p:nvSpPr>
         <p:spPr>
           <a:xfrm>
-            <a:off x="7108845" y="5259189"/>
+            <a:off x="6974370" y="5259189"/>
             <a:ext cx="1373891" cy="307777"/>
           </a:xfrm>
           <a:prstGeom prst="rect">
@@ -4010,7 +4054,7 @@
         </p:nvSpPr>
         <p:spPr>
           <a:xfrm>
-            <a:off x="7094722" y="5479194"/>
+            <a:off x="6960247" y="5479194"/>
             <a:ext cx="2040532" cy="307777"/>
           </a:xfrm>
           <a:prstGeom prst="rect">
@@ -4073,6 +4117,22 @@
                 </a:solidFill>
               </a:rPr>
               <a:t>fixed</a:t>
+            </a:r>
+            <a:r>
+              <a:rPr lang="de-DE" sz="1200" i="1" dirty="0">
+                <a:solidFill>
+                  <a:srgbClr val="FF0000"/>
+                </a:solidFill>
+              </a:rPr>
+              <a:t> </a:t>
+            </a:r>
+            <a:r>
+              <a:rPr lang="de-DE" sz="1200" i="1" dirty="0" err="1">
+                <a:solidFill>
+                  <a:srgbClr val="FF0000"/>
+                </a:solidFill>
+              </a:rPr>
+              <a:t>port</a:t>
             </a:r>
             <a:r>
               <a:rPr lang="de-DE" sz="1200" i="1" dirty="0">
@@ -4126,7 +4186,7 @@
         </p:blipFill>
         <p:spPr>
           <a:xfrm>
-            <a:off x="7645109" y="2326527"/>
+            <a:off x="7510634" y="2326527"/>
             <a:ext cx="699532" cy="1020242"/>
           </a:xfrm>
           <a:prstGeom prst="rect">
@@ -4148,8 +4208,8 @@
         </p:nvSpPr>
         <p:spPr>
           <a:xfrm>
-            <a:off x="1756150" y="1821390"/>
-            <a:ext cx="894200" cy="430887"/>
+            <a:off x="1540990" y="1821390"/>
+            <a:ext cx="1051146" cy="430887"/>
           </a:xfrm>
           <a:prstGeom prst="rect">
             <a:avLst/>
@@ -4172,7 +4232,7 @@
             </a:r>
             <a:r>
               <a:rPr lang="de-DE" sz="1100" i="1" dirty="0"/>
-              <a:t> + </a:t>
+              <a:t> and </a:t>
             </a:r>
             <a:br>
               <a:rPr lang="de-DE" sz="1100" i="1" dirty="0"/>
@@ -4203,8 +4263,8 @@
         </p:nvSpPr>
         <p:spPr>
           <a:xfrm>
-            <a:off x="5142979" y="1215935"/>
-            <a:ext cx="1698735" cy="307777"/>
+            <a:off x="5008504" y="1215935"/>
+            <a:ext cx="1513941" cy="307777"/>
           </a:xfrm>
           <a:prstGeom prst="rect">
             <a:avLst/>
@@ -4217,21 +4277,13 @@
           </a:bodyPr>
           <a:lstStyle/>
           <a:p>
-            <a:r>
-              <a:rPr lang="de-DE" sz="1400" b="1" i="1" dirty="0" err="1">
-                <a:solidFill>
-                  <a:srgbClr val="0070C0"/>
-                </a:solidFill>
-              </a:rPr>
-              <a:t>Prepare</a:t>
-            </a:r>
             <a:r>
               <a:rPr lang="de-DE" sz="1400" b="1" i="1" dirty="0">
                 <a:solidFill>
                   <a:srgbClr val="0070C0"/>
                 </a:solidFill>
               </a:rPr>
-              <a:t> FTP </a:t>
+              <a:t>FTP </a:t>
             </a:r>
             <a:r>
               <a:rPr lang="de-DE" sz="1400" b="1" i="1" dirty="0" err="1">
@@ -4240,6 +4292,22 @@
                 </a:solidFill>
               </a:rPr>
               <a:t>session</a:t>
+            </a:r>
+            <a:r>
+              <a:rPr lang="de-DE" sz="1400" b="1" i="1" dirty="0">
+                <a:solidFill>
+                  <a:srgbClr val="0070C0"/>
+                </a:solidFill>
+              </a:rPr>
+              <a:t> </a:t>
+            </a:r>
+            <a:r>
+              <a:rPr lang="de-DE" sz="1400" b="1" i="1" dirty="0" err="1">
+                <a:solidFill>
+                  <a:srgbClr val="0070C0"/>
+                </a:solidFill>
+              </a:rPr>
+              <a:t>setup</a:t>
             </a:r>
             <a:r>
               <a:rPr lang="de-DE" sz="1400" b="1" i="1" dirty="0">
@@ -4271,8 +4339,8 @@
         </p:nvSpPr>
         <p:spPr>
           <a:xfrm>
-            <a:off x="5287652" y="1840558"/>
-            <a:ext cx="1319592" cy="430887"/>
+            <a:off x="5141956" y="1840558"/>
+            <a:ext cx="1342035" cy="430887"/>
           </a:xfrm>
           <a:prstGeom prst="rect">
             <a:avLst/>
@@ -4304,7 +4372,7 @@
             </a:r>
             <a:r>
               <a:rPr lang="de-DE" sz="1100" i="1" dirty="0"/>
-              <a:t> +</a:t>
+              <a:t> and</a:t>
             </a:r>
             <a:br>
               <a:rPr lang="de-DE" sz="1100" i="1" dirty="0"/>
@@ -4343,7 +4411,7 @@
         </p:nvSpPr>
         <p:spPr>
           <a:xfrm>
-            <a:off x="3509186" y="4165083"/>
+            <a:off x="3374711" y="4165083"/>
             <a:ext cx="1362874" cy="261610"/>
           </a:xfrm>
           <a:prstGeom prst="rect">
@@ -4395,7 +4463,7 @@
         </p:nvSpPr>
         <p:spPr>
           <a:xfrm>
-            <a:off x="4036525" y="3881095"/>
+            <a:off x="3902050" y="3881095"/>
             <a:ext cx="295324" cy="310219"/>
           </a:xfrm>
           <a:prstGeom prst="ellipse">
@@ -4452,7 +4520,7 @@
         </p:nvCxnSpPr>
         <p:spPr>
           <a:xfrm rot="16200000" flipH="1">
-            <a:off x="3676328" y="2425338"/>
+            <a:off x="3541853" y="2425338"/>
             <a:ext cx="652242" cy="5496709"/>
           </a:xfrm>
           <a:prstGeom prst="bentConnector2">
@@ -4499,7 +4567,7 @@
         </p:nvCxnSpPr>
         <p:spPr>
           <a:xfrm rot="16200000" flipH="1">
-            <a:off x="3657474" y="2444192"/>
+            <a:off x="3522999" y="2444192"/>
             <a:ext cx="755255" cy="5562013"/>
           </a:xfrm>
           <a:prstGeom prst="bentConnector2">
@@ -4546,7 +4614,7 @@
         </p:nvCxnSpPr>
         <p:spPr>
           <a:xfrm rot="16200000" flipH="1">
-            <a:off x="3695984" y="2405682"/>
+            <a:off x="3561509" y="2405682"/>
             <a:ext cx="558766" cy="5442545"/>
           </a:xfrm>
           <a:prstGeom prst="bentConnector2">
@@ -4590,7 +4658,7 @@
         </p:nvSpPr>
         <p:spPr>
           <a:xfrm>
-            <a:off x="4019789" y="5351921"/>
+            <a:off x="3885314" y="5351921"/>
             <a:ext cx="295324" cy="310219"/>
           </a:xfrm>
           <a:prstGeom prst="ellipse">
@@ -4646,7 +4714,7 @@
         </p:nvCxnSpPr>
         <p:spPr>
           <a:xfrm>
-            <a:off x="5071941" y="1673951"/>
+            <a:off x="4937466" y="1673951"/>
             <a:ext cx="1700486" cy="13864"/>
           </a:xfrm>
           <a:prstGeom prst="straightConnector1">
@@ -4686,7 +4754,7 @@
         </p:nvSpPr>
         <p:spPr>
           <a:xfrm>
-            <a:off x="5814422" y="1516139"/>
+            <a:off x="5679947" y="1516139"/>
             <a:ext cx="295324" cy="310219"/>
           </a:xfrm>
           <a:prstGeom prst="ellipse">
@@ -4739,10 +4807,10 @@
         </p:nvGrpSpPr>
         <p:grpSpPr>
           <a:xfrm>
-            <a:off x="7118266" y="3793587"/>
-            <a:ext cx="998937" cy="534180"/>
+            <a:off x="6983791" y="3793587"/>
+            <a:ext cx="1209554" cy="534180"/>
             <a:chOff x="7073441" y="3874272"/>
-            <a:chExt cx="998937" cy="534180"/>
+            <a:chExt cx="1209554" cy="534180"/>
           </a:xfrm>
         </p:grpSpPr>
         <p:sp>
@@ -4760,7 +4828,7 @@
           <p:spPr>
             <a:xfrm>
               <a:off x="7076574" y="3874272"/>
-              <a:ext cx="980397" cy="307777"/>
+              <a:ext cx="1206421" cy="307777"/>
             </a:xfrm>
             <a:prstGeom prst="rect">
               <a:avLst/>
@@ -4781,7 +4849,7 @@
               <a:pPr algn="l"/>
               <a:r>
                 <a:rPr lang="de-DE" sz="1400" b="1" dirty="0"/>
-                <a:t>Listen </a:t>
+                <a:t>Listening </a:t>
               </a:r>
               <a:r>
                 <a:rPr lang="de-DE" sz="1400" b="1" dirty="0" err="1"/>
@@ -4859,7 +4927,7 @@
         </p:nvGrpSpPr>
         <p:grpSpPr>
           <a:xfrm>
-            <a:off x="7078811" y="1429184"/>
+            <a:off x="6944336" y="1429184"/>
             <a:ext cx="1306768" cy="526483"/>
             <a:chOff x="7078811" y="1527799"/>
             <a:chExt cx="1306768" cy="526483"/>
@@ -4973,7 +5041,7 @@
         </p:nvSpPr>
         <p:spPr>
           <a:xfrm>
-            <a:off x="3196253" y="1585508"/>
+            <a:off x="3061778" y="1585508"/>
             <a:ext cx="288000" cy="180000"/>
           </a:xfrm>
           <a:prstGeom prst="rect">
@@ -5027,10 +5095,10 @@
         </p:nvGrpSpPr>
         <p:grpSpPr>
           <a:xfrm>
-            <a:off x="3134068" y="1449339"/>
-            <a:ext cx="1233366" cy="499246"/>
+            <a:off x="2999593" y="1449339"/>
+            <a:ext cx="1273915" cy="499246"/>
             <a:chOff x="3134068" y="1494164"/>
-            <a:chExt cx="1233366" cy="499246"/>
+            <a:chExt cx="1273915" cy="499246"/>
           </a:xfrm>
         </p:grpSpPr>
         <p:sp>
@@ -5101,7 +5169,7 @@
           <p:spPr>
             <a:xfrm>
               <a:off x="3500362" y="1494164"/>
-              <a:ext cx="500778" cy="307777"/>
+              <a:ext cx="907621" cy="307777"/>
             </a:xfrm>
             <a:prstGeom prst="rect">
               <a:avLst/>
@@ -5116,7 +5184,11 @@
             <a:p>
               <a:r>
                 <a:rPr lang="de-DE" sz="1400" b="1" dirty="0"/>
-                <a:t>Port</a:t>
+                <a:t>Auth </a:t>
+              </a:r>
+              <a:r>
+                <a:rPr lang="de-DE" sz="1400" b="1" dirty="0" err="1"/>
+                <a:t>port</a:t>
               </a:r>
               <a:endParaRPr lang="en-GB" sz="1400" dirty="0"/>
             </a:p>

</xml_diff>

<commit_message>
add icons frp auth and uftpd servers
</commit_message>
<xml_diff>
--- a/source/_static/test-uftp-setup.pptx
+++ b/source/_static/test-uftp-setup.pptx
@@ -3562,8 +3562,8 @@
         </p:nvGrpSpPr>
         <p:grpSpPr>
           <a:xfrm>
-            <a:off x="3676836" y="1974721"/>
-            <a:ext cx="809380" cy="847425"/>
+            <a:off x="3578595" y="1974721"/>
+            <a:ext cx="907621" cy="847425"/>
             <a:chOff x="3905433" y="1301287"/>
             <a:chExt cx="949060" cy="957430"/>
           </a:xfrm>
@@ -4186,8 +4186,8 @@
         </p:blipFill>
         <p:spPr>
           <a:xfrm>
-            <a:off x="7510634" y="2326527"/>
-            <a:ext cx="699532" cy="1020242"/>
+            <a:off x="7404848" y="2326527"/>
+            <a:ext cx="806644" cy="972485"/>
           </a:xfrm>
           <a:prstGeom prst="rect">
             <a:avLst/>

</xml_diff>